<commit_message>
Fixing Design of PPTX
</commit_message>
<xml_diff>
--- a/output/techforward_live/techforward_live_enhanced_brand_book.pptx
+++ b/output/techforward_live/techforward_live_enhanced_brand_book.pptx
@@ -3095,74 +3095,31 @@
 <file path=ppt/slides/slide1.xml><?xml version="1.0" encoding="utf-8"?>
 <p:sld xmlns:a="http://schemas.openxmlformats.org/drawingml/2006/main" xmlns:p="http://schemas.openxmlformats.org/presentationml/2006/main" xmlns:r="http://schemas.openxmlformats.org/officeDocument/2006/relationships">
   <p:cSld>
+    <p:bg>
+      <p:bgPr>
+        <a:solidFill>
+          <a:srgbClr val="000000"/>
+        </a:solidFill>
+        <a:effectLst/>
+      </p:bgPr>
+    </p:bg>
     <p:spTree>
       <p:nvGrpSpPr>
         <p:cNvPr id="1" name=""/>
         <p:cNvGrpSpPr/>
         <p:nvPr/>
       </p:nvGrpSpPr>
-      <p:sp>
-        <p:nvSpPr>
-          <p:cNvPr id="2" name="Rectangle 1"/>
-          <p:cNvSpPr/>
-          <p:nvPr/>
-        </p:nvSpPr>
-        <p:spPr>
-          <a:xfrm>
-            <a:off x="0" y="0"/>
-            <a:ext cx="9144000" cy="6858000"/>
-          </a:xfrm>
-          <a:prstGeom prst="rect">
-            <a:avLst/>
-          </a:prstGeom>
-          <a:gradFill rotWithShape="1">
-            <a:gsLst>
-              <a:gs pos="0">
-                <a:srgbClr val="2E86AB"/>
-              </a:gs>
-              <a:gs pos="100000">
-                <a:srgbClr val="A23B72"/>
-              </a:gs>
-            </a:gsLst>
-            <a:lin scaled="0" ang="13500000"/>
-          </a:gradFill>
-          <a:ln>
-            <a:noFill/>
-          </a:ln>
-        </p:spPr>
-        <p:style>
-          <a:lnRef idx="1">
-            <a:schemeClr val="accent1"/>
-          </a:lnRef>
-          <a:fillRef idx="3">
-            <a:schemeClr val="accent1"/>
-          </a:fillRef>
-          <a:effectRef idx="2">
-            <a:schemeClr val="accent1"/>
-          </a:effectRef>
-          <a:fontRef idx="minor">
-            <a:schemeClr val="lt1"/>
-          </a:fontRef>
-        </p:style>
-        <p:txBody>
-          <a:bodyPr rtlCol="0" anchor="ctr"/>
-          <a:lstStyle/>
-          <a:p>
-            <a:pPr algn="ctr"/>
-          </a:p>
-        </p:txBody>
-      </p:sp>
       <p:grpSpPr/>
       <p:sp>
         <p:nvSpPr>
-          <p:cNvPr id="3" name="TextBox 2"/>
+          <p:cNvPr id="2" name="TextBox 1"/>
           <p:cNvSpPr txBox="1"/>
           <p:nvPr/>
         </p:nvSpPr>
         <p:spPr>
           <a:xfrm>
-            <a:off x="1828800" y="2686050"/>
-            <a:ext cx="5486400" cy="1485900"/>
+            <a:off x="1143000" y="4171950"/>
+            <a:ext cx="2743200" cy="742950"/>
           </a:xfrm>
           <a:prstGeom prst="rect">
             <a:avLst/>
@@ -3176,9 +3133,9 @@
           <a:lstStyle/>
           <a:p>
             <a:pPr algn="ctr">
-              <a:defRPr sz="4800" b="1">
-                <a:solidFill>
-                  <a:srgbClr val="2E86AB"/>
+              <a:defRPr sz="3600" b="1">
+                <a:solidFill>
+                  <a:srgbClr val="FFFFFF"/>
                 </a:solidFill>
                 <a:latin typeface="Inter"/>
               </a:defRPr>
@@ -3189,6 +3146,41 @@
           </a:p>
         </p:txBody>
       </p:sp>
+      <p:cxnSp>
+        <p:nvCxnSpPr>
+          <p:cNvPr id="3" name="Connector 2"/>
+          <p:cNvCxnSpPr/>
+          <p:nvPr/>
+        </p:nvCxnSpPr>
+        <p:spPr>
+          <a:xfrm>
+            <a:off x="6629400.0" y="5657850.0"/>
+            <a:ext cx="2057400.0" cy="0.0"/>
+          </a:xfrm>
+          <a:prstGeom prst="line">
+            <a:avLst/>
+          </a:prstGeom>
+          <a:ln>
+            <a:solidFill>
+              <a:srgbClr val="2E86AB"/>
+            </a:solidFill>
+          </a:ln>
+        </p:spPr>
+        <p:style>
+          <a:lnRef idx="2">
+            <a:schemeClr val="accent1"/>
+          </a:lnRef>
+          <a:fillRef idx="0">
+            <a:schemeClr val="accent1"/>
+          </a:fillRef>
+          <a:effectRef idx="1">
+            <a:schemeClr val="accent1"/>
+          </a:effectRef>
+          <a:fontRef idx="minor">
+            <a:schemeClr val="tx1"/>
+          </a:fontRef>
+        </p:style>
+      </p:cxnSp>
       <p:sp>
         <p:nvSpPr>
           <p:cNvPr id="4" name="TextBox 3"/>
@@ -3197,8 +3189,8 @@
         </p:nvSpPr>
         <p:spPr>
           <a:xfrm>
-            <a:off x="2514600" y="4171950"/>
-            <a:ext cx="4114800" cy="742950"/>
+            <a:off x="6629400" y="5657850"/>
+            <a:ext cx="2057400" cy="1485900"/>
           </a:xfrm>
           <a:prstGeom prst="rect">
             <a:avLst/>
@@ -3206,136 +3198,21 @@
           <a:noFill/>
         </p:spPr>
         <p:txBody>
-          <a:bodyPr wrap="none">
+          <a:bodyPr wrap="none" anchor="ctr">
             <a:spAutoFit/>
           </a:bodyPr>
           <a:lstStyle/>
           <a:p>
             <a:pPr algn="ctr">
-              <a:defRPr sz="2400" b="0">
-                <a:solidFill>
-                  <a:srgbClr val="2E86AB"/>
-                </a:solidFill>
-                <a:latin typeface="Source Sans Pro"/>
-              </a:defRPr>
-            </a:pPr>
-            <a:r>
-              <a:t>Brand Book</a:t>
-            </a:r>
-          </a:p>
-        </p:txBody>
-      </p:sp>
-      <p:sp>
-        <p:nvSpPr>
-          <p:cNvPr id="5" name="Oval 4"/>
-          <p:cNvSpPr/>
-          <p:nvPr/>
-        </p:nvSpPr>
-        <p:spPr>
-          <a:xfrm>
-            <a:off x="6629400" y="1200150"/>
-            <a:ext cx="1371600" cy="1485900"/>
-          </a:xfrm>
-          <a:prstGeom prst="ellipse">
-            <a:avLst/>
-          </a:prstGeom>
-          <a:solidFill>
-            <a:srgbClr val="F18F01"/>
-          </a:solidFill>
-          <a:ln>
-            <a:noFill/>
-          </a:ln>
-        </p:spPr>
-        <p:style>
-          <a:lnRef idx="1">
-            <a:schemeClr val="accent1"/>
-          </a:lnRef>
-          <a:fillRef idx="3">
-            <a:schemeClr val="accent1"/>
-          </a:fillRef>
-          <a:effectRef idx="2">
-            <a:schemeClr val="accent1"/>
-          </a:effectRef>
-          <a:fontRef idx="minor">
-            <a:schemeClr val="lt1"/>
-          </a:fontRef>
-        </p:style>
-        <p:txBody>
-          <a:bodyPr rtlCol="0" anchor="ctr"/>
-          <a:lstStyle/>
-          <a:p>
-            <a:pPr algn="ctr"/>
-          </a:p>
-        </p:txBody>
-      </p:sp>
-      <p:sp>
-        <p:nvSpPr>
-          <p:cNvPr id="6" name="TextBox 5"/>
-          <p:cNvSpPr txBox="1"/>
-          <p:nvPr/>
-        </p:nvSpPr>
-        <p:spPr>
-          <a:xfrm>
-            <a:off x="457200" y="5657850"/>
-            <a:ext cx="4114800" cy="742950"/>
-          </a:xfrm>
-          <a:prstGeom prst="rect">
-            <a:avLst/>
-          </a:prstGeom>
-          <a:noFill/>
-        </p:spPr>
-        <p:txBody>
-          <a:bodyPr wrap="none">
-            <a:spAutoFit/>
-          </a:bodyPr>
-          <a:lstStyle/>
-          <a:p>
-            <a:pPr algn="l">
-              <a:defRPr sz="1000" b="0">
-                <a:solidFill>
-                  <a:srgbClr val="2E86AB"/>
-                </a:solidFill>
-                <a:latin typeface="Source Sans Pro"/>
-              </a:defRPr>
-            </a:pPr>
-            <a:r>
-              <a:t>TechForward Live</a:t>
-            </a:r>
-          </a:p>
-        </p:txBody>
-      </p:sp>
-      <p:sp>
-        <p:nvSpPr>
-          <p:cNvPr id="7" name="TextBox 6"/>
-          <p:cNvSpPr txBox="1"/>
-          <p:nvPr/>
-        </p:nvSpPr>
-        <p:spPr>
-          <a:xfrm>
-            <a:off x="4572000" y="5657850"/>
-            <a:ext cx="4114800" cy="742950"/>
-          </a:xfrm>
-          <a:prstGeom prst="rect">
-            <a:avLst/>
-          </a:prstGeom>
-          <a:noFill/>
-        </p:spPr>
-        <p:txBody>
-          <a:bodyPr wrap="none">
-            <a:spAutoFit/>
-          </a:bodyPr>
-          <a:lstStyle/>
-          <a:p>
-            <a:pPr algn="r">
-              <a:defRPr sz="1000" b="0">
-                <a:solidFill>
-                  <a:srgbClr val="2E86AB"/>
-                </a:solidFill>
-                <a:latin typeface="Source Sans Pro"/>
-              </a:defRPr>
-            </a:pPr>
-            <a:r>
-              <a:t>1</a:t>
+              <a:defRPr sz="1800" b="0">
+                <a:solidFill>
+                  <a:srgbClr val="FFFFFF"/>
+                </a:solidFill>
+                <a:latin typeface="Source Sans Pro"/>
+              </a:defRPr>
+            </a:pPr>
+            <a:r>
+              <a:t>Brand Identity System</a:t>
             </a:r>
           </a:p>
         </p:txBody>

</xml_diff>

<commit_message>
Fixes Table of Content
</commit_message>
<xml_diff>
--- a/output/techforward_live/techforward_live_enhanced_brand_book.pptx
+++ b/output/techforward_live/techforward_live_enhanced_brand_book.pptx
@@ -3135,7 +3135,7 @@
             <a:pPr algn="ctr">
               <a:defRPr sz="3600" b="1">
                 <a:solidFill>
-                  <a:srgbClr val="FFFFFF"/>
+                  <a:srgbClr val="2E86AB"/>
                 </a:solidFill>
                 <a:latin typeface="Inter"/>
               </a:defRPr>
@@ -3206,7 +3206,7 @@
             <a:pPr algn="ctr">
               <a:defRPr sz="1800" b="0">
                 <a:solidFill>
-                  <a:srgbClr val="FFFFFF"/>
+                  <a:srgbClr val="2E86AB"/>
                 </a:solidFill>
                 <a:latin typeface="Source Sans Pro"/>
               </a:defRPr>
@@ -4458,59 +4458,24 @@
 <file path=ppt/slides/slide2.xml><?xml version="1.0" encoding="utf-8"?>
 <p:sld xmlns:a="http://schemas.openxmlformats.org/drawingml/2006/main" xmlns:p="http://schemas.openxmlformats.org/presentationml/2006/main" xmlns:r="http://schemas.openxmlformats.org/officeDocument/2006/relationships">
   <p:cSld>
+    <p:bg>
+      <p:bgPr>
+        <a:solidFill>
+          <a:srgbClr val="000000"/>
+        </a:solidFill>
+        <a:effectLst/>
+      </p:bgPr>
+    </p:bg>
     <p:spTree>
       <p:nvGrpSpPr>
         <p:cNvPr id="1" name=""/>
         <p:cNvGrpSpPr/>
         <p:nvPr/>
       </p:nvGrpSpPr>
-      <p:sp>
-        <p:nvSpPr>
-          <p:cNvPr id="2" name="Rectangle 1"/>
-          <p:cNvSpPr/>
-          <p:nvPr/>
-        </p:nvSpPr>
-        <p:spPr>
-          <a:xfrm>
-            <a:off x="0" y="0"/>
-            <a:ext cx="9144000" cy="6858000"/>
-          </a:xfrm>
-          <a:prstGeom prst="rect">
-            <a:avLst/>
-          </a:prstGeom>
-          <a:solidFill>
-            <a:srgbClr val="1A1A1A"/>
-          </a:solidFill>
-          <a:ln>
-            <a:noFill/>
-          </a:ln>
-        </p:spPr>
-        <p:style>
-          <a:lnRef idx="1">
-            <a:schemeClr val="accent1"/>
-          </a:lnRef>
-          <a:fillRef idx="3">
-            <a:schemeClr val="accent1"/>
-          </a:fillRef>
-          <a:effectRef idx="2">
-            <a:schemeClr val="accent1"/>
-          </a:effectRef>
-          <a:fontRef idx="minor">
-            <a:schemeClr val="lt1"/>
-          </a:fontRef>
-        </p:style>
-        <p:txBody>
-          <a:bodyPr rtlCol="0" anchor="ctr"/>
-          <a:lstStyle/>
-          <a:p>
-            <a:pPr algn="ctr"/>
-          </a:p>
-        </p:txBody>
-      </p:sp>
       <p:grpSpPr/>
       <p:sp>
         <p:nvSpPr>
-          <p:cNvPr id="3" name="TextBox 2"/>
+          <p:cNvPr id="2" name="TextBox 1"/>
           <p:cNvSpPr txBox="1"/>
           <p:nvPr/>
         </p:nvSpPr>
@@ -4546,14 +4511,14 @@
       </p:sp>
       <p:sp>
         <p:nvSpPr>
-          <p:cNvPr id="4" name="TextBox 3"/>
+          <p:cNvPr id="3" name="TextBox 2"/>
           <p:cNvSpPr txBox="1"/>
           <p:nvPr/>
         </p:nvSpPr>
         <p:spPr>
           <a:xfrm>
             <a:off x="1143000" y="1943100"/>
-            <a:ext cx="3429000" cy="3714750"/>
+            <a:ext cx="2743200" cy="3714750"/>
           </a:xfrm>
           <a:prstGeom prst="rect">
             <a:avLst/>
@@ -4587,6 +4552,16 @@
                 <a:latin typeface="Source Sans Pro"/>
               </a:defRPr>
             </a:pPr>
+          </a:p>
+          <a:p>
+            <a:pPr>
+              <a:defRPr sz="1600" b="0">
+                <a:solidFill>
+                  <a:srgbClr val="2E86AB"/>
+                </a:solidFill>
+                <a:latin typeface="Source Sans Pro"/>
+              </a:defRPr>
+            </a:pPr>
             <a:r>
               <a:t>2. Market Analysis &amp; Insights</a:t>
             </a:r>
@@ -4600,6 +4575,16 @@
                 <a:latin typeface="Source Sans Pro"/>
               </a:defRPr>
             </a:pPr>
+          </a:p>
+          <a:p>
+            <a:pPr>
+              <a:defRPr sz="1600" b="0">
+                <a:solidFill>
+                  <a:srgbClr val="2E86AB"/>
+                </a:solidFill>
+                <a:latin typeface="Source Sans Pro"/>
+              </a:defRPr>
+            </a:pPr>
             <a:r>
               <a:t>3. Brand Positioning</a:t>
             </a:r>
@@ -4613,6 +4598,16 @@
                 <a:latin typeface="Source Sans Pro"/>
               </a:defRPr>
             </a:pPr>
+          </a:p>
+          <a:p>
+            <a:pPr>
+              <a:defRPr sz="1600" b="0">
+                <a:solidFill>
+                  <a:srgbClr val="2E86AB"/>
+                </a:solidFill>
+                <a:latin typeface="Source Sans Pro"/>
+              </a:defRPr>
+            </a:pPr>
             <a:r>
               <a:t>4. Logo Variations</a:t>
             </a:r>
@@ -4626,6 +4621,16 @@
                 <a:latin typeface="Source Sans Pro"/>
               </a:defRPr>
             </a:pPr>
+          </a:p>
+          <a:p>
+            <a:pPr>
+              <a:defRPr sz="1600" b="0">
+                <a:solidFill>
+                  <a:srgbClr val="2E86AB"/>
+                </a:solidFill>
+                <a:latin typeface="Source Sans Pro"/>
+              </a:defRPr>
+            </a:pPr>
             <a:r>
               <a:t>5. Color Palette</a:t>
             </a:r>
@@ -4639,6 +4644,16 @@
                 <a:latin typeface="Source Sans Pro"/>
               </a:defRPr>
             </a:pPr>
+          </a:p>
+          <a:p>
+            <a:pPr>
+              <a:defRPr sz="1600" b="0">
+                <a:solidFill>
+                  <a:srgbClr val="2E86AB"/>
+                </a:solidFill>
+                <a:latin typeface="Source Sans Pro"/>
+              </a:defRPr>
+            </a:pPr>
             <a:r>
               <a:t>6. Typography</a:t>
             </a:r>
@@ -4647,14 +4662,14 @@
       </p:sp>
       <p:sp>
         <p:nvSpPr>
-          <p:cNvPr id="5" name="TextBox 4"/>
+          <p:cNvPr id="4" name="TextBox 3"/>
           <p:cNvSpPr txBox="1"/>
           <p:nvPr/>
         </p:nvSpPr>
         <p:spPr>
           <a:xfrm>
-            <a:off x="5257800" y="1943100"/>
-            <a:ext cx="3429000" cy="3714750"/>
+            <a:off x="5943600" y="1943100"/>
+            <a:ext cx="2743200" cy="3714750"/>
           </a:xfrm>
           <a:prstGeom prst="rect">
             <a:avLst/>
@@ -4688,6 +4703,16 @@
                 <a:latin typeface="Source Sans Pro"/>
               </a:defRPr>
             </a:pPr>
+          </a:p>
+          <a:p>
+            <a:pPr>
+              <a:defRPr sz="1600" b="0">
+                <a:solidFill>
+                  <a:srgbClr val="2E86AB"/>
+                </a:solidFill>
+                <a:latin typeface="Source Sans Pro"/>
+              </a:defRPr>
+            </a:pPr>
             <a:r>
               <a:t>8. Brand Story &amp; Mission</a:t>
             </a:r>
@@ -4701,6 +4726,16 @@
                 <a:latin typeface="Source Sans Pro"/>
               </a:defRPr>
             </a:pPr>
+          </a:p>
+          <a:p>
+            <a:pPr>
+              <a:defRPr sz="1600" b="0">
+                <a:solidFill>
+                  <a:srgbClr val="2E86AB"/>
+                </a:solidFill>
+                <a:latin typeface="Source Sans Pro"/>
+              </a:defRPr>
+            </a:pPr>
             <a:r>
               <a:t>9. Brand Voice &amp; Tone</a:t>
             </a:r>
@@ -4714,6 +4749,16 @@
                 <a:latin typeface="Source Sans Pro"/>
               </a:defRPr>
             </a:pPr>
+          </a:p>
+          <a:p>
+            <a:pPr>
+              <a:defRPr sz="1600" b="0">
+                <a:solidFill>
+                  <a:srgbClr val="2E86AB"/>
+                </a:solidFill>
+                <a:latin typeface="Source Sans Pro"/>
+              </a:defRPr>
+            </a:pPr>
             <a:r>
               <a:t>10. Messaging &amp; Value Propositions</a:t>
             </a:r>
@@ -4727,6 +4772,16 @@
                 <a:latin typeface="Source Sans Pro"/>
               </a:defRPr>
             </a:pPr>
+          </a:p>
+          <a:p>
+            <a:pPr>
+              <a:defRPr sz="1600" b="0">
+                <a:solidFill>
+                  <a:srgbClr val="2E86AB"/>
+                </a:solidFill>
+                <a:latin typeface="Source Sans Pro"/>
+              </a:defRPr>
+            </a:pPr>
             <a:r>
               <a:t>11. Marketing Copy</a:t>
             </a:r>
@@ -4740,80 +4795,18 @@
                 <a:latin typeface="Source Sans Pro"/>
               </a:defRPr>
             </a:pPr>
+          </a:p>
+          <a:p>
+            <a:pPr>
+              <a:defRPr sz="1600" b="0">
+                <a:solidFill>
+                  <a:srgbClr val="2E86AB"/>
+                </a:solidFill>
+                <a:latin typeface="Source Sans Pro"/>
+              </a:defRPr>
+            </a:pPr>
             <a:r>
               <a:t>12. Brand Collateral Templates</a:t>
-            </a:r>
-          </a:p>
-        </p:txBody>
-      </p:sp>
-      <p:sp>
-        <p:nvSpPr>
-          <p:cNvPr id="6" name="TextBox 5"/>
-          <p:cNvSpPr txBox="1"/>
-          <p:nvPr/>
-        </p:nvSpPr>
-        <p:spPr>
-          <a:xfrm>
-            <a:off x="457200" y="5657850"/>
-            <a:ext cx="4114800" cy="742950"/>
-          </a:xfrm>
-          <a:prstGeom prst="rect">
-            <a:avLst/>
-          </a:prstGeom>
-          <a:noFill/>
-        </p:spPr>
-        <p:txBody>
-          <a:bodyPr wrap="none">
-            <a:spAutoFit/>
-          </a:bodyPr>
-          <a:lstStyle/>
-          <a:p>
-            <a:pPr algn="l">
-              <a:defRPr sz="1000" b="0">
-                <a:solidFill>
-                  <a:srgbClr val="2E86AB"/>
-                </a:solidFill>
-                <a:latin typeface="Source Sans Pro"/>
-              </a:defRPr>
-            </a:pPr>
-            <a:r>
-              <a:t>TechForward Live</a:t>
-            </a:r>
-          </a:p>
-        </p:txBody>
-      </p:sp>
-      <p:sp>
-        <p:nvSpPr>
-          <p:cNvPr id="7" name="TextBox 6"/>
-          <p:cNvSpPr txBox="1"/>
-          <p:nvPr/>
-        </p:nvSpPr>
-        <p:spPr>
-          <a:xfrm>
-            <a:off x="4572000" y="5657850"/>
-            <a:ext cx="4114800" cy="742950"/>
-          </a:xfrm>
-          <a:prstGeom prst="rect">
-            <a:avLst/>
-          </a:prstGeom>
-          <a:noFill/>
-        </p:spPr>
-        <p:txBody>
-          <a:bodyPr wrap="none">
-            <a:spAutoFit/>
-          </a:bodyPr>
-          <a:lstStyle/>
-          <a:p>
-            <a:pPr algn="r">
-              <a:defRPr sz="1000" b="0">
-                <a:solidFill>
-                  <a:srgbClr val="2E86AB"/>
-                </a:solidFill>
-                <a:latin typeface="Source Sans Pro"/>
-              </a:defRPr>
-            </a:pPr>
-            <a:r>
-              <a:t>2</a:t>
             </a:r>
           </a:p>
         </p:txBody>

</xml_diff>

<commit_message>
Added Introduction Section and Styled It
</commit_message>
<xml_diff>
--- a/output/techforward_live/techforward_live_enhanced_brand_book.pptx
+++ b/output/techforward_live/techforward_live_enhanced_brand_book.pptx
@@ -4522,8 +4522,146 @@
         </p:nvSpPr>
         <p:spPr>
           <a:xfrm>
-            <a:off x="1143000" y="457200"/>
-            <a:ext cx="6858000" cy="742950"/>
+            <a:off x="800100" y="1051560"/>
+            <a:ext cx="6858000" cy="2971800"/>
+          </a:xfrm>
+          <a:prstGeom prst="rect">
+            <a:avLst/>
+          </a:prstGeom>
+          <a:noFill/>
+        </p:spPr>
+        <p:txBody>
+          <a:bodyPr wrap="square" lIns="0" rIns="0" tIns="0" bIns="0">
+            <a:spAutoFit/>
+          </a:bodyPr>
+          <a:lstStyle/>
+          <a:p>
+            <a:pPr algn="l">
+              <a:spcAft>
+                <a:spcPts val="800"/>
+              </a:spcAft>
+              <a:defRPr sz="2000" b="0">
+                <a:solidFill>
+                  <a:srgbClr val="FFFFFF"/>
+                </a:solidFill>
+                <a:latin typeface="Source Sans Pro"/>
+              </a:defRPr>
+            </a:pPr>
+            <a:r>
+              <a:t>The following brand identity system for TechForward Live</a:t>
+            </a:r>
+          </a:p>
+          <a:p>
+            <a:pPr algn="l">
+              <a:spcAft>
+                <a:spcPts val="800"/>
+              </a:spcAft>
+              <a:defRPr sz="2000" b="0">
+                <a:solidFill>
+                  <a:srgbClr val="FFFFFF"/>
+                </a:solidFill>
+                <a:latin typeface="Source Sans Pro"/>
+              </a:defRPr>
+            </a:pPr>
+            <a:r>
+              <a:t>is thoughtfully crafted to present our brand in</a:t>
+            </a:r>
+          </a:p>
+          <a:p>
+            <a:pPr algn="l">
+              <a:spcAft>
+                <a:spcPts val="800"/>
+              </a:spcAft>
+              <a:defRPr sz="2000" b="0">
+                <a:solidFill>
+                  <a:srgbClr val="FFFFFF"/>
+                </a:solidFill>
+                <a:latin typeface="Source Sans Pro"/>
+              </a:defRPr>
+            </a:pPr>
+            <a:r>
+              <a:t>an international, engaging, consistent, recognisable</a:t>
+            </a:r>
+          </a:p>
+          <a:p>
+            <a:pPr algn="l">
+              <a:spcAft>
+                <a:spcPts val="800"/>
+              </a:spcAft>
+              <a:defRPr sz="2000" b="0">
+                <a:solidFill>
+                  <a:srgbClr val="FFFFFF"/>
+                </a:solidFill>
+                <a:latin typeface="Source Sans Pro"/>
+              </a:defRPr>
+            </a:pPr>
+            <a:r>
+              <a:t>and proprietary way. Unique in form, versatile in its</a:t>
+            </a:r>
+          </a:p>
+          <a:p>
+            <a:pPr algn="l">
+              <a:spcAft>
+                <a:spcPts val="800"/>
+              </a:spcAft>
+              <a:defRPr sz="2000" b="0">
+                <a:solidFill>
+                  <a:srgbClr val="FFFFFF"/>
+                </a:solidFill>
+                <a:latin typeface="Source Sans Pro"/>
+              </a:defRPr>
+            </a:pPr>
+            <a:r>
+              <a:t>application and unified by a fundamental principle.</a:t>
+            </a:r>
+          </a:p>
+        </p:txBody>
+      </p:sp>
+      <p:cxnSp>
+        <p:nvCxnSpPr>
+          <p:cNvPr id="3" name="Connector 2"/>
+          <p:cNvCxnSpPr/>
+          <p:nvPr/>
+        </p:nvCxnSpPr>
+        <p:spPr>
+          <a:xfrm>
+            <a:off x="457200" y="4914900.0"/>
+            <a:ext cx="8229600" cy="0.0"/>
+          </a:xfrm>
+          <a:prstGeom prst="line">
+            <a:avLst/>
+          </a:prstGeom>
+          <a:ln w="25400">
+            <a:solidFill>
+              <a:srgbClr val="2E86AB"/>
+            </a:solidFill>
+          </a:ln>
+        </p:spPr>
+        <p:style>
+          <a:lnRef idx="2">
+            <a:schemeClr val="accent1"/>
+          </a:lnRef>
+          <a:fillRef idx="0">
+            <a:schemeClr val="accent1"/>
+          </a:fillRef>
+          <a:effectRef idx="1">
+            <a:schemeClr val="accent1"/>
+          </a:effectRef>
+          <a:fontRef idx="minor">
+            <a:schemeClr val="tx1"/>
+          </a:fontRef>
+        </p:style>
+      </p:cxnSp>
+      <p:sp>
+        <p:nvSpPr>
+          <p:cNvPr id="4" name="TextBox 3"/>
+          <p:cNvSpPr txBox="1"/>
+          <p:nvPr/>
+        </p:nvSpPr>
+        <p:spPr>
+          <a:xfrm>
+            <a:off x="800100" y="5189220"/>
+            <a:ext cx="3657600" cy="731520"/>
           </a:xfrm>
           <a:prstGeom prst="rect">
             <a:avLst/>
@@ -4536,8 +4674,8 @@
           </a:bodyPr>
           <a:lstStyle/>
           <a:p>
-            <a:pPr algn="ctr">
-              <a:defRPr sz="3200" b="1">
+            <a:pPr algn="l">
+              <a:defRPr sz="2800" b="1">
                 <a:solidFill>
                   <a:srgbClr val="2E86AB"/>
                 </a:solidFill>
@@ -4545,89 +4683,7 @@
               </a:defRPr>
             </a:pPr>
             <a:r>
-              <a:t>Introduction</a:t>
-            </a:r>
-          </a:p>
-        </p:txBody>
-      </p:sp>
-      <p:sp>
-        <p:nvSpPr>
-          <p:cNvPr id="3" name="TextBox 2"/>
-          <p:cNvSpPr txBox="1"/>
-          <p:nvPr/>
-        </p:nvSpPr>
-        <p:spPr>
-          <a:xfrm>
-            <a:off x="1828800" y="1943100"/>
-            <a:ext cx="5486400" cy="2971800"/>
-          </a:xfrm>
-          <a:prstGeom prst="rect">
-            <a:avLst/>
-          </a:prstGeom>
-          <a:noFill/>
-        </p:spPr>
-        <p:txBody>
-          <a:bodyPr wrap="square">
-            <a:spAutoFit/>
-          </a:bodyPr>
-          <a:lstStyle/>
-          <a:p>
-            <a:pPr algn="ctr">
-              <a:defRPr sz="1800" b="0">
-                <a:solidFill>
-                  <a:srgbClr val="FFFFFF"/>
-                </a:solidFill>
-                <a:latin typeface="Source Sans Pro"/>
-              </a:defRPr>
-            </a:pPr>
-            <a:r>
-              <a:t>Welcome to the TechForward Live Brand Book.</a:t>
-            </a:r>
-          </a:p>
-          <a:p>
-            <a:pPr algn="ctr">
-              <a:defRPr sz="1800" b="0">
-                <a:solidFill>
-                  <a:srgbClr val="FFFFFF"/>
-                </a:solidFill>
-                <a:latin typeface="Source Sans Pro"/>
-              </a:defRPr>
-            </a:pPr>
-          </a:p>
-          <a:p>
-            <a:pPr algn="ctr">
-              <a:defRPr sz="1800" b="0">
-                <a:solidFill>
-                  <a:srgbClr val="FFFFFF"/>
-                </a:solidFill>
-                <a:latin typeface="Source Sans Pro"/>
-              </a:defRPr>
-            </a:pPr>
-            <a:r>
-              <a:t>This comprehensive guide outlines our brand identity, values, and visual standards to ensure consistent brand representation across all touchpoints.</a:t>
-            </a:r>
-          </a:p>
-          <a:p>
-            <a:pPr algn="ctr">
-              <a:defRPr sz="1800" b="0">
-                <a:solidFill>
-                  <a:srgbClr val="FFFFFF"/>
-                </a:solidFill>
-                <a:latin typeface="Source Sans Pro"/>
-              </a:defRPr>
-            </a:pPr>
-          </a:p>
-          <a:p>
-            <a:pPr algn="ctr">
-              <a:defRPr sz="1800" b="0">
-                <a:solidFill>
-                  <a:srgbClr val="FFFFFF"/>
-                </a:solidFill>
-                <a:latin typeface="Source Sans Pro"/>
-              </a:defRPr>
-            </a:pPr>
-            <a:r>
-              <a:t>Our mission is to serve Progressive businesses seeking digital transformation and innovation with excellence and innovation.</a:t>
+              <a:t>INTRODUCTION</a:t>
             </a:r>
           </a:p>
         </p:txBody>

</xml_diff>

<commit_message>
Added Style In Brand Purpose
</commit_message>
<xml_diff>
--- a/output/techforward_live/techforward_live_enhanced_brand_book.pptx
+++ b/output/techforward_live/techforward_live_enhanced_brand_book.pptx
@@ -13,6 +13,8 @@
     <p:sldId id="261" r:id="rId12"/>
     <p:sldId id="262" r:id="rId13"/>
     <p:sldId id="263" r:id="rId14"/>
+    <p:sldId id="264" r:id="rId15"/>
+    <p:sldId id="265" r:id="rId16"/>
   </p:sldIdLst>
   <p:sldSz cx="9144000" cy="6858000" type="screen4x3"/>
   <p:notesSz cx="6858000" cy="9144000"/>
@@ -3111,7 +3113,7 @@
         </p:nvSpPr>
         <p:spPr>
           <a:xfrm>
-            <a:off x="1828800" y="4171950"/>
+            <a:off x="1143000" y="3800475"/>
             <a:ext cx="2743200" cy="742950"/>
           </a:xfrm>
           <a:prstGeom prst="rect">
@@ -3120,12 +3122,12 @@
           <a:noFill/>
         </p:spPr>
         <p:txBody>
-          <a:bodyPr wrap="none">
+          <a:bodyPr wrap="none" lIns="0" rIns="0" tIns="0" bIns="0">
             <a:spAutoFit/>
           </a:bodyPr>
           <a:lstStyle/>
           <a:p>
-            <a:pPr algn="ctr">
+            <a:pPr algn="l">
               <a:defRPr sz="3600" b="1">
                 <a:solidFill>
                   <a:srgbClr val="FFFFFF"/>
@@ -3206,6 +3208,594 @@
             </a:pPr>
             <a:r>
               <a:t>Brand Identity System</a:t>
+            </a:r>
+          </a:p>
+        </p:txBody>
+      </p:sp>
+    </p:spTree>
+  </p:cSld>
+  <p:clrMapOvr>
+    <a:masterClrMapping/>
+  </p:clrMapOvr>
+</p:sld>
+</file>
+
+<file path=ppt/slides/slide10.xml><?xml version="1.0" encoding="utf-8"?>
+<p:sld xmlns:a="http://schemas.openxmlformats.org/drawingml/2006/main" xmlns:p="http://schemas.openxmlformats.org/presentationml/2006/main" xmlns:r="http://schemas.openxmlformats.org/officeDocument/2006/relationships">
+  <p:cSld>
+    <p:spTree>
+      <p:nvGrpSpPr>
+        <p:cNvPr id="1" name=""/>
+        <p:cNvGrpSpPr/>
+        <p:nvPr/>
+      </p:nvGrpSpPr>
+      <p:sp>
+        <p:nvSpPr>
+          <p:cNvPr id="2" name="Rectangle 1"/>
+          <p:cNvSpPr/>
+          <p:nvPr/>
+        </p:nvSpPr>
+        <p:spPr>
+          <a:xfrm>
+            <a:off x="0" y="0"/>
+            <a:ext cx="9144000" cy="6858000"/>
+          </a:xfrm>
+          <a:prstGeom prst="rect">
+            <a:avLst/>
+          </a:prstGeom>
+          <a:solidFill>
+            <a:srgbClr val="1A1A1A"/>
+          </a:solidFill>
+          <a:ln>
+            <a:noFill/>
+          </a:ln>
+        </p:spPr>
+        <p:style>
+          <a:lnRef idx="1">
+            <a:schemeClr val="accent1"/>
+          </a:lnRef>
+          <a:fillRef idx="3">
+            <a:schemeClr val="accent1"/>
+          </a:fillRef>
+          <a:effectRef idx="2">
+            <a:schemeClr val="accent1"/>
+          </a:effectRef>
+          <a:fontRef idx="minor">
+            <a:schemeClr val="lt1"/>
+          </a:fontRef>
+        </p:style>
+        <p:txBody>
+          <a:bodyPr rtlCol="0" anchor="ctr"/>
+          <a:lstStyle/>
+          <a:p>
+            <a:pPr algn="ctr"/>
+          </a:p>
+        </p:txBody>
+      </p:sp>
+      <p:grpSpPr/>
+      <p:sp>
+        <p:nvSpPr>
+          <p:cNvPr id="3" name="TextBox 2"/>
+          <p:cNvSpPr txBox="1"/>
+          <p:nvPr/>
+        </p:nvSpPr>
+        <p:spPr>
+          <a:xfrm>
+            <a:off x="1143000" y="457200"/>
+            <a:ext cx="6858000" cy="742950"/>
+          </a:xfrm>
+          <a:prstGeom prst="rect">
+            <a:avLst/>
+          </a:prstGeom>
+          <a:noFill/>
+        </p:spPr>
+        <p:txBody>
+          <a:bodyPr wrap="none">
+            <a:spAutoFit/>
+          </a:bodyPr>
+          <a:lstStyle/>
+          <a:p>
+            <a:pPr>
+              <a:defRPr sz="3200" b="1">
+                <a:solidFill>
+                  <a:srgbClr val="2E86AB"/>
+                </a:solidFill>
+                <a:latin typeface="Inter"/>
+              </a:defRPr>
+            </a:pPr>
+            <a:r>
+              <a:t>Visual &amp; Photography Guidelines</a:t>
+            </a:r>
+          </a:p>
+        </p:txBody>
+      </p:sp>
+      <p:sp>
+        <p:nvSpPr>
+          <p:cNvPr id="4" name="TextBox 3"/>
+          <p:cNvSpPr txBox="1"/>
+          <p:nvPr/>
+        </p:nvSpPr>
+        <p:spPr>
+          <a:xfrm>
+            <a:off x="1143000" y="1943100"/>
+            <a:ext cx="3429000" cy="2971800"/>
+          </a:xfrm>
+          <a:prstGeom prst="rect">
+            <a:avLst/>
+          </a:prstGeom>
+          <a:noFill/>
+        </p:spPr>
+        <p:txBody>
+          <a:bodyPr wrap="square">
+            <a:spAutoFit/>
+          </a:bodyPr>
+          <a:lstStyle/>
+          <a:p>
+            <a:pPr>
+              <a:defRPr sz="1800" b="0">
+                <a:solidFill>
+                  <a:srgbClr val="2E86AB"/>
+                </a:solidFill>
+                <a:latin typeface="Source Sans Pro"/>
+              </a:defRPr>
+            </a:pPr>
+            <a:r>
+              <a:t>Visual Style Guidelines:</a:t>
+            </a:r>
+          </a:p>
+          <a:p>
+            <a:pPr>
+              <a:defRPr sz="1400" b="0">
+                <a:solidFill>
+                  <a:srgbClr val="2E86AB"/>
+                </a:solidFill>
+                <a:latin typeface="Source Sans Pro"/>
+              </a:defRPr>
+            </a:pPr>
+            <a:r>
+              <a:t>• Modern</a:t>
+            </a:r>
+          </a:p>
+          <a:p>
+            <a:pPr>
+              <a:defRPr sz="1400" b="0">
+                <a:solidFill>
+                  <a:srgbClr val="2E86AB"/>
+                </a:solidFill>
+                <a:latin typeface="Source Sans Pro"/>
+              </a:defRPr>
+            </a:pPr>
+            <a:r>
+              <a:t>• clean</a:t>
+            </a:r>
+          </a:p>
+          <a:p>
+            <a:pPr>
+              <a:defRPr sz="1400" b="0">
+                <a:solidFill>
+                  <a:srgbClr val="2E86AB"/>
+                </a:solidFill>
+                <a:latin typeface="Source Sans Pro"/>
+              </a:defRPr>
+            </a:pPr>
+            <a:r>
+              <a:t>• professional</a:t>
+            </a:r>
+          </a:p>
+          <a:p>
+            <a:pPr>
+              <a:defRPr sz="1400" b="0">
+                <a:solidFill>
+                  <a:srgbClr val="2E86AB"/>
+                </a:solidFill>
+                <a:latin typeface="Source Sans Pro"/>
+              </a:defRPr>
+            </a:pPr>
+            <a:r>
+              <a:t>• minimalist</a:t>
+            </a:r>
+          </a:p>
+          <a:p>
+            <a:pPr>
+              <a:defRPr sz="1400" b="0">
+                <a:solidFill>
+                  <a:srgbClr val="2E86AB"/>
+                </a:solidFill>
+                <a:latin typeface="Source Sans Pro"/>
+              </a:defRPr>
+            </a:pPr>
+            <a:r>
+              <a:t>• bold typography</a:t>
+            </a:r>
+          </a:p>
+        </p:txBody>
+      </p:sp>
+      <p:sp>
+        <p:nvSpPr>
+          <p:cNvPr id="5" name="TextBox 4"/>
+          <p:cNvSpPr txBox="1"/>
+          <p:nvPr/>
+        </p:nvSpPr>
+        <p:spPr>
+          <a:xfrm>
+            <a:off x="5257800" y="1943100"/>
+            <a:ext cx="3429000" cy="2971800"/>
+          </a:xfrm>
+          <a:prstGeom prst="rect">
+            <a:avLst/>
+          </a:prstGeom>
+          <a:noFill/>
+        </p:spPr>
+        <p:txBody>
+          <a:bodyPr wrap="square">
+            <a:spAutoFit/>
+          </a:bodyPr>
+          <a:lstStyle/>
+          <a:p>
+            <a:pPr>
+              <a:defRPr sz="1800" b="0">
+                <a:solidFill>
+                  <a:srgbClr val="2E86AB"/>
+                </a:solidFill>
+                <a:latin typeface="Source Sans Pro"/>
+              </a:defRPr>
+            </a:pPr>
+            <a:r>
+              <a:t>Photography Guidelines:</a:t>
+            </a:r>
+          </a:p>
+          <a:p>
+            <a:pPr>
+              <a:defRPr sz="1400" b="0">
+                <a:solidFill>
+                  <a:srgbClr val="2E86AB"/>
+                </a:solidFill>
+                <a:latin typeface="Source Sans Pro"/>
+              </a:defRPr>
+            </a:pPr>
+            <a:r>
+              <a:t>• High contrast</a:t>
+            </a:r>
+          </a:p>
+          <a:p>
+            <a:pPr>
+              <a:defRPr sz="1400" b="0">
+                <a:solidFill>
+                  <a:srgbClr val="2E86AB"/>
+                </a:solidFill>
+                <a:latin typeface="Source Sans Pro"/>
+              </a:defRPr>
+            </a:pPr>
+            <a:r>
+              <a:t>• authentic moments</a:t>
+            </a:r>
+          </a:p>
+          <a:p>
+            <a:pPr>
+              <a:defRPr sz="1400" b="0">
+                <a:solidFill>
+                  <a:srgbClr val="2E86AB"/>
+                </a:solidFill>
+                <a:latin typeface="Source Sans Pro"/>
+              </a:defRPr>
+            </a:pPr>
+            <a:r>
+              <a:t>• natural lighting</a:t>
+            </a:r>
+          </a:p>
+        </p:txBody>
+      </p:sp>
+      <p:sp>
+        <p:nvSpPr>
+          <p:cNvPr id="6" name="Rectangle 5"/>
+          <p:cNvSpPr/>
+          <p:nvPr/>
+        </p:nvSpPr>
+        <p:spPr>
+          <a:xfrm>
+            <a:off x="5257800" y="4914900"/>
+            <a:ext cx="685800" cy="742950"/>
+          </a:xfrm>
+          <a:prstGeom prst="rect">
+            <a:avLst/>
+          </a:prstGeom>
+          <a:solidFill>
+            <a:srgbClr val="404040"/>
+          </a:solidFill>
+          <a:ln w="12700">
+            <a:solidFill>
+              <a:srgbClr val="808080"/>
+            </a:solidFill>
+          </a:ln>
+        </p:spPr>
+        <p:style>
+          <a:lnRef idx="1">
+            <a:schemeClr val="accent1"/>
+          </a:lnRef>
+          <a:fillRef idx="3">
+            <a:schemeClr val="accent1"/>
+          </a:fillRef>
+          <a:effectRef idx="2">
+            <a:schemeClr val="accent1"/>
+          </a:effectRef>
+          <a:fontRef idx="minor">
+            <a:schemeClr val="lt1"/>
+          </a:fontRef>
+        </p:style>
+        <p:txBody>
+          <a:bodyPr rtlCol="0" anchor="ctr"/>
+          <a:lstStyle/>
+          <a:p>
+            <a:pPr algn="ctr"/>
+          </a:p>
+        </p:txBody>
+      </p:sp>
+      <p:sp>
+        <p:nvSpPr>
+          <p:cNvPr id="7" name="TextBox 6"/>
+          <p:cNvSpPr txBox="1"/>
+          <p:nvPr/>
+        </p:nvSpPr>
+        <p:spPr>
+          <a:xfrm>
+            <a:off x="5257800" y="5162550"/>
+            <a:ext cx="685800" cy="247650"/>
+          </a:xfrm>
+          <a:prstGeom prst="rect">
+            <a:avLst/>
+          </a:prstGeom>
+          <a:noFill/>
+        </p:spPr>
+        <p:txBody>
+          <a:bodyPr wrap="none">
+            <a:spAutoFit/>
+          </a:bodyPr>
+          <a:lstStyle/>
+          <a:p>
+            <a:pPr algn="ctr">
+              <a:defRPr sz="800" b="0">
+                <a:solidFill>
+                  <a:srgbClr val="2E86AB"/>
+                </a:solidFill>
+                <a:latin typeface="Source Sans Pro"/>
+              </a:defRPr>
+            </a:pPr>
+            <a:r>
+              <a:t>Example</a:t>
+            </a:r>
+          </a:p>
+        </p:txBody>
+      </p:sp>
+      <p:sp>
+        <p:nvSpPr>
+          <p:cNvPr id="8" name="Rectangle 7"/>
+          <p:cNvSpPr/>
+          <p:nvPr/>
+        </p:nvSpPr>
+        <p:spPr>
+          <a:xfrm>
+            <a:off x="6629400" y="4914900"/>
+            <a:ext cx="685800" cy="742950"/>
+          </a:xfrm>
+          <a:prstGeom prst="rect">
+            <a:avLst/>
+          </a:prstGeom>
+          <a:solidFill>
+            <a:srgbClr val="404040"/>
+          </a:solidFill>
+          <a:ln w="12700">
+            <a:solidFill>
+              <a:srgbClr val="808080"/>
+            </a:solidFill>
+          </a:ln>
+        </p:spPr>
+        <p:style>
+          <a:lnRef idx="1">
+            <a:schemeClr val="accent1"/>
+          </a:lnRef>
+          <a:fillRef idx="3">
+            <a:schemeClr val="accent1"/>
+          </a:fillRef>
+          <a:effectRef idx="2">
+            <a:schemeClr val="accent1"/>
+          </a:effectRef>
+          <a:fontRef idx="minor">
+            <a:schemeClr val="lt1"/>
+          </a:fontRef>
+        </p:style>
+        <p:txBody>
+          <a:bodyPr rtlCol="0" anchor="ctr"/>
+          <a:lstStyle/>
+          <a:p>
+            <a:pPr algn="ctr"/>
+          </a:p>
+        </p:txBody>
+      </p:sp>
+      <p:sp>
+        <p:nvSpPr>
+          <p:cNvPr id="9" name="TextBox 8"/>
+          <p:cNvSpPr txBox="1"/>
+          <p:nvPr/>
+        </p:nvSpPr>
+        <p:spPr>
+          <a:xfrm>
+            <a:off x="6629400" y="5162550"/>
+            <a:ext cx="685800" cy="247650"/>
+          </a:xfrm>
+          <a:prstGeom prst="rect">
+            <a:avLst/>
+          </a:prstGeom>
+          <a:noFill/>
+        </p:spPr>
+        <p:txBody>
+          <a:bodyPr wrap="none">
+            <a:spAutoFit/>
+          </a:bodyPr>
+          <a:lstStyle/>
+          <a:p>
+            <a:pPr algn="ctr">
+              <a:defRPr sz="800" b="0">
+                <a:solidFill>
+                  <a:srgbClr val="2E86AB"/>
+                </a:solidFill>
+                <a:latin typeface="Source Sans Pro"/>
+              </a:defRPr>
+            </a:pPr>
+            <a:r>
+              <a:t>Example</a:t>
+            </a:r>
+          </a:p>
+        </p:txBody>
+      </p:sp>
+      <p:sp>
+        <p:nvSpPr>
+          <p:cNvPr id="10" name="Rectangle 9"/>
+          <p:cNvSpPr/>
+          <p:nvPr/>
+        </p:nvSpPr>
+        <p:spPr>
+          <a:xfrm>
+            <a:off x="8001000" y="4914900"/>
+            <a:ext cx="685800" cy="742950"/>
+          </a:xfrm>
+          <a:prstGeom prst="rect">
+            <a:avLst/>
+          </a:prstGeom>
+          <a:solidFill>
+            <a:srgbClr val="404040"/>
+          </a:solidFill>
+          <a:ln w="12700">
+            <a:solidFill>
+              <a:srgbClr val="808080"/>
+            </a:solidFill>
+          </a:ln>
+        </p:spPr>
+        <p:style>
+          <a:lnRef idx="1">
+            <a:schemeClr val="accent1"/>
+          </a:lnRef>
+          <a:fillRef idx="3">
+            <a:schemeClr val="accent1"/>
+          </a:fillRef>
+          <a:effectRef idx="2">
+            <a:schemeClr val="accent1"/>
+          </a:effectRef>
+          <a:fontRef idx="minor">
+            <a:schemeClr val="lt1"/>
+          </a:fontRef>
+        </p:style>
+        <p:txBody>
+          <a:bodyPr rtlCol="0" anchor="ctr"/>
+          <a:lstStyle/>
+          <a:p>
+            <a:pPr algn="ctr"/>
+          </a:p>
+        </p:txBody>
+      </p:sp>
+      <p:sp>
+        <p:nvSpPr>
+          <p:cNvPr id="11" name="TextBox 10"/>
+          <p:cNvSpPr txBox="1"/>
+          <p:nvPr/>
+        </p:nvSpPr>
+        <p:spPr>
+          <a:xfrm>
+            <a:off x="8001000" y="5162550"/>
+            <a:ext cx="685800" cy="247650"/>
+          </a:xfrm>
+          <a:prstGeom prst="rect">
+            <a:avLst/>
+          </a:prstGeom>
+          <a:noFill/>
+        </p:spPr>
+        <p:txBody>
+          <a:bodyPr wrap="none">
+            <a:spAutoFit/>
+          </a:bodyPr>
+          <a:lstStyle/>
+          <a:p>
+            <a:pPr algn="ctr">
+              <a:defRPr sz="800" b="0">
+                <a:solidFill>
+                  <a:srgbClr val="2E86AB"/>
+                </a:solidFill>
+                <a:latin typeface="Source Sans Pro"/>
+              </a:defRPr>
+            </a:pPr>
+            <a:r>
+              <a:t>Example</a:t>
+            </a:r>
+          </a:p>
+        </p:txBody>
+      </p:sp>
+      <p:sp>
+        <p:nvSpPr>
+          <p:cNvPr id="12" name="TextBox 11"/>
+          <p:cNvSpPr txBox="1"/>
+          <p:nvPr/>
+        </p:nvSpPr>
+        <p:spPr>
+          <a:xfrm>
+            <a:off x="457200" y="5657850"/>
+            <a:ext cx="4114800" cy="742950"/>
+          </a:xfrm>
+          <a:prstGeom prst="rect">
+            <a:avLst/>
+          </a:prstGeom>
+          <a:noFill/>
+        </p:spPr>
+        <p:txBody>
+          <a:bodyPr wrap="none">
+            <a:spAutoFit/>
+          </a:bodyPr>
+          <a:lstStyle/>
+          <a:p>
+            <a:pPr algn="l">
+              <a:defRPr sz="1000" b="0">
+                <a:solidFill>
+                  <a:srgbClr val="2E86AB"/>
+                </a:solidFill>
+                <a:latin typeface="Source Sans Pro"/>
+              </a:defRPr>
+            </a:pPr>
+            <a:r>
+              <a:t>TechForward Live</a:t>
+            </a:r>
+          </a:p>
+        </p:txBody>
+      </p:sp>
+      <p:sp>
+        <p:nvSpPr>
+          <p:cNvPr id="13" name="TextBox 12"/>
+          <p:cNvSpPr txBox="1"/>
+          <p:nvPr/>
+        </p:nvSpPr>
+        <p:spPr>
+          <a:xfrm>
+            <a:off x="4572000" y="5657850"/>
+            <a:ext cx="4114800" cy="742950"/>
+          </a:xfrm>
+          <a:prstGeom prst="rect">
+            <a:avLst/>
+          </a:prstGeom>
+          <a:noFill/>
+        </p:spPr>
+        <p:txBody>
+          <a:bodyPr wrap="none">
+            <a:spAutoFit/>
+          </a:bodyPr>
+          <a:lstStyle/>
+          <a:p>
+            <a:pPr algn="r">
+              <a:defRPr sz="1000" b="0">
+                <a:solidFill>
+                  <a:srgbClr val="2E86AB"/>
+                </a:solidFill>
+                <a:latin typeface="Source Sans Pro"/>
+              </a:defRPr>
+            </a:pPr>
+            <a:r>
+              <a:t>10</a:t>
             </a:r>
           </a:p>
         </p:txBody>
@@ -3445,7 +4035,7 @@
               </a:defRPr>
             </a:pPr>
             <a:r>
-              <a:t>Brand Purpose</a:t>
+              <a:t>Brand Purpose (Vision)</a:t>
             </a:r>
           </a:p>
         </p:txBody>
@@ -3552,7 +4142,7 @@
               </a:defRPr>
             </a:pPr>
             <a:r>
-              <a:t>Brand Story</a:t>
+              <a:t>Brand Purpose (Mission)</a:t>
             </a:r>
           </a:p>
         </p:txBody>
@@ -3659,7 +4249,7 @@
               </a:defRPr>
             </a:pPr>
             <a:r>
-              <a:t>Logo Variations</a:t>
+              <a:t>Brand Purpose (Values)</a:t>
             </a:r>
           </a:p>
         </p:txBody>
@@ -3743,115 +4333,7 @@
         </p:nvSpPr>
         <p:spPr>
           <a:xfrm>
-            <a:off x="3657600" y="1920240"/>
-            <a:ext cx="1828800" cy="228600"/>
-          </a:xfrm>
-          <a:prstGeom prst="rect">
-            <a:avLst/>
-          </a:prstGeom>
-          <a:noFill/>
-        </p:spPr>
-        <p:txBody>
-          <a:bodyPr wrap="none" lIns="0" tIns="0" bIns="0">
-            <a:spAutoFit/>
-          </a:bodyPr>
-          <a:lstStyle/>
-          <a:p>
-            <a:pPr>
-              <a:defRPr sz="900" b="0">
-                <a:solidFill>
-                  <a:srgbClr val="CCCCCC"/>
-                </a:solidFill>
-                <a:latin typeface="Source Sans Pro"/>
-              </a:defRPr>
-            </a:pPr>
-            <a:r>
-              <a:t>Logo Mark</a:t>
-            </a:r>
-          </a:p>
-        </p:txBody>
-      </p:sp>
-      <p:sp>
-        <p:nvSpPr>
-          <p:cNvPr id="17" name="TextBox 16"/>
-          <p:cNvSpPr txBox="1"/>
-          <p:nvPr/>
-        </p:nvSpPr>
-        <p:spPr>
-          <a:xfrm>
-            <a:off x="3657600" y="2148840"/>
-            <a:ext cx="1828800" cy="228600"/>
-          </a:xfrm>
-          <a:prstGeom prst="rect">
-            <a:avLst/>
-          </a:prstGeom>
-          <a:noFill/>
-        </p:spPr>
-        <p:txBody>
-          <a:bodyPr wrap="none" lIns="0" tIns="0" bIns="0">
-            <a:spAutoFit/>
-          </a:bodyPr>
-          <a:lstStyle/>
-          <a:p>
-            <a:pPr>
-              <a:defRPr sz="900" b="0">
-                <a:solidFill>
-                  <a:srgbClr val="CCCCCC"/>
-                </a:solidFill>
-                <a:latin typeface="Source Sans Pro"/>
-              </a:defRPr>
-            </a:pPr>
-            <a:r>
-              <a:t>Clear Space</a:t>
-            </a:r>
-          </a:p>
-        </p:txBody>
-      </p:sp>
-      <p:sp>
-        <p:nvSpPr>
-          <p:cNvPr id="18" name="TextBox 17"/>
-          <p:cNvSpPr txBox="1"/>
-          <p:nvPr/>
-        </p:nvSpPr>
-        <p:spPr>
-          <a:xfrm>
-            <a:off x="3657600" y="2377440"/>
-            <a:ext cx="1828800" cy="228600"/>
-          </a:xfrm>
-          <a:prstGeom prst="rect">
-            <a:avLst/>
-          </a:prstGeom>
-          <a:noFill/>
-        </p:spPr>
-        <p:txBody>
-          <a:bodyPr wrap="none" lIns="0" tIns="0" bIns="0">
-            <a:spAutoFit/>
-          </a:bodyPr>
-          <a:lstStyle/>
-          <a:p>
-            <a:pPr>
-              <a:defRPr sz="900" b="0">
-                <a:solidFill>
-                  <a:srgbClr val="CCCCCC"/>
-                </a:solidFill>
-                <a:latin typeface="Source Sans Pro"/>
-              </a:defRPr>
-            </a:pPr>
-            <a:r>
-              <a:t>Usage Guidelines</a:t>
-            </a:r>
-          </a:p>
-        </p:txBody>
-      </p:sp>
-      <p:sp>
-        <p:nvSpPr>
-          <p:cNvPr id="19" name="TextBox 18"/>
-          <p:cNvSpPr txBox="1"/>
-          <p:nvPr/>
-        </p:nvSpPr>
-        <p:spPr>
-          <a:xfrm>
-            <a:off x="3474720" y="2743200"/>
+            <a:off x="3474720" y="2057400"/>
             <a:ext cx="1828800" cy="274320"/>
           </a:xfrm>
           <a:prstGeom prst="rect">
@@ -3874,20 +4356,20 @@
               </a:defRPr>
             </a:pPr>
             <a:r>
-              <a:t>Brand Colors</a:t>
+              <a:t>Brand Story</a:t>
             </a:r>
           </a:p>
         </p:txBody>
       </p:sp>
       <p:cxnSp>
         <p:nvCxnSpPr>
-          <p:cNvPr id="20" name="Connector 19"/>
+          <p:cNvPr id="17" name="Connector 16"/>
           <p:cNvCxnSpPr/>
           <p:nvPr/>
         </p:nvCxnSpPr>
         <p:spPr>
           <a:xfrm>
-            <a:off x="5349239" y="2852928"/>
+            <a:off x="5349239" y="2167128"/>
             <a:ext cx="365760" cy="0"/>
           </a:xfrm>
           <a:prstGeom prst="line">
@@ -3916,13 +4398,13 @@
       </p:cxnSp>
       <p:sp>
         <p:nvSpPr>
-          <p:cNvPr id="21" name="TextBox 20"/>
+          <p:cNvPr id="18" name="TextBox 17"/>
           <p:cNvSpPr txBox="1"/>
           <p:nvPr/>
         </p:nvSpPr>
         <p:spPr>
           <a:xfrm>
-            <a:off x="5760720" y="2743200"/>
+            <a:off x="5760720" y="2057400"/>
             <a:ext cx="274320" cy="274320"/>
           </a:xfrm>
           <a:prstGeom prst="rect">
@@ -3952,121 +4434,13 @@
       </p:sp>
       <p:sp>
         <p:nvSpPr>
-          <p:cNvPr id="22" name="TextBox 21"/>
+          <p:cNvPr id="19" name="TextBox 18"/>
           <p:cNvSpPr txBox="1"/>
           <p:nvPr/>
         </p:nvSpPr>
         <p:spPr>
           <a:xfrm>
-            <a:off x="3657600" y="3108960"/>
-            <a:ext cx="1828800" cy="228600"/>
-          </a:xfrm>
-          <a:prstGeom prst="rect">
-            <a:avLst/>
-          </a:prstGeom>
-          <a:noFill/>
-        </p:spPr>
-        <p:txBody>
-          <a:bodyPr wrap="none" lIns="0" tIns="0" bIns="0">
-            <a:spAutoFit/>
-          </a:bodyPr>
-          <a:lstStyle/>
-          <a:p>
-            <a:pPr>
-              <a:defRPr sz="900" b="0">
-                <a:solidFill>
-                  <a:srgbClr val="CCCCCC"/>
-                </a:solidFill>
-                <a:latin typeface="Source Sans Pro"/>
-              </a:defRPr>
-            </a:pPr>
-            <a:r>
-              <a:t>Primary Colors</a:t>
-            </a:r>
-          </a:p>
-        </p:txBody>
-      </p:sp>
-      <p:sp>
-        <p:nvSpPr>
-          <p:cNvPr id="23" name="TextBox 22"/>
-          <p:cNvSpPr txBox="1"/>
-          <p:nvPr/>
-        </p:nvSpPr>
-        <p:spPr>
-          <a:xfrm>
-            <a:off x="3657600" y="3337560"/>
-            <a:ext cx="1828800" cy="228600"/>
-          </a:xfrm>
-          <a:prstGeom prst="rect">
-            <a:avLst/>
-          </a:prstGeom>
-          <a:noFill/>
-        </p:spPr>
-        <p:txBody>
-          <a:bodyPr wrap="none" lIns="0" tIns="0" bIns="0">
-            <a:spAutoFit/>
-          </a:bodyPr>
-          <a:lstStyle/>
-          <a:p>
-            <a:pPr>
-              <a:defRPr sz="900" b="0">
-                <a:solidFill>
-                  <a:srgbClr val="CCCCCC"/>
-                </a:solidFill>
-                <a:latin typeface="Source Sans Pro"/>
-              </a:defRPr>
-            </a:pPr>
-            <a:r>
-              <a:t>Secondary Colors</a:t>
-            </a:r>
-          </a:p>
-        </p:txBody>
-      </p:sp>
-      <p:sp>
-        <p:nvSpPr>
-          <p:cNvPr id="24" name="TextBox 23"/>
-          <p:cNvSpPr txBox="1"/>
-          <p:nvPr/>
-        </p:nvSpPr>
-        <p:spPr>
-          <a:xfrm>
-            <a:off x="3657600" y="3566160"/>
-            <a:ext cx="1828800" cy="228600"/>
-          </a:xfrm>
-          <a:prstGeom prst="rect">
-            <a:avLst/>
-          </a:prstGeom>
-          <a:noFill/>
-        </p:spPr>
-        <p:txBody>
-          <a:bodyPr wrap="none" lIns="0" tIns="0" bIns="0">
-            <a:spAutoFit/>
-          </a:bodyPr>
-          <a:lstStyle/>
-          <a:p>
-            <a:pPr>
-              <a:defRPr sz="900" b="0">
-                <a:solidFill>
-                  <a:srgbClr val="CCCCCC"/>
-                </a:solidFill>
-                <a:latin typeface="Source Sans Pro"/>
-              </a:defRPr>
-            </a:pPr>
-            <a:r>
-              <a:t>Color Usage</a:t>
-            </a:r>
-          </a:p>
-        </p:txBody>
-      </p:sp>
-      <p:sp>
-        <p:nvSpPr>
-          <p:cNvPr id="25" name="TextBox 24"/>
-          <p:cNvSpPr txBox="1"/>
-          <p:nvPr/>
-        </p:nvSpPr>
-        <p:spPr>
-          <a:xfrm>
-            <a:off x="3474720" y="3931920"/>
+            <a:off x="3474720" y="2560320"/>
             <a:ext cx="1828800" cy="274320"/>
           </a:xfrm>
           <a:prstGeom prst="rect">
@@ -4089,20 +4463,20 @@
               </a:defRPr>
             </a:pPr>
             <a:r>
-              <a:t>Typography</a:t>
+              <a:t>Logo Variations</a:t>
             </a:r>
           </a:p>
         </p:txBody>
       </p:sp>
       <p:cxnSp>
         <p:nvCxnSpPr>
-          <p:cNvPr id="26" name="Connector 25"/>
+          <p:cNvPr id="20" name="Connector 19"/>
           <p:cNvCxnSpPr/>
           <p:nvPr/>
         </p:nvCxnSpPr>
         <p:spPr>
           <a:xfrm>
-            <a:off x="5349239" y="4041648"/>
+            <a:off x="5349239" y="2670048"/>
             <a:ext cx="365760" cy="0"/>
           </a:xfrm>
           <a:prstGeom prst="line">
@@ -4131,13 +4505,13 @@
       </p:cxnSp>
       <p:sp>
         <p:nvSpPr>
-          <p:cNvPr id="27" name="TextBox 26"/>
+          <p:cNvPr id="21" name="TextBox 20"/>
           <p:cNvSpPr txBox="1"/>
           <p:nvPr/>
         </p:nvSpPr>
         <p:spPr>
           <a:xfrm>
-            <a:off x="5760720" y="3931920"/>
+            <a:off x="5760720" y="2560320"/>
             <a:ext cx="274320" cy="274320"/>
           </a:xfrm>
           <a:prstGeom prst="rect">
@@ -4167,13 +4541,13 @@
       </p:sp>
       <p:sp>
         <p:nvSpPr>
-          <p:cNvPr id="28" name="TextBox 27"/>
+          <p:cNvPr id="22" name="TextBox 21"/>
           <p:cNvSpPr txBox="1"/>
           <p:nvPr/>
         </p:nvSpPr>
         <p:spPr>
           <a:xfrm>
-            <a:off x="3657600" y="4297680"/>
+            <a:off x="3657600" y="2926079"/>
             <a:ext cx="1828800" cy="228600"/>
           </a:xfrm>
           <a:prstGeom prst="rect">
@@ -4196,20 +4570,20 @@
               </a:defRPr>
             </a:pPr>
             <a:r>
-              <a:t>Brand Font</a:t>
-            </a:r>
-          </a:p>
-        </p:txBody>
-      </p:sp>
-      <p:sp>
-        <p:nvSpPr>
-          <p:cNvPr id="29" name="TextBox 28"/>
+              <a:t>Logo Mark</a:t>
+            </a:r>
+          </a:p>
+        </p:txBody>
+      </p:sp>
+      <p:sp>
+        <p:nvSpPr>
+          <p:cNvPr id="23" name="TextBox 22"/>
           <p:cNvSpPr txBox="1"/>
           <p:nvPr/>
         </p:nvSpPr>
         <p:spPr>
           <a:xfrm>
-            <a:off x="3657600" y="4526280"/>
+            <a:off x="3657600" y="3154679"/>
             <a:ext cx="1828800" cy="228600"/>
           </a:xfrm>
           <a:prstGeom prst="rect">
@@ -4232,20 +4606,20 @@
               </a:defRPr>
             </a:pPr>
             <a:r>
-              <a:t>Font Usage</a:t>
-            </a:r>
-          </a:p>
-        </p:txBody>
-      </p:sp>
-      <p:sp>
-        <p:nvSpPr>
-          <p:cNvPr id="30" name="TextBox 29"/>
+              <a:t>Clear Space</a:t>
+            </a:r>
+          </a:p>
+        </p:txBody>
+      </p:sp>
+      <p:sp>
+        <p:nvSpPr>
+          <p:cNvPr id="24" name="TextBox 23"/>
           <p:cNvSpPr txBox="1"/>
           <p:nvPr/>
         </p:nvSpPr>
         <p:spPr>
           <a:xfrm>
-            <a:off x="3657600" y="4754880"/>
+            <a:off x="3657600" y="3383279"/>
             <a:ext cx="1828800" cy="228600"/>
           </a:xfrm>
           <a:prstGeom prst="rect">
@@ -4268,14 +4642,14 @@
               </a:defRPr>
             </a:pPr>
             <a:r>
-              <a:t>Text Hierarchy</a:t>
-            </a:r>
-          </a:p>
-        </p:txBody>
-      </p:sp>
-      <p:sp>
-        <p:nvSpPr>
-          <p:cNvPr id="31" name="TextBox 30"/>
+              <a:t>Usage Guidelines</a:t>
+            </a:r>
+          </a:p>
+        </p:txBody>
+      </p:sp>
+      <p:sp>
+        <p:nvSpPr>
+          <p:cNvPr id="25" name="TextBox 24"/>
           <p:cNvSpPr txBox="1"/>
           <p:nvPr/>
         </p:nvSpPr>
@@ -4304,14 +4678,14 @@
               </a:defRPr>
             </a:pPr>
             <a:r>
-              <a:t>Visual Guidelines</a:t>
+              <a:t>Brand Colors</a:t>
             </a:r>
           </a:p>
         </p:txBody>
       </p:sp>
       <p:cxnSp>
         <p:nvCxnSpPr>
-          <p:cNvPr id="32" name="Connector 31"/>
+          <p:cNvPr id="26" name="Connector 25"/>
           <p:cNvCxnSpPr/>
           <p:nvPr/>
         </p:nvCxnSpPr>
@@ -4346,7 +4720,7 @@
       </p:cxnSp>
       <p:sp>
         <p:nvSpPr>
-          <p:cNvPr id="33" name="TextBox 32"/>
+          <p:cNvPr id="27" name="TextBox 26"/>
           <p:cNvSpPr txBox="1"/>
           <p:nvPr/>
         </p:nvSpPr>
@@ -4382,7 +4756,7 @@
       </p:sp>
       <p:sp>
         <p:nvSpPr>
-          <p:cNvPr id="34" name="TextBox 33"/>
+          <p:cNvPr id="28" name="TextBox 27"/>
           <p:cNvSpPr txBox="1"/>
           <p:nvPr/>
         </p:nvSpPr>
@@ -4411,14 +4785,14 @@
               </a:defRPr>
             </a:pPr>
             <a:r>
-              <a:t>Visual Style</a:t>
-            </a:r>
-          </a:p>
-        </p:txBody>
-      </p:sp>
-      <p:sp>
-        <p:nvSpPr>
-          <p:cNvPr id="35" name="TextBox 34"/>
+              <a:t>Primary Colors</a:t>
+            </a:r>
+          </a:p>
+        </p:txBody>
+      </p:sp>
+      <p:sp>
+        <p:nvSpPr>
+          <p:cNvPr id="29" name="TextBox 28"/>
           <p:cNvSpPr txBox="1"/>
           <p:nvPr/>
         </p:nvSpPr>
@@ -4447,7 +4821,222 @@
               </a:defRPr>
             </a:pPr>
             <a:r>
-              <a:t>Photography</a:t>
+              <a:t>Secondary Colors</a:t>
+            </a:r>
+          </a:p>
+        </p:txBody>
+      </p:sp>
+      <p:sp>
+        <p:nvSpPr>
+          <p:cNvPr id="30" name="TextBox 29"/>
+          <p:cNvSpPr txBox="1"/>
+          <p:nvPr/>
+        </p:nvSpPr>
+        <p:spPr>
+          <a:xfrm>
+            <a:off x="6675120" y="2377440"/>
+            <a:ext cx="1828800" cy="228600"/>
+          </a:xfrm>
+          <a:prstGeom prst="rect">
+            <a:avLst/>
+          </a:prstGeom>
+          <a:noFill/>
+        </p:spPr>
+        <p:txBody>
+          <a:bodyPr wrap="none" lIns="0" tIns="0" bIns="0">
+            <a:spAutoFit/>
+          </a:bodyPr>
+          <a:lstStyle/>
+          <a:p>
+            <a:pPr>
+              <a:defRPr sz="900" b="0">
+                <a:solidFill>
+                  <a:srgbClr val="CCCCCC"/>
+                </a:solidFill>
+                <a:latin typeface="Source Sans Pro"/>
+              </a:defRPr>
+            </a:pPr>
+            <a:r>
+              <a:t>Color Usage</a:t>
+            </a:r>
+          </a:p>
+        </p:txBody>
+      </p:sp>
+      <p:sp>
+        <p:nvSpPr>
+          <p:cNvPr id="31" name="TextBox 30"/>
+          <p:cNvSpPr txBox="1"/>
+          <p:nvPr/>
+        </p:nvSpPr>
+        <p:spPr>
+          <a:xfrm>
+            <a:off x="6492240" y="2743200"/>
+            <a:ext cx="1828800" cy="274320"/>
+          </a:xfrm>
+          <a:prstGeom prst="rect">
+            <a:avLst/>
+          </a:prstGeom>
+          <a:noFill/>
+        </p:spPr>
+        <p:txBody>
+          <a:bodyPr wrap="none" lIns="0" rIns="0" tIns="0" bIns="0">
+            <a:spAutoFit/>
+          </a:bodyPr>
+          <a:lstStyle/>
+          <a:p>
+            <a:pPr>
+              <a:defRPr sz="1200" b="1">
+                <a:solidFill>
+                  <a:srgbClr val="FFFFFF"/>
+                </a:solidFill>
+                <a:latin typeface="Source Sans Pro"/>
+              </a:defRPr>
+            </a:pPr>
+            <a:r>
+              <a:t>Typography</a:t>
+            </a:r>
+          </a:p>
+        </p:txBody>
+      </p:sp>
+      <p:cxnSp>
+        <p:nvCxnSpPr>
+          <p:cNvPr id="32" name="Connector 31"/>
+          <p:cNvCxnSpPr/>
+          <p:nvPr/>
+        </p:nvCxnSpPr>
+        <p:spPr>
+          <a:xfrm>
+            <a:off x="8366759" y="2852928"/>
+            <a:ext cx="365760" cy="0"/>
+          </a:xfrm>
+          <a:prstGeom prst="line">
+            <a:avLst/>
+          </a:prstGeom>
+          <a:ln w="19050">
+            <a:solidFill>
+              <a:srgbClr val="2E86AB"/>
+            </a:solidFill>
+          </a:ln>
+        </p:spPr>
+        <p:style>
+          <a:lnRef idx="2">
+            <a:schemeClr val="accent1"/>
+          </a:lnRef>
+          <a:fillRef idx="0">
+            <a:schemeClr val="accent1"/>
+          </a:fillRef>
+          <a:effectRef idx="1">
+            <a:schemeClr val="accent1"/>
+          </a:effectRef>
+          <a:fontRef idx="minor">
+            <a:schemeClr val="tx1"/>
+          </a:fontRef>
+        </p:style>
+      </p:cxnSp>
+      <p:sp>
+        <p:nvSpPr>
+          <p:cNvPr id="33" name="TextBox 32"/>
+          <p:cNvSpPr txBox="1"/>
+          <p:nvPr/>
+        </p:nvSpPr>
+        <p:spPr>
+          <a:xfrm>
+            <a:off x="8778240" y="2743200"/>
+            <a:ext cx="274320" cy="274320"/>
+          </a:xfrm>
+          <a:prstGeom prst="rect">
+            <a:avLst/>
+          </a:prstGeom>
+          <a:noFill/>
+        </p:spPr>
+        <p:txBody>
+          <a:bodyPr wrap="none" lIns="0" tIns="0" bIns="0">
+            <a:spAutoFit/>
+          </a:bodyPr>
+          <a:lstStyle/>
+          <a:p>
+            <a:pPr>
+              <a:defRPr sz="1200" b="1">
+                <a:solidFill>
+                  <a:srgbClr val="2E86AB"/>
+                </a:solidFill>
+                <a:latin typeface="Source Sans Pro"/>
+              </a:defRPr>
+            </a:pPr>
+            <a:r>
+              <a:t>08</a:t>
+            </a:r>
+          </a:p>
+        </p:txBody>
+      </p:sp>
+      <p:sp>
+        <p:nvSpPr>
+          <p:cNvPr id="34" name="TextBox 33"/>
+          <p:cNvSpPr txBox="1"/>
+          <p:nvPr/>
+        </p:nvSpPr>
+        <p:spPr>
+          <a:xfrm>
+            <a:off x="6675120" y="3108960"/>
+            <a:ext cx="1828800" cy="228600"/>
+          </a:xfrm>
+          <a:prstGeom prst="rect">
+            <a:avLst/>
+          </a:prstGeom>
+          <a:noFill/>
+        </p:spPr>
+        <p:txBody>
+          <a:bodyPr wrap="none" lIns="0" tIns="0" bIns="0">
+            <a:spAutoFit/>
+          </a:bodyPr>
+          <a:lstStyle/>
+          <a:p>
+            <a:pPr>
+              <a:defRPr sz="900" b="0">
+                <a:solidFill>
+                  <a:srgbClr val="CCCCCC"/>
+                </a:solidFill>
+                <a:latin typeface="Source Sans Pro"/>
+              </a:defRPr>
+            </a:pPr>
+            <a:r>
+              <a:t>Brand Font</a:t>
+            </a:r>
+          </a:p>
+        </p:txBody>
+      </p:sp>
+      <p:sp>
+        <p:nvSpPr>
+          <p:cNvPr id="35" name="TextBox 34"/>
+          <p:cNvSpPr txBox="1"/>
+          <p:nvPr/>
+        </p:nvSpPr>
+        <p:spPr>
+          <a:xfrm>
+            <a:off x="6675120" y="3337560"/>
+            <a:ext cx="1828800" cy="228600"/>
+          </a:xfrm>
+          <a:prstGeom prst="rect">
+            <a:avLst/>
+          </a:prstGeom>
+          <a:noFill/>
+        </p:spPr>
+        <p:txBody>
+          <a:bodyPr wrap="none" lIns="0" tIns="0" bIns="0">
+            <a:spAutoFit/>
+          </a:bodyPr>
+          <a:lstStyle/>
+          <a:p>
+            <a:pPr>
+              <a:defRPr sz="900" b="0">
+                <a:solidFill>
+                  <a:srgbClr val="CCCCCC"/>
+                </a:solidFill>
+                <a:latin typeface="Source Sans Pro"/>
+              </a:defRPr>
+            </a:pPr>
+            <a:r>
+              <a:t>Font Usage</a:t>
             </a:r>
           </a:p>
         </p:txBody>
@@ -4460,7 +5049,222 @@
         </p:nvSpPr>
         <p:spPr>
           <a:xfrm>
-            <a:off x="6675120" y="2377440"/>
+            <a:off x="6675120" y="3566160"/>
+            <a:ext cx="1828800" cy="228600"/>
+          </a:xfrm>
+          <a:prstGeom prst="rect">
+            <a:avLst/>
+          </a:prstGeom>
+          <a:noFill/>
+        </p:spPr>
+        <p:txBody>
+          <a:bodyPr wrap="none" lIns="0" tIns="0" bIns="0">
+            <a:spAutoFit/>
+          </a:bodyPr>
+          <a:lstStyle/>
+          <a:p>
+            <a:pPr>
+              <a:defRPr sz="900" b="0">
+                <a:solidFill>
+                  <a:srgbClr val="CCCCCC"/>
+                </a:solidFill>
+                <a:latin typeface="Source Sans Pro"/>
+              </a:defRPr>
+            </a:pPr>
+            <a:r>
+              <a:t>Text Hierarchy</a:t>
+            </a:r>
+          </a:p>
+        </p:txBody>
+      </p:sp>
+      <p:sp>
+        <p:nvSpPr>
+          <p:cNvPr id="37" name="TextBox 36"/>
+          <p:cNvSpPr txBox="1"/>
+          <p:nvPr/>
+        </p:nvSpPr>
+        <p:spPr>
+          <a:xfrm>
+            <a:off x="6492240" y="3931920"/>
+            <a:ext cx="1828800" cy="274320"/>
+          </a:xfrm>
+          <a:prstGeom prst="rect">
+            <a:avLst/>
+          </a:prstGeom>
+          <a:noFill/>
+        </p:spPr>
+        <p:txBody>
+          <a:bodyPr wrap="none" lIns="0" rIns="0" tIns="0" bIns="0">
+            <a:spAutoFit/>
+          </a:bodyPr>
+          <a:lstStyle/>
+          <a:p>
+            <a:pPr>
+              <a:defRPr sz="1200" b="1">
+                <a:solidFill>
+                  <a:srgbClr val="FFFFFF"/>
+                </a:solidFill>
+                <a:latin typeface="Source Sans Pro"/>
+              </a:defRPr>
+            </a:pPr>
+            <a:r>
+              <a:t>Visual Guidelines</a:t>
+            </a:r>
+          </a:p>
+        </p:txBody>
+      </p:sp>
+      <p:cxnSp>
+        <p:nvCxnSpPr>
+          <p:cNvPr id="38" name="Connector 37"/>
+          <p:cNvCxnSpPr/>
+          <p:nvPr/>
+        </p:nvCxnSpPr>
+        <p:spPr>
+          <a:xfrm>
+            <a:off x="8366759" y="4041648"/>
+            <a:ext cx="365760" cy="0"/>
+          </a:xfrm>
+          <a:prstGeom prst="line">
+            <a:avLst/>
+          </a:prstGeom>
+          <a:ln w="19050">
+            <a:solidFill>
+              <a:srgbClr val="2E86AB"/>
+            </a:solidFill>
+          </a:ln>
+        </p:spPr>
+        <p:style>
+          <a:lnRef idx="2">
+            <a:schemeClr val="accent1"/>
+          </a:lnRef>
+          <a:fillRef idx="0">
+            <a:schemeClr val="accent1"/>
+          </a:fillRef>
+          <a:effectRef idx="1">
+            <a:schemeClr val="accent1"/>
+          </a:effectRef>
+          <a:fontRef idx="minor">
+            <a:schemeClr val="tx1"/>
+          </a:fontRef>
+        </p:style>
+      </p:cxnSp>
+      <p:sp>
+        <p:nvSpPr>
+          <p:cNvPr id="39" name="TextBox 38"/>
+          <p:cNvSpPr txBox="1"/>
+          <p:nvPr/>
+        </p:nvSpPr>
+        <p:spPr>
+          <a:xfrm>
+            <a:off x="8778240" y="3931920"/>
+            <a:ext cx="274320" cy="274320"/>
+          </a:xfrm>
+          <a:prstGeom prst="rect">
+            <a:avLst/>
+          </a:prstGeom>
+          <a:noFill/>
+        </p:spPr>
+        <p:txBody>
+          <a:bodyPr wrap="none" lIns="0" tIns="0" bIns="0">
+            <a:spAutoFit/>
+          </a:bodyPr>
+          <a:lstStyle/>
+          <a:p>
+            <a:pPr>
+              <a:defRPr sz="1200" b="1">
+                <a:solidFill>
+                  <a:srgbClr val="2E86AB"/>
+                </a:solidFill>
+                <a:latin typeface="Source Sans Pro"/>
+              </a:defRPr>
+            </a:pPr>
+            <a:r>
+              <a:t>09</a:t>
+            </a:r>
+          </a:p>
+        </p:txBody>
+      </p:sp>
+      <p:sp>
+        <p:nvSpPr>
+          <p:cNvPr id="40" name="TextBox 39"/>
+          <p:cNvSpPr txBox="1"/>
+          <p:nvPr/>
+        </p:nvSpPr>
+        <p:spPr>
+          <a:xfrm>
+            <a:off x="6675120" y="4297680"/>
+            <a:ext cx="1828800" cy="228600"/>
+          </a:xfrm>
+          <a:prstGeom prst="rect">
+            <a:avLst/>
+          </a:prstGeom>
+          <a:noFill/>
+        </p:spPr>
+        <p:txBody>
+          <a:bodyPr wrap="none" lIns="0" tIns="0" bIns="0">
+            <a:spAutoFit/>
+          </a:bodyPr>
+          <a:lstStyle/>
+          <a:p>
+            <a:pPr>
+              <a:defRPr sz="900" b="0">
+                <a:solidFill>
+                  <a:srgbClr val="CCCCCC"/>
+                </a:solidFill>
+                <a:latin typeface="Source Sans Pro"/>
+              </a:defRPr>
+            </a:pPr>
+            <a:r>
+              <a:t>Visual Style</a:t>
+            </a:r>
+          </a:p>
+        </p:txBody>
+      </p:sp>
+      <p:sp>
+        <p:nvSpPr>
+          <p:cNvPr id="41" name="TextBox 40"/>
+          <p:cNvSpPr txBox="1"/>
+          <p:nvPr/>
+        </p:nvSpPr>
+        <p:spPr>
+          <a:xfrm>
+            <a:off x="6675120" y="4526280"/>
+            <a:ext cx="1828800" cy="228600"/>
+          </a:xfrm>
+          <a:prstGeom prst="rect">
+            <a:avLst/>
+          </a:prstGeom>
+          <a:noFill/>
+        </p:spPr>
+        <p:txBody>
+          <a:bodyPr wrap="none" lIns="0" tIns="0" bIns="0">
+            <a:spAutoFit/>
+          </a:bodyPr>
+          <a:lstStyle/>
+          <a:p>
+            <a:pPr>
+              <a:defRPr sz="900" b="0">
+                <a:solidFill>
+                  <a:srgbClr val="CCCCCC"/>
+                </a:solidFill>
+                <a:latin typeface="Source Sans Pro"/>
+              </a:defRPr>
+            </a:pPr>
+            <a:r>
+              <a:t>Photography</a:t>
+            </a:r>
+          </a:p>
+        </p:txBody>
+      </p:sp>
+      <p:sp>
+        <p:nvSpPr>
+          <p:cNvPr id="42" name="TextBox 41"/>
+          <p:cNvSpPr txBox="1"/>
+          <p:nvPr/>
+        </p:nvSpPr>
+        <p:spPr>
+          <a:xfrm>
+            <a:off x="6675120" y="4754880"/>
             <a:ext cx="1828800" cy="228600"/>
           </a:xfrm>
           <a:prstGeom prst="rect">
@@ -4748,175 +5552,8 @@
               </a:defRPr>
             </a:pPr>
             <a:r>
-              <a:t>Vision: To be the preferred partner for businesses seeking excellence and innovation in their field.</a:t>
-            </a:r>
-          </a:p>
-          <a:p>
-            <a:pPr algn="l">
-              <a:spcAft>
-                <a:spcPts val="800"/>
-              </a:spcAft>
-              <a:defRPr sz="2000" b="0">
-                <a:solidFill>
-                  <a:srgbClr val="FFFFFF"/>
-                </a:solidFill>
-                <a:latin typeface="Source Sans Pro"/>
-              </a:defRPr>
-            </a:pPr>
-          </a:p>
-          <a:p>
-            <a:pPr algn="l">
-              <a:spcAft>
-                <a:spcPts val="800"/>
-              </a:spcAft>
-              <a:defRPr sz="2000" b="0">
-                <a:solidFill>
-                  <a:srgbClr val="FFFFFF"/>
-                </a:solidFill>
-                <a:latin typeface="Source Sans Pro"/>
-              </a:defRPr>
-            </a:pPr>
-            <a:r>
-              <a:t>Mission: We deliver exceptional solutions that drive growth and create lasting value for our clients and communities.</a:t>
-            </a:r>
-          </a:p>
-          <a:p>
-            <a:pPr algn="l">
-              <a:spcAft>
-                <a:spcPts val="800"/>
-              </a:spcAft>
-              <a:defRPr sz="2000" b="0">
-                <a:solidFill>
-                  <a:srgbClr val="FFFFFF"/>
-                </a:solidFill>
-                <a:latin typeface="Source Sans Pro"/>
-              </a:defRPr>
-            </a:pPr>
-          </a:p>
-          <a:p>
-            <a:pPr algn="l">
-              <a:spcAft>
-                <a:spcPts val="800"/>
-              </a:spcAft>
-              <a:defRPr sz="2000" b="0">
-                <a:solidFill>
-                  <a:srgbClr val="FFFFFF"/>
-                </a:solidFill>
-                <a:latin typeface="Source Sans Pro"/>
-              </a:defRPr>
-            </a:pPr>
-            <a:r>
-              <a:t>Core Values:</a:t>
-            </a:r>
-          </a:p>
-          <a:p>
-            <a:pPr algn="l">
-              <a:spcAft>
-                <a:spcPts val="800"/>
-              </a:spcAft>
-              <a:defRPr sz="2000" b="0">
-                <a:solidFill>
-                  <a:srgbClr val="FFFFFF"/>
-                </a:solidFill>
-                <a:latin typeface="Source Sans Pro"/>
-              </a:defRPr>
-            </a:pPr>
-            <a:r>
-              <a:t>• Innovation: Driving progress through creative thinking and breakthrough solutions</a:t>
-            </a:r>
-          </a:p>
-          <a:p>
-            <a:pPr algn="l">
-              <a:spcAft>
-                <a:spcPts val="800"/>
-              </a:spcAft>
-              <a:defRPr sz="2000" b="0">
-                <a:solidFill>
-                  <a:srgbClr val="FFFFFF"/>
-                </a:solidFill>
-                <a:latin typeface="Source Sans Pro"/>
-              </a:defRPr>
-            </a:pPr>
-            <a:r>
-              <a:t>• Simplicity: Embodying simplicity in all aspects of our business operations</a:t>
-            </a:r>
-          </a:p>
-          <a:p>
-            <a:pPr algn="l">
-              <a:spcAft>
-                <a:spcPts val="800"/>
-              </a:spcAft>
-              <a:defRPr sz="2000" b="0">
-                <a:solidFill>
-                  <a:srgbClr val="FFFFFF"/>
-                </a:solidFill>
-                <a:latin typeface="Source Sans Pro"/>
-              </a:defRPr>
-            </a:pPr>
-            <a:r>
-              <a:t>• Human-Centered: Embodying human-centered in all aspects of our business operations</a:t>
-            </a:r>
-          </a:p>
-          <a:p>
-            <a:pPr algn="l">
-              <a:spcAft>
-                <a:spcPts val="800"/>
-              </a:spcAft>
-              <a:defRPr sz="2000" b="0">
-                <a:solidFill>
-                  <a:srgbClr val="FFFFFF"/>
-                </a:solidFill>
-                <a:latin typeface="Source Sans Pro"/>
-              </a:defRPr>
-            </a:pPr>
-            <a:r>
-              <a:t>• Excellence: Pursuing the highest standards in everything we deliver</a:t>
-            </a:r>
-          </a:p>
-          <a:p>
-            <a:pPr algn="l">
-              <a:spcAft>
-                <a:spcPts val="800"/>
-              </a:spcAft>
-              <a:defRPr sz="2000" b="0">
-                <a:solidFill>
-                  <a:srgbClr val="FFFFFF"/>
-                </a:solidFill>
-                <a:latin typeface="Source Sans Pro"/>
-              </a:defRPr>
-            </a:pPr>
-            <a:r>
-              <a:t>• Trust: Building lasting relationships through transparency and consistent delivery</a:t>
-            </a:r>
-          </a:p>
-          <a:p>
-            <a:pPr algn="l">
-              <a:spcAft>
-                <a:spcPts val="800"/>
-              </a:spcAft>
-              <a:defRPr sz="2000" b="0">
-                <a:solidFill>
-                  <a:srgbClr val="FFFFFF"/>
-                </a:solidFill>
-                <a:latin typeface="Source Sans Pro"/>
-              </a:defRPr>
-            </a:pPr>
-            <a:r>
-              <a:t>• Reliability: Ensuring dependable performance and unwavering support in all our services</a:t>
-            </a:r>
-          </a:p>
-          <a:p>
-            <a:pPr algn="l">
-              <a:spcAft>
-                <a:spcPts val="800"/>
-              </a:spcAft>
-              <a:defRPr sz="2000" b="0">
-                <a:solidFill>
-                  <a:srgbClr val="FFFFFF"/>
-                </a:solidFill>
-                <a:latin typeface="Source Sans Pro"/>
-              </a:defRPr>
-            </a:pPr>
+              <a:t>To be the preferred partner for businesses seeking excellence and innovation in their field.</a:t>
+            </a:r>
           </a:p>
         </p:txBody>
       </p:sp>
@@ -4964,7 +5601,7 @@
         <p:spPr>
           <a:xfrm>
             <a:off x="800100" y="5189220"/>
-            <a:ext cx="3657600" cy="731520"/>
+            <a:ext cx="5486400" cy="731520"/>
           </a:xfrm>
           <a:prstGeom prst="rect">
             <a:avLst/>
@@ -4986,7 +5623,7 @@
               </a:defRPr>
             </a:pPr>
             <a:r>
-              <a:t>BRAND PURPOSE</a:t>
+              <a:t>VISION</a:t>
             </a:r>
           </a:p>
         </p:txBody>
@@ -5002,66 +5639,105 @@
 <file path=ppt/slides/slide5.xml><?xml version="1.0" encoding="utf-8"?>
 <p:sld xmlns:a="http://schemas.openxmlformats.org/drawingml/2006/main" xmlns:p="http://schemas.openxmlformats.org/presentationml/2006/main" xmlns:r="http://schemas.openxmlformats.org/officeDocument/2006/relationships">
   <p:cSld>
+    <p:bg>
+      <p:bgPr>
+        <a:solidFill>
+          <a:srgbClr val="000000"/>
+        </a:solidFill>
+        <a:effectLst/>
+      </p:bgPr>
+    </p:bg>
     <p:spTree>
       <p:nvGrpSpPr>
         <p:cNvPr id="1" name=""/>
         <p:cNvGrpSpPr/>
         <p:nvPr/>
       </p:nvGrpSpPr>
-      <p:sp>
-        <p:nvSpPr>
-          <p:cNvPr id="2" name="Rectangle 1"/>
-          <p:cNvSpPr/>
-          <p:nvPr/>
-        </p:nvSpPr>
-        <p:spPr>
-          <a:xfrm>
-            <a:off x="0" y="0"/>
-            <a:ext cx="9144000" cy="6858000"/>
-          </a:xfrm>
-          <a:prstGeom prst="rect">
-            <a:avLst/>
-          </a:prstGeom>
-          <a:solidFill>
-            <a:srgbClr val="1A1A1A"/>
-          </a:solidFill>
-          <a:ln>
-            <a:noFill/>
+      <p:grpSpPr/>
+      <p:sp>
+        <p:nvSpPr>
+          <p:cNvPr id="2" name="TextBox 1"/>
+          <p:cNvSpPr txBox="1"/>
+          <p:nvPr/>
+        </p:nvSpPr>
+        <p:spPr>
+          <a:xfrm>
+            <a:off x="800100" y="1051560"/>
+            <a:ext cx="6858000" cy="2971800"/>
+          </a:xfrm>
+          <a:prstGeom prst="rect">
+            <a:avLst/>
+          </a:prstGeom>
+          <a:noFill/>
+        </p:spPr>
+        <p:txBody>
+          <a:bodyPr wrap="square" lIns="0" rIns="0" tIns="0" bIns="0">
+            <a:spAutoFit/>
+          </a:bodyPr>
+          <a:lstStyle/>
+          <a:p>
+            <a:pPr algn="l">
+              <a:spcAft>
+                <a:spcPts val="800"/>
+              </a:spcAft>
+              <a:defRPr sz="2000" b="0">
+                <a:solidFill>
+                  <a:srgbClr val="FFFFFF"/>
+                </a:solidFill>
+                <a:latin typeface="Source Sans Pro"/>
+              </a:defRPr>
+            </a:pPr>
+            <a:r>
+              <a:t>We deliver exceptional solutions that drive growth and create lasting value for our clients and communities.</a:t>
+            </a:r>
+          </a:p>
+        </p:txBody>
+      </p:sp>
+      <p:cxnSp>
+        <p:nvCxnSpPr>
+          <p:cNvPr id="3" name="Connector 2"/>
+          <p:cNvCxnSpPr/>
+          <p:nvPr/>
+        </p:nvCxnSpPr>
+        <p:spPr>
+          <a:xfrm>
+            <a:off x="457200" y="4914900.0"/>
+            <a:ext cx="8229600" cy="0.0"/>
+          </a:xfrm>
+          <a:prstGeom prst="line">
+            <a:avLst/>
+          </a:prstGeom>
+          <a:ln w="25400">
+            <a:solidFill>
+              <a:srgbClr val="2E86AB"/>
+            </a:solidFill>
           </a:ln>
         </p:spPr>
         <p:style>
-          <a:lnRef idx="1">
+          <a:lnRef idx="2">
             <a:schemeClr val="accent1"/>
           </a:lnRef>
-          <a:fillRef idx="3">
+          <a:fillRef idx="0">
             <a:schemeClr val="accent1"/>
           </a:fillRef>
-          <a:effectRef idx="2">
+          <a:effectRef idx="1">
             <a:schemeClr val="accent1"/>
           </a:effectRef>
           <a:fontRef idx="minor">
-            <a:schemeClr val="lt1"/>
+            <a:schemeClr val="tx1"/>
           </a:fontRef>
         </p:style>
-        <p:txBody>
-          <a:bodyPr rtlCol="0" anchor="ctr"/>
-          <a:lstStyle/>
-          <a:p>
-            <a:pPr algn="ctr"/>
-          </a:p>
-        </p:txBody>
-      </p:sp>
-      <p:grpSpPr/>
-      <p:sp>
-        <p:nvSpPr>
-          <p:cNvPr id="3" name="TextBox 2"/>
+      </p:cxnSp>
+      <p:sp>
+        <p:nvSpPr>
+          <p:cNvPr id="4" name="TextBox 3"/>
           <p:cNvSpPr txBox="1"/>
           <p:nvPr/>
         </p:nvSpPr>
         <p:spPr>
           <a:xfrm>
-            <a:off x="1143000" y="457200"/>
-            <a:ext cx="6858000" cy="742950"/>
+            <a:off x="800100" y="5189220"/>
+            <a:ext cx="5486400" cy="731520"/>
           </a:xfrm>
           <a:prstGeom prst="rect">
             <a:avLst/>
@@ -5074,8 +5750,8 @@
           </a:bodyPr>
           <a:lstStyle/>
           <a:p>
-            <a:pPr>
-              <a:defRPr sz="3200" b="1">
+            <a:pPr algn="l">
+              <a:defRPr sz="2800" b="1">
                 <a:solidFill>
                   <a:srgbClr val="2E86AB"/>
                 </a:solidFill>
@@ -5083,115 +5759,7 @@
               </a:defRPr>
             </a:pPr>
             <a:r>
-              <a:t>Brand Story</a:t>
-            </a:r>
-          </a:p>
-        </p:txBody>
-      </p:sp>
-      <p:sp>
-        <p:nvSpPr>
-          <p:cNvPr id="4" name="TextBox 3"/>
-          <p:cNvSpPr txBox="1"/>
-          <p:nvPr/>
-        </p:nvSpPr>
-        <p:spPr>
-          <a:xfrm>
-            <a:off x="1143000" y="1943100"/>
-            <a:ext cx="6858000" cy="2971800"/>
-          </a:xfrm>
-          <a:prstGeom prst="rect">
-            <a:avLst/>
-          </a:prstGeom>
-          <a:noFill/>
-        </p:spPr>
-        <p:txBody>
-          <a:bodyPr wrap="square">
-            <a:spAutoFit/>
-          </a:bodyPr>
-          <a:lstStyle/>
-          <a:p>
-            <a:pPr>
-              <a:defRPr sz="1600" b="0">
-                <a:solidFill>
-                  <a:srgbClr val="2E86AB"/>
-                </a:solidFill>
-                <a:latin typeface="Source Sans Pro"/>
-              </a:defRPr>
-            </a:pPr>
-            <a:r>
-              <a:t>We revolutionize technology through innovative design and human-centered solutions that empower businesses to achieve their digital transformation goals.</a:t>
-            </a:r>
-          </a:p>
-        </p:txBody>
-      </p:sp>
-      <p:sp>
-        <p:nvSpPr>
-          <p:cNvPr id="5" name="TextBox 4"/>
-          <p:cNvSpPr txBox="1"/>
-          <p:nvPr/>
-        </p:nvSpPr>
-        <p:spPr>
-          <a:xfrm>
-            <a:off x="457200" y="5657850"/>
-            <a:ext cx="4114800" cy="742950"/>
-          </a:xfrm>
-          <a:prstGeom prst="rect">
-            <a:avLst/>
-          </a:prstGeom>
-          <a:noFill/>
-        </p:spPr>
-        <p:txBody>
-          <a:bodyPr wrap="none">
-            <a:spAutoFit/>
-          </a:bodyPr>
-          <a:lstStyle/>
-          <a:p>
-            <a:pPr algn="l">
-              <a:defRPr sz="1000" b="0">
-                <a:solidFill>
-                  <a:srgbClr val="2E86AB"/>
-                </a:solidFill>
-                <a:latin typeface="Source Sans Pro"/>
-              </a:defRPr>
-            </a:pPr>
-            <a:r>
-              <a:t>TechForward Live</a:t>
-            </a:r>
-          </a:p>
-        </p:txBody>
-      </p:sp>
-      <p:sp>
-        <p:nvSpPr>
-          <p:cNvPr id="6" name="TextBox 5"/>
-          <p:cNvSpPr txBox="1"/>
-          <p:nvPr/>
-        </p:nvSpPr>
-        <p:spPr>
-          <a:xfrm>
-            <a:off x="4572000" y="5657850"/>
-            <a:ext cx="4114800" cy="742950"/>
-          </a:xfrm>
-          <a:prstGeom prst="rect">
-            <a:avLst/>
-          </a:prstGeom>
-          <a:noFill/>
-        </p:spPr>
-        <p:txBody>
-          <a:bodyPr wrap="none">
-            <a:spAutoFit/>
-          </a:bodyPr>
-          <a:lstStyle/>
-          <a:p>
-            <a:pPr algn="r">
-              <a:defRPr sz="1000" b="0">
-                <a:solidFill>
-                  <a:srgbClr val="2E86AB"/>
-                </a:solidFill>
-                <a:latin typeface="Source Sans Pro"/>
-              </a:defRPr>
-            </a:pPr>
-            <a:r>
-              <a:t>5</a:t>
+              <a:t>MISSION</a:t>
             </a:r>
           </a:p>
         </p:txBody>
@@ -5207,66 +5775,214 @@
 <file path=ppt/slides/slide6.xml><?xml version="1.0" encoding="utf-8"?>
 <p:sld xmlns:a="http://schemas.openxmlformats.org/drawingml/2006/main" xmlns:p="http://schemas.openxmlformats.org/presentationml/2006/main" xmlns:r="http://schemas.openxmlformats.org/officeDocument/2006/relationships">
   <p:cSld>
+    <p:bg>
+      <p:bgPr>
+        <a:solidFill>
+          <a:srgbClr val="000000"/>
+        </a:solidFill>
+        <a:effectLst/>
+      </p:bgPr>
+    </p:bg>
     <p:spTree>
       <p:nvGrpSpPr>
         <p:cNvPr id="1" name=""/>
         <p:cNvGrpSpPr/>
         <p:nvPr/>
       </p:nvGrpSpPr>
-      <p:sp>
-        <p:nvSpPr>
-          <p:cNvPr id="2" name="Rectangle 1"/>
-          <p:cNvSpPr/>
-          <p:nvPr/>
-        </p:nvSpPr>
-        <p:spPr>
-          <a:xfrm>
-            <a:off x="0" y="0"/>
-            <a:ext cx="9144000" cy="6858000"/>
-          </a:xfrm>
-          <a:prstGeom prst="rect">
-            <a:avLst/>
-          </a:prstGeom>
-          <a:solidFill>
-            <a:srgbClr val="1A1A1A"/>
-          </a:solidFill>
-          <a:ln>
-            <a:noFill/>
+      <p:grpSpPr/>
+      <p:sp>
+        <p:nvSpPr>
+          <p:cNvPr id="2" name="TextBox 1"/>
+          <p:cNvSpPr txBox="1"/>
+          <p:nvPr/>
+        </p:nvSpPr>
+        <p:spPr>
+          <a:xfrm>
+            <a:off x="800100" y="1051560"/>
+            <a:ext cx="6858000" cy="2971800"/>
+          </a:xfrm>
+          <a:prstGeom prst="rect">
+            <a:avLst/>
+          </a:prstGeom>
+          <a:noFill/>
+        </p:spPr>
+        <p:txBody>
+          <a:bodyPr wrap="square" lIns="0" rIns="0" tIns="0" bIns="0">
+            <a:spAutoFit/>
+          </a:bodyPr>
+          <a:lstStyle/>
+          <a:p>
+            <a:pPr algn="l">
+              <a:spcAft>
+                <a:spcPts val="800"/>
+              </a:spcAft>
+              <a:defRPr sz="2000" b="0">
+                <a:solidFill>
+                  <a:srgbClr val="FFFFFF"/>
+                </a:solidFill>
+                <a:latin typeface="Source Sans Pro"/>
+              </a:defRPr>
+            </a:pPr>
+            <a:r>
+              <a:t>Core Values:</a:t>
+            </a:r>
+          </a:p>
+          <a:p>
+            <a:pPr algn="l">
+              <a:spcAft>
+                <a:spcPts val="800"/>
+              </a:spcAft>
+              <a:defRPr sz="2000" b="0">
+                <a:solidFill>
+                  <a:srgbClr val="FFFFFF"/>
+                </a:solidFill>
+                <a:latin typeface="Source Sans Pro"/>
+              </a:defRPr>
+            </a:pPr>
+            <a:r>
+              <a:t>• Innovation: Driving progress through creative thinking and breakthrough solutions</a:t>
+            </a:r>
+          </a:p>
+          <a:p>
+            <a:pPr algn="l">
+              <a:spcAft>
+                <a:spcPts val="800"/>
+              </a:spcAft>
+              <a:defRPr sz="2000" b="0">
+                <a:solidFill>
+                  <a:srgbClr val="FFFFFF"/>
+                </a:solidFill>
+                <a:latin typeface="Source Sans Pro"/>
+              </a:defRPr>
+            </a:pPr>
+            <a:r>
+              <a:t>• Simplicity: Embodying simplicity in all aspects of our business operations</a:t>
+            </a:r>
+          </a:p>
+          <a:p>
+            <a:pPr algn="l">
+              <a:spcAft>
+                <a:spcPts val="800"/>
+              </a:spcAft>
+              <a:defRPr sz="2000" b="0">
+                <a:solidFill>
+                  <a:srgbClr val="FFFFFF"/>
+                </a:solidFill>
+                <a:latin typeface="Source Sans Pro"/>
+              </a:defRPr>
+            </a:pPr>
+            <a:r>
+              <a:t>• Human-Centered: Embodying human-centered in all aspects of our business operations</a:t>
+            </a:r>
+          </a:p>
+          <a:p>
+            <a:pPr algn="l">
+              <a:spcAft>
+                <a:spcPts val="800"/>
+              </a:spcAft>
+              <a:defRPr sz="2000" b="0">
+                <a:solidFill>
+                  <a:srgbClr val="FFFFFF"/>
+                </a:solidFill>
+                <a:latin typeface="Source Sans Pro"/>
+              </a:defRPr>
+            </a:pPr>
+            <a:r>
+              <a:t>• Excellence: Pursuing the highest standards in everything we deliver</a:t>
+            </a:r>
+          </a:p>
+          <a:p>
+            <a:pPr algn="l">
+              <a:spcAft>
+                <a:spcPts val="800"/>
+              </a:spcAft>
+              <a:defRPr sz="2000" b="0">
+                <a:solidFill>
+                  <a:srgbClr val="FFFFFF"/>
+                </a:solidFill>
+                <a:latin typeface="Source Sans Pro"/>
+              </a:defRPr>
+            </a:pPr>
+            <a:r>
+              <a:t>• Trust: Building lasting relationships through transparency and consistent delivery</a:t>
+            </a:r>
+          </a:p>
+          <a:p>
+            <a:pPr algn="l">
+              <a:spcAft>
+                <a:spcPts val="800"/>
+              </a:spcAft>
+              <a:defRPr sz="2000" b="0">
+                <a:solidFill>
+                  <a:srgbClr val="FFFFFF"/>
+                </a:solidFill>
+                <a:latin typeface="Source Sans Pro"/>
+              </a:defRPr>
+            </a:pPr>
+            <a:r>
+              <a:t>• Reliability: Ensuring dependable performance and unwavering support in all our services</a:t>
+            </a:r>
+          </a:p>
+          <a:p>
+            <a:pPr algn="l">
+              <a:spcAft>
+                <a:spcPts val="800"/>
+              </a:spcAft>
+              <a:defRPr sz="2000" b="0">
+                <a:solidFill>
+                  <a:srgbClr val="FFFFFF"/>
+                </a:solidFill>
+                <a:latin typeface="Source Sans Pro"/>
+              </a:defRPr>
+            </a:pPr>
+          </a:p>
+        </p:txBody>
+      </p:sp>
+      <p:cxnSp>
+        <p:nvCxnSpPr>
+          <p:cNvPr id="3" name="Connector 2"/>
+          <p:cNvCxnSpPr/>
+          <p:nvPr/>
+        </p:nvCxnSpPr>
+        <p:spPr>
+          <a:xfrm>
+            <a:off x="457200" y="4914900.0"/>
+            <a:ext cx="8229600" cy="0.0"/>
+          </a:xfrm>
+          <a:prstGeom prst="line">
+            <a:avLst/>
+          </a:prstGeom>
+          <a:ln w="25400">
+            <a:solidFill>
+              <a:srgbClr val="2E86AB"/>
+            </a:solidFill>
           </a:ln>
         </p:spPr>
         <p:style>
-          <a:lnRef idx="1">
+          <a:lnRef idx="2">
             <a:schemeClr val="accent1"/>
           </a:lnRef>
-          <a:fillRef idx="3">
+          <a:fillRef idx="0">
             <a:schemeClr val="accent1"/>
           </a:fillRef>
-          <a:effectRef idx="2">
+          <a:effectRef idx="1">
             <a:schemeClr val="accent1"/>
           </a:effectRef>
           <a:fontRef idx="minor">
-            <a:schemeClr val="lt1"/>
+            <a:schemeClr val="tx1"/>
           </a:fontRef>
         </p:style>
-        <p:txBody>
-          <a:bodyPr rtlCol="0" anchor="ctr"/>
-          <a:lstStyle/>
-          <a:p>
-            <a:pPr algn="ctr"/>
-          </a:p>
-        </p:txBody>
-      </p:sp>
-      <p:grpSpPr/>
-      <p:sp>
-        <p:nvSpPr>
-          <p:cNvPr id="3" name="TextBox 2"/>
+      </p:cxnSp>
+      <p:sp>
+        <p:nvSpPr>
+          <p:cNvPr id="4" name="TextBox 3"/>
           <p:cNvSpPr txBox="1"/>
           <p:nvPr/>
         </p:nvSpPr>
         <p:spPr>
           <a:xfrm>
-            <a:off x="1143000" y="457200"/>
-            <a:ext cx="6858000" cy="742950"/>
+            <a:off x="800100" y="5189220"/>
+            <a:ext cx="5486400" cy="731520"/>
           </a:xfrm>
           <a:prstGeom prst="rect">
             <a:avLst/>
@@ -5279,8 +5995,8 @@
           </a:bodyPr>
           <a:lstStyle/>
           <a:p>
-            <a:pPr>
-              <a:defRPr sz="3200" b="1">
+            <a:pPr algn="l">
+              <a:defRPr sz="2800" b="1">
                 <a:solidFill>
                   <a:srgbClr val="2E86AB"/>
                 </a:solidFill>
@@ -5288,478 +6004,7 @@
               </a:defRPr>
             </a:pPr>
             <a:r>
-              <a:t>Color Palette</a:t>
-            </a:r>
-          </a:p>
-        </p:txBody>
-      </p:sp>
-      <p:sp>
-        <p:nvSpPr>
-          <p:cNvPr id="4" name="Rectangle 3"/>
-          <p:cNvSpPr/>
-          <p:nvPr/>
-        </p:nvSpPr>
-        <p:spPr>
-          <a:xfrm>
-            <a:off x="1143000" y="1943100"/>
-            <a:ext cx="2057400" cy="1485900"/>
-          </a:xfrm>
-          <a:prstGeom prst="rect">
-            <a:avLst/>
-          </a:prstGeom>
-          <a:solidFill>
-            <a:srgbClr val="2E86AB"/>
-          </a:solidFill>
-          <a:ln w="12700">
-            <a:solidFill>
-              <a:srgbClr val="FFFFFF"/>
-            </a:solidFill>
-          </a:ln>
-        </p:spPr>
-        <p:style>
-          <a:lnRef idx="1">
-            <a:schemeClr val="accent1"/>
-          </a:lnRef>
-          <a:fillRef idx="3">
-            <a:schemeClr val="accent1"/>
-          </a:fillRef>
-          <a:effectRef idx="2">
-            <a:schemeClr val="accent1"/>
-          </a:effectRef>
-          <a:fontRef idx="minor">
-            <a:schemeClr val="lt1"/>
-          </a:fontRef>
-        </p:style>
-        <p:txBody>
-          <a:bodyPr rtlCol="0" anchor="ctr"/>
-          <a:lstStyle/>
-          <a:p>
-            <a:pPr algn="ctr"/>
-          </a:p>
-        </p:txBody>
-      </p:sp>
-      <p:sp>
-        <p:nvSpPr>
-          <p:cNvPr id="5" name="TextBox 4"/>
-          <p:cNvSpPr txBox="1"/>
-          <p:nvPr/>
-        </p:nvSpPr>
-        <p:spPr>
-          <a:xfrm>
-            <a:off x="1143000" y="3429000"/>
-            <a:ext cx="2057400" cy="1485900"/>
-          </a:xfrm>
-          <a:prstGeom prst="rect">
-            <a:avLst/>
-          </a:prstGeom>
-          <a:noFill/>
-        </p:spPr>
-        <p:txBody>
-          <a:bodyPr wrap="square">
-            <a:spAutoFit/>
-          </a:bodyPr>
-          <a:lstStyle/>
-          <a:p>
-            <a:pPr>
-              <a:defRPr sz="1000" b="0">
-                <a:solidFill>
-                  <a:srgbClr val="2E86AB"/>
-                </a:solidFill>
-                <a:latin typeface="Source Sans Pro"/>
-              </a:defRPr>
-            </a:pPr>
-            <a:r>
-              <a:t>Primary</a:t>
-            </a:r>
-          </a:p>
-          <a:p>
-            <a:pPr>
-              <a:defRPr sz="1000" b="0">
-                <a:solidFill>
-                  <a:srgbClr val="2E86AB"/>
-                </a:solidFill>
-                <a:latin typeface="Source Sans Pro"/>
-              </a:defRPr>
-            </a:pPr>
-            <a:r>
-              <a:t>#2E86AB</a:t>
-            </a:r>
-          </a:p>
-          <a:p>
-            <a:pPr>
-              <a:defRPr sz="1000" b="0">
-                <a:solidFill>
-                  <a:srgbClr val="2E86AB"/>
-                </a:solidFill>
-                <a:latin typeface="Source Sans Pro"/>
-              </a:defRPr>
-            </a:pPr>
-            <a:r>
-              <a:t>RGB(46, 134, 171)</a:t>
-            </a:r>
-          </a:p>
-          <a:p>
-            <a:pPr>
-              <a:defRPr sz="1000" b="0">
-                <a:solidFill>
-                  <a:srgbClr val="2E86AB"/>
-                </a:solidFill>
-                <a:latin typeface="Source Sans Pro"/>
-              </a:defRPr>
-            </a:pPr>
-            <a:r>
-              <a:t>CMYK(73, 21, 0, 32)</a:t>
-            </a:r>
-          </a:p>
-          <a:p>
-            <a:pPr>
-              <a:defRPr sz="1000" b="0">
-                <a:solidFill>
-                  <a:srgbClr val="2E86AB"/>
-                </a:solidFill>
-                <a:latin typeface="Source Sans Pro"/>
-              </a:defRPr>
-            </a:pPr>
-            <a:r>
-              <a:t>Use Light Text</a:t>
-            </a:r>
-          </a:p>
-        </p:txBody>
-      </p:sp>
-      <p:sp>
-        <p:nvSpPr>
-          <p:cNvPr id="6" name="Rectangle 5"/>
-          <p:cNvSpPr/>
-          <p:nvPr/>
-        </p:nvSpPr>
-        <p:spPr>
-          <a:xfrm>
-            <a:off x="3886200" y="1943100"/>
-            <a:ext cx="2057400" cy="1485900"/>
-          </a:xfrm>
-          <a:prstGeom prst="rect">
-            <a:avLst/>
-          </a:prstGeom>
-          <a:solidFill>
-            <a:srgbClr val="A23B72"/>
-          </a:solidFill>
-          <a:ln w="12700">
-            <a:solidFill>
-              <a:srgbClr val="FFFFFF"/>
-            </a:solidFill>
-          </a:ln>
-        </p:spPr>
-        <p:style>
-          <a:lnRef idx="1">
-            <a:schemeClr val="accent1"/>
-          </a:lnRef>
-          <a:fillRef idx="3">
-            <a:schemeClr val="accent1"/>
-          </a:fillRef>
-          <a:effectRef idx="2">
-            <a:schemeClr val="accent1"/>
-          </a:effectRef>
-          <a:fontRef idx="minor">
-            <a:schemeClr val="lt1"/>
-          </a:fontRef>
-        </p:style>
-        <p:txBody>
-          <a:bodyPr rtlCol="0" anchor="ctr"/>
-          <a:lstStyle/>
-          <a:p>
-            <a:pPr algn="ctr"/>
-          </a:p>
-        </p:txBody>
-      </p:sp>
-      <p:sp>
-        <p:nvSpPr>
-          <p:cNvPr id="7" name="TextBox 6"/>
-          <p:cNvSpPr txBox="1"/>
-          <p:nvPr/>
-        </p:nvSpPr>
-        <p:spPr>
-          <a:xfrm>
-            <a:off x="3886200" y="3429000"/>
-            <a:ext cx="2057400" cy="1485900"/>
-          </a:xfrm>
-          <a:prstGeom prst="rect">
-            <a:avLst/>
-          </a:prstGeom>
-          <a:noFill/>
-        </p:spPr>
-        <p:txBody>
-          <a:bodyPr wrap="square">
-            <a:spAutoFit/>
-          </a:bodyPr>
-          <a:lstStyle/>
-          <a:p>
-            <a:pPr>
-              <a:defRPr sz="1000" b="0">
-                <a:solidFill>
-                  <a:srgbClr val="2E86AB"/>
-                </a:solidFill>
-                <a:latin typeface="Source Sans Pro"/>
-              </a:defRPr>
-            </a:pPr>
-            <a:r>
-              <a:t>Secondary</a:t>
-            </a:r>
-          </a:p>
-          <a:p>
-            <a:pPr>
-              <a:defRPr sz="1000" b="0">
-                <a:solidFill>
-                  <a:srgbClr val="2E86AB"/>
-                </a:solidFill>
-                <a:latin typeface="Source Sans Pro"/>
-              </a:defRPr>
-            </a:pPr>
-            <a:r>
-              <a:t>#A23B72</a:t>
-            </a:r>
-          </a:p>
-          <a:p>
-            <a:pPr>
-              <a:defRPr sz="1000" b="0">
-                <a:solidFill>
-                  <a:srgbClr val="2E86AB"/>
-                </a:solidFill>
-                <a:latin typeface="Source Sans Pro"/>
-              </a:defRPr>
-            </a:pPr>
-            <a:r>
-              <a:t>RGB(162, 59, 114)</a:t>
-            </a:r>
-          </a:p>
-          <a:p>
-            <a:pPr>
-              <a:defRPr sz="1000" b="0">
-                <a:solidFill>
-                  <a:srgbClr val="2E86AB"/>
-                </a:solidFill>
-                <a:latin typeface="Source Sans Pro"/>
-              </a:defRPr>
-            </a:pPr>
-            <a:r>
-              <a:t>CMYK(0, 63, 29, 36)</a:t>
-            </a:r>
-          </a:p>
-          <a:p>
-            <a:pPr>
-              <a:defRPr sz="1000" b="0">
-                <a:solidFill>
-                  <a:srgbClr val="2E86AB"/>
-                </a:solidFill>
-                <a:latin typeface="Source Sans Pro"/>
-              </a:defRPr>
-            </a:pPr>
-            <a:r>
-              <a:t>Use Light Text</a:t>
-            </a:r>
-          </a:p>
-        </p:txBody>
-      </p:sp>
-      <p:sp>
-        <p:nvSpPr>
-          <p:cNvPr id="8" name="Rectangle 7"/>
-          <p:cNvSpPr/>
-          <p:nvPr/>
-        </p:nvSpPr>
-        <p:spPr>
-          <a:xfrm>
-            <a:off x="6629400" y="1943100"/>
-            <a:ext cx="2057400" cy="1485900"/>
-          </a:xfrm>
-          <a:prstGeom prst="rect">
-            <a:avLst/>
-          </a:prstGeom>
-          <a:solidFill>
-            <a:srgbClr val="F18F01"/>
-          </a:solidFill>
-          <a:ln w="12700">
-            <a:solidFill>
-              <a:srgbClr val="FFFFFF"/>
-            </a:solidFill>
-          </a:ln>
-        </p:spPr>
-        <p:style>
-          <a:lnRef idx="1">
-            <a:schemeClr val="accent1"/>
-          </a:lnRef>
-          <a:fillRef idx="3">
-            <a:schemeClr val="accent1"/>
-          </a:fillRef>
-          <a:effectRef idx="2">
-            <a:schemeClr val="accent1"/>
-          </a:effectRef>
-          <a:fontRef idx="minor">
-            <a:schemeClr val="lt1"/>
-          </a:fontRef>
-        </p:style>
-        <p:txBody>
-          <a:bodyPr rtlCol="0" anchor="ctr"/>
-          <a:lstStyle/>
-          <a:p>
-            <a:pPr algn="ctr"/>
-          </a:p>
-        </p:txBody>
-      </p:sp>
-      <p:sp>
-        <p:nvSpPr>
-          <p:cNvPr id="9" name="TextBox 8"/>
-          <p:cNvSpPr txBox="1"/>
-          <p:nvPr/>
-        </p:nvSpPr>
-        <p:spPr>
-          <a:xfrm>
-            <a:off x="6629400" y="3429000"/>
-            <a:ext cx="2057400" cy="1485900"/>
-          </a:xfrm>
-          <a:prstGeom prst="rect">
-            <a:avLst/>
-          </a:prstGeom>
-          <a:noFill/>
-        </p:spPr>
-        <p:txBody>
-          <a:bodyPr wrap="square">
-            <a:spAutoFit/>
-          </a:bodyPr>
-          <a:lstStyle/>
-          <a:p>
-            <a:pPr>
-              <a:defRPr sz="1000" b="0">
-                <a:solidFill>
-                  <a:srgbClr val="2E86AB"/>
-                </a:solidFill>
-                <a:latin typeface="Source Sans Pro"/>
-              </a:defRPr>
-            </a:pPr>
-            <a:r>
-              <a:t>Accent</a:t>
-            </a:r>
-          </a:p>
-          <a:p>
-            <a:pPr>
-              <a:defRPr sz="1000" b="0">
-                <a:solidFill>
-                  <a:srgbClr val="2E86AB"/>
-                </a:solidFill>
-                <a:latin typeface="Source Sans Pro"/>
-              </a:defRPr>
-            </a:pPr>
-            <a:r>
-              <a:t>#F18F01</a:t>
-            </a:r>
-          </a:p>
-          <a:p>
-            <a:pPr>
-              <a:defRPr sz="1000" b="0">
-                <a:solidFill>
-                  <a:srgbClr val="2E86AB"/>
-                </a:solidFill>
-                <a:latin typeface="Source Sans Pro"/>
-              </a:defRPr>
-            </a:pPr>
-            <a:r>
-              <a:t>RGB(241, 143, 1)</a:t>
-            </a:r>
-          </a:p>
-          <a:p>
-            <a:pPr>
-              <a:defRPr sz="1000" b="0">
-                <a:solidFill>
-                  <a:srgbClr val="2E86AB"/>
-                </a:solidFill>
-                <a:latin typeface="Source Sans Pro"/>
-              </a:defRPr>
-            </a:pPr>
-            <a:r>
-              <a:t>CMYK(0, 40, 99, 5)</a:t>
-            </a:r>
-          </a:p>
-          <a:p>
-            <a:pPr>
-              <a:defRPr sz="1000" b="0">
-                <a:solidFill>
-                  <a:srgbClr val="2E86AB"/>
-                </a:solidFill>
-                <a:latin typeface="Source Sans Pro"/>
-              </a:defRPr>
-            </a:pPr>
-            <a:r>
-              <a:t>Use Dark Text</a:t>
-            </a:r>
-          </a:p>
-        </p:txBody>
-      </p:sp>
-      <p:sp>
-        <p:nvSpPr>
-          <p:cNvPr id="10" name="TextBox 9"/>
-          <p:cNvSpPr txBox="1"/>
-          <p:nvPr/>
-        </p:nvSpPr>
-        <p:spPr>
-          <a:xfrm>
-            <a:off x="457200" y="5657850"/>
-            <a:ext cx="4114800" cy="742950"/>
-          </a:xfrm>
-          <a:prstGeom prst="rect">
-            <a:avLst/>
-          </a:prstGeom>
-          <a:noFill/>
-        </p:spPr>
-        <p:txBody>
-          <a:bodyPr wrap="none">
-            <a:spAutoFit/>
-          </a:bodyPr>
-          <a:lstStyle/>
-          <a:p>
-            <a:pPr algn="l">
-              <a:defRPr sz="1000" b="0">
-                <a:solidFill>
-                  <a:srgbClr val="2E86AB"/>
-                </a:solidFill>
-                <a:latin typeface="Source Sans Pro"/>
-              </a:defRPr>
-            </a:pPr>
-            <a:r>
-              <a:t>TechForward Live</a:t>
-            </a:r>
-          </a:p>
-        </p:txBody>
-      </p:sp>
-      <p:sp>
-        <p:nvSpPr>
-          <p:cNvPr id="11" name="TextBox 10"/>
-          <p:cNvSpPr txBox="1"/>
-          <p:nvPr/>
-        </p:nvSpPr>
-        <p:spPr>
-          <a:xfrm>
-            <a:off x="4572000" y="5657850"/>
-            <a:ext cx="4114800" cy="742950"/>
-          </a:xfrm>
-          <a:prstGeom prst="rect">
-            <a:avLst/>
-          </a:prstGeom>
-          <a:noFill/>
-        </p:spPr>
-        <p:txBody>
-          <a:bodyPr wrap="none">
-            <a:spAutoFit/>
-          </a:bodyPr>
-          <a:lstStyle/>
-          <a:p>
-            <a:pPr algn="r">
-              <a:defRPr sz="1000" b="0">
-                <a:solidFill>
-                  <a:srgbClr val="2E86AB"/>
-                </a:solidFill>
-                <a:latin typeface="Source Sans Pro"/>
-              </a:defRPr>
-            </a:pPr>
-            <a:r>
-              <a:t>6</a:t>
+              <a:t>CORE VALUES</a:t>
             </a:r>
           </a:p>
         </p:txBody>
@@ -5856,7 +6101,7 @@
               </a:defRPr>
             </a:pPr>
             <a:r>
-              <a:t>Typography</a:t>
+              <a:t>Brand Story</a:t>
             </a:r>
           </a:p>
         </p:txBody>
@@ -5870,7 +6115,43 @@
         <p:spPr>
           <a:xfrm>
             <a:off x="1143000" y="1943100"/>
-            <a:ext cx="3429000" cy="742950"/>
+            <a:ext cx="6858000" cy="2971800"/>
+          </a:xfrm>
+          <a:prstGeom prst="rect">
+            <a:avLst/>
+          </a:prstGeom>
+          <a:noFill/>
+        </p:spPr>
+        <p:txBody>
+          <a:bodyPr wrap="square">
+            <a:spAutoFit/>
+          </a:bodyPr>
+          <a:lstStyle/>
+          <a:p>
+            <a:pPr>
+              <a:defRPr sz="1600" b="0">
+                <a:solidFill>
+                  <a:srgbClr val="2E86AB"/>
+                </a:solidFill>
+                <a:latin typeface="Source Sans Pro"/>
+              </a:defRPr>
+            </a:pPr>
+            <a:r>
+              <a:t>We revolutionize technology through innovative design and human-centered solutions that empower businesses to achieve their digital transformation goals.</a:t>
+            </a:r>
+          </a:p>
+        </p:txBody>
+      </p:sp>
+      <p:sp>
+        <p:nvSpPr>
+          <p:cNvPr id="5" name="TextBox 4"/>
+          <p:cNvSpPr txBox="1"/>
+          <p:nvPr/>
+        </p:nvSpPr>
+        <p:spPr>
+          <a:xfrm>
+            <a:off x="457200" y="5657850"/>
+            <a:ext cx="4114800" cy="742950"/>
           </a:xfrm>
           <a:prstGeom prst="rect">
             <a:avLst/>
@@ -5883,294 +6164,6 @@
           </a:bodyPr>
           <a:lstStyle/>
           <a:p>
-            <a:pPr>
-              <a:defRPr sz="2000" b="0">
-                <a:solidFill>
-                  <a:srgbClr val="2E86AB"/>
-                </a:solidFill>
-                <a:latin typeface="Source Sans Pro"/>
-              </a:defRPr>
-            </a:pPr>
-            <a:r>
-              <a:t>Primary Font: Inter</a:t>
-            </a:r>
-          </a:p>
-        </p:txBody>
-      </p:sp>
-      <p:sp>
-        <p:nvSpPr>
-          <p:cNvPr id="5" name="TextBox 4"/>
-          <p:cNvSpPr txBox="1"/>
-          <p:nvPr/>
-        </p:nvSpPr>
-        <p:spPr>
-          <a:xfrm>
-            <a:off x="1143000" y="2686050"/>
-            <a:ext cx="3429000" cy="742950"/>
-          </a:xfrm>
-          <a:prstGeom prst="rect">
-            <a:avLst/>
-          </a:prstGeom>
-          <a:noFill/>
-        </p:spPr>
-        <p:txBody>
-          <a:bodyPr wrap="none">
-            <a:spAutoFit/>
-          </a:bodyPr>
-          <a:lstStyle/>
-          <a:p>
-            <a:pPr>
-              <a:defRPr sz="3200" b="1">
-                <a:solidFill>
-                  <a:srgbClr val="2E86AB"/>
-                </a:solidFill>
-                <a:latin typeface="Inter"/>
-              </a:defRPr>
-            </a:pPr>
-            <a:r>
-              <a:t>H1 Heading</a:t>
-            </a:r>
-          </a:p>
-        </p:txBody>
-      </p:sp>
-      <p:sp>
-        <p:nvSpPr>
-          <p:cNvPr id="6" name="TextBox 5"/>
-          <p:cNvSpPr txBox="1"/>
-          <p:nvPr/>
-        </p:nvSpPr>
-        <p:spPr>
-          <a:xfrm>
-            <a:off x="1143000" y="3429000"/>
-            <a:ext cx="3429000" cy="742950"/>
-          </a:xfrm>
-          <a:prstGeom prst="rect">
-            <a:avLst/>
-          </a:prstGeom>
-          <a:noFill/>
-        </p:spPr>
-        <p:txBody>
-          <a:bodyPr wrap="none">
-            <a:spAutoFit/>
-          </a:bodyPr>
-          <a:lstStyle/>
-          <a:p>
-            <a:pPr>
-              <a:defRPr sz="2400" b="1">
-                <a:solidFill>
-                  <a:srgbClr val="2E86AB"/>
-                </a:solidFill>
-                <a:latin typeface="Inter"/>
-              </a:defRPr>
-            </a:pPr>
-            <a:r>
-              <a:t>H2 Heading</a:t>
-            </a:r>
-          </a:p>
-        </p:txBody>
-      </p:sp>
-      <p:sp>
-        <p:nvSpPr>
-          <p:cNvPr id="7" name="TextBox 6"/>
-          <p:cNvSpPr txBox="1"/>
-          <p:nvPr/>
-        </p:nvSpPr>
-        <p:spPr>
-          <a:xfrm>
-            <a:off x="1143000" y="4171950"/>
-            <a:ext cx="3429000" cy="742950"/>
-          </a:xfrm>
-          <a:prstGeom prst="rect">
-            <a:avLst/>
-          </a:prstGeom>
-          <a:noFill/>
-        </p:spPr>
-        <p:txBody>
-          <a:bodyPr wrap="none">
-            <a:spAutoFit/>
-          </a:bodyPr>
-          <a:lstStyle/>
-          <a:p>
-            <a:pPr>
-              <a:defRPr sz="2000" b="0">
-                <a:solidFill>
-                  <a:srgbClr val="2E86AB"/>
-                </a:solidFill>
-                <a:latin typeface="Inter"/>
-              </a:defRPr>
-            </a:pPr>
-            <a:r>
-              <a:t>H3 Heading</a:t>
-            </a:r>
-          </a:p>
-        </p:txBody>
-      </p:sp>
-      <p:sp>
-        <p:nvSpPr>
-          <p:cNvPr id="8" name="TextBox 7"/>
-          <p:cNvSpPr txBox="1"/>
-          <p:nvPr/>
-        </p:nvSpPr>
-        <p:spPr>
-          <a:xfrm>
-            <a:off x="5257800" y="1943100"/>
-            <a:ext cx="3429000" cy="742950"/>
-          </a:xfrm>
-          <a:prstGeom prst="rect">
-            <a:avLst/>
-          </a:prstGeom>
-          <a:noFill/>
-        </p:spPr>
-        <p:txBody>
-          <a:bodyPr wrap="none">
-            <a:spAutoFit/>
-          </a:bodyPr>
-          <a:lstStyle/>
-          <a:p>
-            <a:pPr>
-              <a:defRPr sz="2000" b="0">
-                <a:solidFill>
-                  <a:srgbClr val="2E86AB"/>
-                </a:solidFill>
-                <a:latin typeface="Source Sans Pro"/>
-              </a:defRPr>
-            </a:pPr>
-            <a:r>
-              <a:t>Secondary Font: Source Sans Pro</a:t>
-            </a:r>
-          </a:p>
-        </p:txBody>
-      </p:sp>
-      <p:sp>
-        <p:nvSpPr>
-          <p:cNvPr id="9" name="TextBox 8"/>
-          <p:cNvSpPr txBox="1"/>
-          <p:nvPr/>
-        </p:nvSpPr>
-        <p:spPr>
-          <a:xfrm>
-            <a:off x="5257800" y="2686050"/>
-            <a:ext cx="3429000" cy="742950"/>
-          </a:xfrm>
-          <a:prstGeom prst="rect">
-            <a:avLst/>
-          </a:prstGeom>
-          <a:noFill/>
-        </p:spPr>
-        <p:txBody>
-          <a:bodyPr wrap="none">
-            <a:spAutoFit/>
-          </a:bodyPr>
-          <a:lstStyle/>
-          <a:p>
-            <a:pPr>
-              <a:defRPr sz="1600" b="0">
-                <a:solidFill>
-                  <a:srgbClr val="2E86AB"/>
-                </a:solidFill>
-                <a:latin typeface="Source Sans Pro"/>
-              </a:defRPr>
-            </a:pPr>
-            <a:r>
-              <a:t>Body Text</a:t>
-            </a:r>
-          </a:p>
-        </p:txBody>
-      </p:sp>
-      <p:sp>
-        <p:nvSpPr>
-          <p:cNvPr id="10" name="TextBox 9"/>
-          <p:cNvSpPr txBox="1"/>
-          <p:nvPr/>
-        </p:nvSpPr>
-        <p:spPr>
-          <a:xfrm>
-            <a:off x="5257800" y="3429000"/>
-            <a:ext cx="3429000" cy="742950"/>
-          </a:xfrm>
-          <a:prstGeom prst="rect">
-            <a:avLst/>
-          </a:prstGeom>
-          <a:noFill/>
-        </p:spPr>
-        <p:txBody>
-          <a:bodyPr wrap="none">
-            <a:spAutoFit/>
-          </a:bodyPr>
-          <a:lstStyle/>
-          <a:p>
-            <a:pPr>
-              <a:defRPr sz="1600" b="1">
-                <a:solidFill>
-                  <a:srgbClr val="2E86AB"/>
-                </a:solidFill>
-                <a:latin typeface="Source Sans Pro"/>
-              </a:defRPr>
-            </a:pPr>
-            <a:r>
-              <a:t>Body Bold</a:t>
-            </a:r>
-          </a:p>
-        </p:txBody>
-      </p:sp>
-      <p:sp>
-        <p:nvSpPr>
-          <p:cNvPr id="11" name="TextBox 10"/>
-          <p:cNvSpPr txBox="1"/>
-          <p:nvPr/>
-        </p:nvSpPr>
-        <p:spPr>
-          <a:xfrm>
-            <a:off x="5257800" y="4171950"/>
-            <a:ext cx="3429000" cy="742950"/>
-          </a:xfrm>
-          <a:prstGeom prst="rect">
-            <a:avLst/>
-          </a:prstGeom>
-          <a:noFill/>
-        </p:spPr>
-        <p:txBody>
-          <a:bodyPr wrap="none">
-            <a:spAutoFit/>
-          </a:bodyPr>
-          <a:lstStyle/>
-          <a:p>
-            <a:pPr>
-              <a:defRPr sz="1200" b="0">
-                <a:solidFill>
-                  <a:srgbClr val="2E86AB"/>
-                </a:solidFill>
-                <a:latin typeface="Source Sans Pro"/>
-              </a:defRPr>
-            </a:pPr>
-            <a:r>
-              <a:t>Caption Text</a:t>
-            </a:r>
-          </a:p>
-        </p:txBody>
-      </p:sp>
-      <p:sp>
-        <p:nvSpPr>
-          <p:cNvPr id="12" name="TextBox 11"/>
-          <p:cNvSpPr txBox="1"/>
-          <p:nvPr/>
-        </p:nvSpPr>
-        <p:spPr>
-          <a:xfrm>
-            <a:off x="457200" y="5657850"/>
-            <a:ext cx="4114800" cy="742950"/>
-          </a:xfrm>
-          <a:prstGeom prst="rect">
-            <a:avLst/>
-          </a:prstGeom>
-          <a:noFill/>
-        </p:spPr>
-        <p:txBody>
-          <a:bodyPr wrap="none">
-            <a:spAutoFit/>
-          </a:bodyPr>
-          <a:lstStyle/>
-          <a:p>
             <a:pPr algn="l">
               <a:defRPr sz="1000" b="0">
                 <a:solidFill>
@@ -6187,7 +6180,7 @@
       </p:sp>
       <p:sp>
         <p:nvSpPr>
-          <p:cNvPr id="13" name="TextBox 12"/>
+          <p:cNvPr id="6" name="TextBox 5"/>
           <p:cNvSpPr txBox="1"/>
           <p:nvPr/>
         </p:nvSpPr>
@@ -6313,207 +6306,31 @@
               </a:defRPr>
             </a:pPr>
             <a:r>
-              <a:t>Visual &amp; Photography Guidelines</a:t>
-            </a:r>
-          </a:p>
-        </p:txBody>
-      </p:sp>
-      <p:sp>
-        <p:nvSpPr>
-          <p:cNvPr id="4" name="TextBox 3"/>
-          <p:cNvSpPr txBox="1"/>
+              <a:t>Color Palette</a:t>
+            </a:r>
+          </a:p>
+        </p:txBody>
+      </p:sp>
+      <p:sp>
+        <p:nvSpPr>
+          <p:cNvPr id="4" name="Rectangle 3"/>
+          <p:cNvSpPr/>
           <p:nvPr/>
         </p:nvSpPr>
         <p:spPr>
           <a:xfrm>
             <a:off x="1143000" y="1943100"/>
-            <a:ext cx="3429000" cy="2971800"/>
-          </a:xfrm>
-          <a:prstGeom prst="rect">
-            <a:avLst/>
-          </a:prstGeom>
-          <a:noFill/>
-        </p:spPr>
-        <p:txBody>
-          <a:bodyPr wrap="square">
-            <a:spAutoFit/>
-          </a:bodyPr>
-          <a:lstStyle/>
-          <a:p>
-            <a:pPr>
-              <a:defRPr sz="1800" b="0">
-                <a:solidFill>
-                  <a:srgbClr val="2E86AB"/>
-                </a:solidFill>
-                <a:latin typeface="Source Sans Pro"/>
-              </a:defRPr>
-            </a:pPr>
-            <a:r>
-              <a:t>Visual Style Guidelines:</a:t>
-            </a:r>
-          </a:p>
-          <a:p>
-            <a:pPr>
-              <a:defRPr sz="1400" b="0">
-                <a:solidFill>
-                  <a:srgbClr val="2E86AB"/>
-                </a:solidFill>
-                <a:latin typeface="Source Sans Pro"/>
-              </a:defRPr>
-            </a:pPr>
-            <a:r>
-              <a:t>• Modern</a:t>
-            </a:r>
-          </a:p>
-          <a:p>
-            <a:pPr>
-              <a:defRPr sz="1400" b="0">
-                <a:solidFill>
-                  <a:srgbClr val="2E86AB"/>
-                </a:solidFill>
-                <a:latin typeface="Source Sans Pro"/>
-              </a:defRPr>
-            </a:pPr>
-            <a:r>
-              <a:t>• clean</a:t>
-            </a:r>
-          </a:p>
-          <a:p>
-            <a:pPr>
-              <a:defRPr sz="1400" b="0">
-                <a:solidFill>
-                  <a:srgbClr val="2E86AB"/>
-                </a:solidFill>
-                <a:latin typeface="Source Sans Pro"/>
-              </a:defRPr>
-            </a:pPr>
-            <a:r>
-              <a:t>• professional</a:t>
-            </a:r>
-          </a:p>
-          <a:p>
-            <a:pPr>
-              <a:defRPr sz="1400" b="0">
-                <a:solidFill>
-                  <a:srgbClr val="2E86AB"/>
-                </a:solidFill>
-                <a:latin typeface="Source Sans Pro"/>
-              </a:defRPr>
-            </a:pPr>
-            <a:r>
-              <a:t>• minimalist</a:t>
-            </a:r>
-          </a:p>
-          <a:p>
-            <a:pPr>
-              <a:defRPr sz="1400" b="0">
-                <a:solidFill>
-                  <a:srgbClr val="2E86AB"/>
-                </a:solidFill>
-                <a:latin typeface="Source Sans Pro"/>
-              </a:defRPr>
-            </a:pPr>
-            <a:r>
-              <a:t>• bold typography</a:t>
-            </a:r>
-          </a:p>
-        </p:txBody>
-      </p:sp>
-      <p:sp>
-        <p:nvSpPr>
-          <p:cNvPr id="5" name="TextBox 4"/>
-          <p:cNvSpPr txBox="1"/>
-          <p:nvPr/>
-        </p:nvSpPr>
-        <p:spPr>
-          <a:xfrm>
-            <a:off x="5257800" y="1943100"/>
-            <a:ext cx="3429000" cy="2971800"/>
-          </a:xfrm>
-          <a:prstGeom prst="rect">
-            <a:avLst/>
-          </a:prstGeom>
-          <a:noFill/>
-        </p:spPr>
-        <p:txBody>
-          <a:bodyPr wrap="square">
-            <a:spAutoFit/>
-          </a:bodyPr>
-          <a:lstStyle/>
-          <a:p>
-            <a:pPr>
-              <a:defRPr sz="1800" b="0">
-                <a:solidFill>
-                  <a:srgbClr val="2E86AB"/>
-                </a:solidFill>
-                <a:latin typeface="Source Sans Pro"/>
-              </a:defRPr>
-            </a:pPr>
-            <a:r>
-              <a:t>Photography Guidelines:</a:t>
-            </a:r>
-          </a:p>
-          <a:p>
-            <a:pPr>
-              <a:defRPr sz="1400" b="0">
-                <a:solidFill>
-                  <a:srgbClr val="2E86AB"/>
-                </a:solidFill>
-                <a:latin typeface="Source Sans Pro"/>
-              </a:defRPr>
-            </a:pPr>
-            <a:r>
-              <a:t>• High contrast</a:t>
-            </a:r>
-          </a:p>
-          <a:p>
-            <a:pPr>
-              <a:defRPr sz="1400" b="0">
-                <a:solidFill>
-                  <a:srgbClr val="2E86AB"/>
-                </a:solidFill>
-                <a:latin typeface="Source Sans Pro"/>
-              </a:defRPr>
-            </a:pPr>
-            <a:r>
-              <a:t>• authentic moments</a:t>
-            </a:r>
-          </a:p>
-          <a:p>
-            <a:pPr>
-              <a:defRPr sz="1400" b="0">
-                <a:solidFill>
-                  <a:srgbClr val="2E86AB"/>
-                </a:solidFill>
-                <a:latin typeface="Source Sans Pro"/>
-              </a:defRPr>
-            </a:pPr>
-            <a:r>
-              <a:t>• natural lighting</a:t>
-            </a:r>
-          </a:p>
-        </p:txBody>
-      </p:sp>
-      <p:sp>
-        <p:nvSpPr>
-          <p:cNvPr id="6" name="Rectangle 5"/>
-          <p:cNvSpPr/>
-          <p:nvPr/>
-        </p:nvSpPr>
-        <p:spPr>
-          <a:xfrm>
-            <a:off x="5257800" y="4914900"/>
-            <a:ext cx="685800" cy="742950"/>
+            <a:ext cx="2057400" cy="1485900"/>
           </a:xfrm>
           <a:prstGeom prst="rect">
             <a:avLst/>
           </a:prstGeom>
           <a:solidFill>
-            <a:srgbClr val="404040"/>
+            <a:srgbClr val="2E86AB"/>
           </a:solidFill>
           <a:ln w="12700">
             <a:solidFill>
-              <a:srgbClr val="808080"/>
+              <a:srgbClr val="FFFFFF"/>
             </a:solidFill>
           </a:ln>
         </p:spPr>
@@ -6541,14 +6358,14 @@
       </p:sp>
       <p:sp>
         <p:nvSpPr>
-          <p:cNvPr id="7" name="TextBox 6"/>
+          <p:cNvPr id="5" name="TextBox 4"/>
           <p:cNvSpPr txBox="1"/>
           <p:nvPr/>
         </p:nvSpPr>
         <p:spPr>
           <a:xfrm>
-            <a:off x="5257800" y="5162550"/>
-            <a:ext cx="685800" cy="247650"/>
+            <a:off x="1143000" y="3429000"/>
+            <a:ext cx="2057400" cy="1485900"/>
           </a:xfrm>
           <a:prstGeom prst="rect">
             <a:avLst/>
@@ -6556,13 +6373,13 @@
           <a:noFill/>
         </p:spPr>
         <p:txBody>
-          <a:bodyPr wrap="none">
+          <a:bodyPr wrap="square">
             <a:spAutoFit/>
           </a:bodyPr>
           <a:lstStyle/>
           <a:p>
-            <a:pPr algn="ctr">
-              <a:defRPr sz="800" b="0">
+            <a:pPr>
+              <a:defRPr sz="1000" b="0">
                 <a:solidFill>
                   <a:srgbClr val="2E86AB"/>
                 </a:solidFill>
@@ -6570,31 +6387,83 @@
               </a:defRPr>
             </a:pPr>
             <a:r>
-              <a:t>Example</a:t>
-            </a:r>
-          </a:p>
-        </p:txBody>
-      </p:sp>
-      <p:sp>
-        <p:nvSpPr>
-          <p:cNvPr id="8" name="Rectangle 7"/>
+              <a:t>Primary</a:t>
+            </a:r>
+          </a:p>
+          <a:p>
+            <a:pPr>
+              <a:defRPr sz="1000" b="0">
+                <a:solidFill>
+                  <a:srgbClr val="2E86AB"/>
+                </a:solidFill>
+                <a:latin typeface="Source Sans Pro"/>
+              </a:defRPr>
+            </a:pPr>
+            <a:r>
+              <a:t>#2E86AB</a:t>
+            </a:r>
+          </a:p>
+          <a:p>
+            <a:pPr>
+              <a:defRPr sz="1000" b="0">
+                <a:solidFill>
+                  <a:srgbClr val="2E86AB"/>
+                </a:solidFill>
+                <a:latin typeface="Source Sans Pro"/>
+              </a:defRPr>
+            </a:pPr>
+            <a:r>
+              <a:t>RGB(46, 134, 171)</a:t>
+            </a:r>
+          </a:p>
+          <a:p>
+            <a:pPr>
+              <a:defRPr sz="1000" b="0">
+                <a:solidFill>
+                  <a:srgbClr val="2E86AB"/>
+                </a:solidFill>
+                <a:latin typeface="Source Sans Pro"/>
+              </a:defRPr>
+            </a:pPr>
+            <a:r>
+              <a:t>CMYK(73, 21, 0, 32)</a:t>
+            </a:r>
+          </a:p>
+          <a:p>
+            <a:pPr>
+              <a:defRPr sz="1000" b="0">
+                <a:solidFill>
+                  <a:srgbClr val="2E86AB"/>
+                </a:solidFill>
+                <a:latin typeface="Source Sans Pro"/>
+              </a:defRPr>
+            </a:pPr>
+            <a:r>
+              <a:t>Use Light Text</a:t>
+            </a:r>
+          </a:p>
+        </p:txBody>
+      </p:sp>
+      <p:sp>
+        <p:nvSpPr>
+          <p:cNvPr id="6" name="Rectangle 5"/>
           <p:cNvSpPr/>
           <p:nvPr/>
         </p:nvSpPr>
         <p:spPr>
           <a:xfrm>
-            <a:off x="6629400" y="4914900"/>
-            <a:ext cx="685800" cy="742950"/>
+            <a:off x="3886200" y="1943100"/>
+            <a:ext cx="2057400" cy="1485900"/>
           </a:xfrm>
           <a:prstGeom prst="rect">
             <a:avLst/>
           </a:prstGeom>
           <a:solidFill>
-            <a:srgbClr val="404040"/>
+            <a:srgbClr val="A23B72"/>
           </a:solidFill>
           <a:ln w="12700">
             <a:solidFill>
-              <a:srgbClr val="808080"/>
+              <a:srgbClr val="FFFFFF"/>
             </a:solidFill>
           </a:ln>
         </p:spPr>
@@ -6622,14 +6491,14 @@
       </p:sp>
       <p:sp>
         <p:nvSpPr>
-          <p:cNvPr id="9" name="TextBox 8"/>
+          <p:cNvPr id="7" name="TextBox 6"/>
           <p:cNvSpPr txBox="1"/>
           <p:nvPr/>
         </p:nvSpPr>
         <p:spPr>
           <a:xfrm>
-            <a:off x="6629400" y="5162550"/>
-            <a:ext cx="685800" cy="247650"/>
+            <a:off x="3886200" y="3429000"/>
+            <a:ext cx="2057400" cy="1485900"/>
           </a:xfrm>
           <a:prstGeom prst="rect">
             <a:avLst/>
@@ -6637,13 +6506,13 @@
           <a:noFill/>
         </p:spPr>
         <p:txBody>
-          <a:bodyPr wrap="none">
+          <a:bodyPr wrap="square">
             <a:spAutoFit/>
           </a:bodyPr>
           <a:lstStyle/>
           <a:p>
-            <a:pPr algn="ctr">
-              <a:defRPr sz="800" b="0">
+            <a:pPr>
+              <a:defRPr sz="1000" b="0">
                 <a:solidFill>
                   <a:srgbClr val="2E86AB"/>
                 </a:solidFill>
@@ -6651,31 +6520,83 @@
               </a:defRPr>
             </a:pPr>
             <a:r>
-              <a:t>Example</a:t>
-            </a:r>
-          </a:p>
-        </p:txBody>
-      </p:sp>
-      <p:sp>
-        <p:nvSpPr>
-          <p:cNvPr id="10" name="Rectangle 9"/>
+              <a:t>Secondary</a:t>
+            </a:r>
+          </a:p>
+          <a:p>
+            <a:pPr>
+              <a:defRPr sz="1000" b="0">
+                <a:solidFill>
+                  <a:srgbClr val="2E86AB"/>
+                </a:solidFill>
+                <a:latin typeface="Source Sans Pro"/>
+              </a:defRPr>
+            </a:pPr>
+            <a:r>
+              <a:t>#A23B72</a:t>
+            </a:r>
+          </a:p>
+          <a:p>
+            <a:pPr>
+              <a:defRPr sz="1000" b="0">
+                <a:solidFill>
+                  <a:srgbClr val="2E86AB"/>
+                </a:solidFill>
+                <a:latin typeface="Source Sans Pro"/>
+              </a:defRPr>
+            </a:pPr>
+            <a:r>
+              <a:t>RGB(162, 59, 114)</a:t>
+            </a:r>
+          </a:p>
+          <a:p>
+            <a:pPr>
+              <a:defRPr sz="1000" b="0">
+                <a:solidFill>
+                  <a:srgbClr val="2E86AB"/>
+                </a:solidFill>
+                <a:latin typeface="Source Sans Pro"/>
+              </a:defRPr>
+            </a:pPr>
+            <a:r>
+              <a:t>CMYK(0, 63, 29, 36)</a:t>
+            </a:r>
+          </a:p>
+          <a:p>
+            <a:pPr>
+              <a:defRPr sz="1000" b="0">
+                <a:solidFill>
+                  <a:srgbClr val="2E86AB"/>
+                </a:solidFill>
+                <a:latin typeface="Source Sans Pro"/>
+              </a:defRPr>
+            </a:pPr>
+            <a:r>
+              <a:t>Use Light Text</a:t>
+            </a:r>
+          </a:p>
+        </p:txBody>
+      </p:sp>
+      <p:sp>
+        <p:nvSpPr>
+          <p:cNvPr id="8" name="Rectangle 7"/>
           <p:cNvSpPr/>
           <p:nvPr/>
         </p:nvSpPr>
         <p:spPr>
           <a:xfrm>
-            <a:off x="8001000" y="4914900"/>
-            <a:ext cx="685800" cy="742950"/>
+            <a:off x="6629400" y="1943100"/>
+            <a:ext cx="2057400" cy="1485900"/>
           </a:xfrm>
           <a:prstGeom prst="rect">
             <a:avLst/>
           </a:prstGeom>
           <a:solidFill>
-            <a:srgbClr val="404040"/>
+            <a:srgbClr val="F18F01"/>
           </a:solidFill>
           <a:ln w="12700">
             <a:solidFill>
-              <a:srgbClr val="808080"/>
+              <a:srgbClr val="FFFFFF"/>
             </a:solidFill>
           </a:ln>
         </p:spPr>
@@ -6703,14 +6624,102 @@
       </p:sp>
       <p:sp>
         <p:nvSpPr>
-          <p:cNvPr id="11" name="TextBox 10"/>
+          <p:cNvPr id="9" name="TextBox 8"/>
           <p:cNvSpPr txBox="1"/>
           <p:nvPr/>
         </p:nvSpPr>
         <p:spPr>
           <a:xfrm>
-            <a:off x="8001000" y="5162550"/>
-            <a:ext cx="685800" cy="247650"/>
+            <a:off x="6629400" y="3429000"/>
+            <a:ext cx="2057400" cy="1485900"/>
+          </a:xfrm>
+          <a:prstGeom prst="rect">
+            <a:avLst/>
+          </a:prstGeom>
+          <a:noFill/>
+        </p:spPr>
+        <p:txBody>
+          <a:bodyPr wrap="square">
+            <a:spAutoFit/>
+          </a:bodyPr>
+          <a:lstStyle/>
+          <a:p>
+            <a:pPr>
+              <a:defRPr sz="1000" b="0">
+                <a:solidFill>
+                  <a:srgbClr val="2E86AB"/>
+                </a:solidFill>
+                <a:latin typeface="Source Sans Pro"/>
+              </a:defRPr>
+            </a:pPr>
+            <a:r>
+              <a:t>Accent</a:t>
+            </a:r>
+          </a:p>
+          <a:p>
+            <a:pPr>
+              <a:defRPr sz="1000" b="0">
+                <a:solidFill>
+                  <a:srgbClr val="2E86AB"/>
+                </a:solidFill>
+                <a:latin typeface="Source Sans Pro"/>
+              </a:defRPr>
+            </a:pPr>
+            <a:r>
+              <a:t>#F18F01</a:t>
+            </a:r>
+          </a:p>
+          <a:p>
+            <a:pPr>
+              <a:defRPr sz="1000" b="0">
+                <a:solidFill>
+                  <a:srgbClr val="2E86AB"/>
+                </a:solidFill>
+                <a:latin typeface="Source Sans Pro"/>
+              </a:defRPr>
+            </a:pPr>
+            <a:r>
+              <a:t>RGB(241, 143, 1)</a:t>
+            </a:r>
+          </a:p>
+          <a:p>
+            <a:pPr>
+              <a:defRPr sz="1000" b="0">
+                <a:solidFill>
+                  <a:srgbClr val="2E86AB"/>
+                </a:solidFill>
+                <a:latin typeface="Source Sans Pro"/>
+              </a:defRPr>
+            </a:pPr>
+            <a:r>
+              <a:t>CMYK(0, 40, 99, 5)</a:t>
+            </a:r>
+          </a:p>
+          <a:p>
+            <a:pPr>
+              <a:defRPr sz="1000" b="0">
+                <a:solidFill>
+                  <a:srgbClr val="2E86AB"/>
+                </a:solidFill>
+                <a:latin typeface="Source Sans Pro"/>
+              </a:defRPr>
+            </a:pPr>
+            <a:r>
+              <a:t>Use Dark Text</a:t>
+            </a:r>
+          </a:p>
+        </p:txBody>
+      </p:sp>
+      <p:sp>
+        <p:nvSpPr>
+          <p:cNvPr id="10" name="TextBox 9"/>
+          <p:cNvSpPr txBox="1"/>
+          <p:nvPr/>
+        </p:nvSpPr>
+        <p:spPr>
+          <a:xfrm>
+            <a:off x="457200" y="5657850"/>
+            <a:ext cx="4114800" cy="742950"/>
           </a:xfrm>
           <a:prstGeom prst="rect">
             <a:avLst/>
@@ -6723,8 +6732,8 @@
           </a:bodyPr>
           <a:lstStyle/>
           <a:p>
-            <a:pPr algn="ctr">
-              <a:defRPr sz="800" b="0">
+            <a:pPr algn="l">
+              <a:defRPr sz="1000" b="0">
                 <a:solidFill>
                   <a:srgbClr val="2E86AB"/>
                 </a:solidFill>
@@ -6732,20 +6741,20 @@
               </a:defRPr>
             </a:pPr>
             <a:r>
-              <a:t>Example</a:t>
-            </a:r>
-          </a:p>
-        </p:txBody>
-      </p:sp>
-      <p:sp>
-        <p:nvSpPr>
-          <p:cNvPr id="12" name="TextBox 11"/>
+              <a:t>TechForward Live</a:t>
+            </a:r>
+          </a:p>
+        </p:txBody>
+      </p:sp>
+      <p:sp>
+        <p:nvSpPr>
+          <p:cNvPr id="11" name="TextBox 10"/>
           <p:cNvSpPr txBox="1"/>
           <p:nvPr/>
         </p:nvSpPr>
         <p:spPr>
           <a:xfrm>
-            <a:off x="457200" y="5657850"/>
+            <a:off x="4572000" y="5657850"/>
             <a:ext cx="4114800" cy="742950"/>
           </a:xfrm>
           <a:prstGeom prst="rect">
@@ -6759,7 +6768,7 @@
           </a:bodyPr>
           <a:lstStyle/>
           <a:p>
-            <a:pPr algn="l">
+            <a:pPr algn="r">
               <a:defRPr sz="1000" b="0">
                 <a:solidFill>
                   <a:srgbClr val="2E86AB"/>
@@ -6768,21 +6777,82 @@
               </a:defRPr>
             </a:pPr>
             <a:r>
-              <a:t>TechForward Live</a:t>
-            </a:r>
-          </a:p>
-        </p:txBody>
-      </p:sp>
-      <p:sp>
-        <p:nvSpPr>
-          <p:cNvPr id="13" name="TextBox 12"/>
+              <a:t>8</a:t>
+            </a:r>
+          </a:p>
+        </p:txBody>
+      </p:sp>
+    </p:spTree>
+  </p:cSld>
+  <p:clrMapOvr>
+    <a:masterClrMapping/>
+  </p:clrMapOvr>
+</p:sld>
+</file>
+
+<file path=ppt/slides/slide9.xml><?xml version="1.0" encoding="utf-8"?>
+<p:sld xmlns:a="http://schemas.openxmlformats.org/drawingml/2006/main" xmlns:p="http://schemas.openxmlformats.org/presentationml/2006/main" xmlns:r="http://schemas.openxmlformats.org/officeDocument/2006/relationships">
+  <p:cSld>
+    <p:spTree>
+      <p:nvGrpSpPr>
+        <p:cNvPr id="1" name=""/>
+        <p:cNvGrpSpPr/>
+        <p:nvPr/>
+      </p:nvGrpSpPr>
+      <p:sp>
+        <p:nvSpPr>
+          <p:cNvPr id="2" name="Rectangle 1"/>
+          <p:cNvSpPr/>
+          <p:nvPr/>
+        </p:nvSpPr>
+        <p:spPr>
+          <a:xfrm>
+            <a:off x="0" y="0"/>
+            <a:ext cx="9144000" cy="6858000"/>
+          </a:xfrm>
+          <a:prstGeom prst="rect">
+            <a:avLst/>
+          </a:prstGeom>
+          <a:solidFill>
+            <a:srgbClr val="1A1A1A"/>
+          </a:solidFill>
+          <a:ln>
+            <a:noFill/>
+          </a:ln>
+        </p:spPr>
+        <p:style>
+          <a:lnRef idx="1">
+            <a:schemeClr val="accent1"/>
+          </a:lnRef>
+          <a:fillRef idx="3">
+            <a:schemeClr val="accent1"/>
+          </a:fillRef>
+          <a:effectRef idx="2">
+            <a:schemeClr val="accent1"/>
+          </a:effectRef>
+          <a:fontRef idx="minor">
+            <a:schemeClr val="lt1"/>
+          </a:fontRef>
+        </p:style>
+        <p:txBody>
+          <a:bodyPr rtlCol="0" anchor="ctr"/>
+          <a:lstStyle/>
+          <a:p>
+            <a:pPr algn="ctr"/>
+          </a:p>
+        </p:txBody>
+      </p:sp>
+      <p:grpSpPr/>
+      <p:sp>
+        <p:nvSpPr>
+          <p:cNvPr id="3" name="TextBox 2"/>
           <p:cNvSpPr txBox="1"/>
           <p:nvPr/>
         </p:nvSpPr>
         <p:spPr>
           <a:xfrm>
-            <a:off x="4572000" y="5657850"/>
-            <a:ext cx="4114800" cy="742950"/>
+            <a:off x="1143000" y="457200"/>
+            <a:ext cx="6858000" cy="742950"/>
           </a:xfrm>
           <a:prstGeom prst="rect">
             <a:avLst/>
@@ -6795,6 +6865,366 @@
           </a:bodyPr>
           <a:lstStyle/>
           <a:p>
+            <a:pPr>
+              <a:defRPr sz="3200" b="1">
+                <a:solidFill>
+                  <a:srgbClr val="2E86AB"/>
+                </a:solidFill>
+                <a:latin typeface="Inter"/>
+              </a:defRPr>
+            </a:pPr>
+            <a:r>
+              <a:t>Typography</a:t>
+            </a:r>
+          </a:p>
+        </p:txBody>
+      </p:sp>
+      <p:sp>
+        <p:nvSpPr>
+          <p:cNvPr id="4" name="TextBox 3"/>
+          <p:cNvSpPr txBox="1"/>
+          <p:nvPr/>
+        </p:nvSpPr>
+        <p:spPr>
+          <a:xfrm>
+            <a:off x="1143000" y="1943100"/>
+            <a:ext cx="3429000" cy="742950"/>
+          </a:xfrm>
+          <a:prstGeom prst="rect">
+            <a:avLst/>
+          </a:prstGeom>
+          <a:noFill/>
+        </p:spPr>
+        <p:txBody>
+          <a:bodyPr wrap="none">
+            <a:spAutoFit/>
+          </a:bodyPr>
+          <a:lstStyle/>
+          <a:p>
+            <a:pPr>
+              <a:defRPr sz="2000" b="0">
+                <a:solidFill>
+                  <a:srgbClr val="2E86AB"/>
+                </a:solidFill>
+                <a:latin typeface="Source Sans Pro"/>
+              </a:defRPr>
+            </a:pPr>
+            <a:r>
+              <a:t>Primary Font: Inter</a:t>
+            </a:r>
+          </a:p>
+        </p:txBody>
+      </p:sp>
+      <p:sp>
+        <p:nvSpPr>
+          <p:cNvPr id="5" name="TextBox 4"/>
+          <p:cNvSpPr txBox="1"/>
+          <p:nvPr/>
+        </p:nvSpPr>
+        <p:spPr>
+          <a:xfrm>
+            <a:off x="1143000" y="2686050"/>
+            <a:ext cx="3429000" cy="742950"/>
+          </a:xfrm>
+          <a:prstGeom prst="rect">
+            <a:avLst/>
+          </a:prstGeom>
+          <a:noFill/>
+        </p:spPr>
+        <p:txBody>
+          <a:bodyPr wrap="none">
+            <a:spAutoFit/>
+          </a:bodyPr>
+          <a:lstStyle/>
+          <a:p>
+            <a:pPr>
+              <a:defRPr sz="3200" b="1">
+                <a:solidFill>
+                  <a:srgbClr val="2E86AB"/>
+                </a:solidFill>
+                <a:latin typeface="Inter"/>
+              </a:defRPr>
+            </a:pPr>
+            <a:r>
+              <a:t>H1 Heading</a:t>
+            </a:r>
+          </a:p>
+        </p:txBody>
+      </p:sp>
+      <p:sp>
+        <p:nvSpPr>
+          <p:cNvPr id="6" name="TextBox 5"/>
+          <p:cNvSpPr txBox="1"/>
+          <p:nvPr/>
+        </p:nvSpPr>
+        <p:spPr>
+          <a:xfrm>
+            <a:off x="1143000" y="3429000"/>
+            <a:ext cx="3429000" cy="742950"/>
+          </a:xfrm>
+          <a:prstGeom prst="rect">
+            <a:avLst/>
+          </a:prstGeom>
+          <a:noFill/>
+        </p:spPr>
+        <p:txBody>
+          <a:bodyPr wrap="none">
+            <a:spAutoFit/>
+          </a:bodyPr>
+          <a:lstStyle/>
+          <a:p>
+            <a:pPr>
+              <a:defRPr sz="2400" b="1">
+                <a:solidFill>
+                  <a:srgbClr val="2E86AB"/>
+                </a:solidFill>
+                <a:latin typeface="Inter"/>
+              </a:defRPr>
+            </a:pPr>
+            <a:r>
+              <a:t>H2 Heading</a:t>
+            </a:r>
+          </a:p>
+        </p:txBody>
+      </p:sp>
+      <p:sp>
+        <p:nvSpPr>
+          <p:cNvPr id="7" name="TextBox 6"/>
+          <p:cNvSpPr txBox="1"/>
+          <p:nvPr/>
+        </p:nvSpPr>
+        <p:spPr>
+          <a:xfrm>
+            <a:off x="1143000" y="4171950"/>
+            <a:ext cx="3429000" cy="742950"/>
+          </a:xfrm>
+          <a:prstGeom prst="rect">
+            <a:avLst/>
+          </a:prstGeom>
+          <a:noFill/>
+        </p:spPr>
+        <p:txBody>
+          <a:bodyPr wrap="none">
+            <a:spAutoFit/>
+          </a:bodyPr>
+          <a:lstStyle/>
+          <a:p>
+            <a:pPr>
+              <a:defRPr sz="2000" b="0">
+                <a:solidFill>
+                  <a:srgbClr val="2E86AB"/>
+                </a:solidFill>
+                <a:latin typeface="Inter"/>
+              </a:defRPr>
+            </a:pPr>
+            <a:r>
+              <a:t>H3 Heading</a:t>
+            </a:r>
+          </a:p>
+        </p:txBody>
+      </p:sp>
+      <p:sp>
+        <p:nvSpPr>
+          <p:cNvPr id="8" name="TextBox 7"/>
+          <p:cNvSpPr txBox="1"/>
+          <p:nvPr/>
+        </p:nvSpPr>
+        <p:spPr>
+          <a:xfrm>
+            <a:off x="5257800" y="1943100"/>
+            <a:ext cx="3429000" cy="742950"/>
+          </a:xfrm>
+          <a:prstGeom prst="rect">
+            <a:avLst/>
+          </a:prstGeom>
+          <a:noFill/>
+        </p:spPr>
+        <p:txBody>
+          <a:bodyPr wrap="none">
+            <a:spAutoFit/>
+          </a:bodyPr>
+          <a:lstStyle/>
+          <a:p>
+            <a:pPr>
+              <a:defRPr sz="2000" b="0">
+                <a:solidFill>
+                  <a:srgbClr val="2E86AB"/>
+                </a:solidFill>
+                <a:latin typeface="Source Sans Pro"/>
+              </a:defRPr>
+            </a:pPr>
+            <a:r>
+              <a:t>Secondary Font: Source Sans Pro</a:t>
+            </a:r>
+          </a:p>
+        </p:txBody>
+      </p:sp>
+      <p:sp>
+        <p:nvSpPr>
+          <p:cNvPr id="9" name="TextBox 8"/>
+          <p:cNvSpPr txBox="1"/>
+          <p:nvPr/>
+        </p:nvSpPr>
+        <p:spPr>
+          <a:xfrm>
+            <a:off x="5257800" y="2686050"/>
+            <a:ext cx="3429000" cy="742950"/>
+          </a:xfrm>
+          <a:prstGeom prst="rect">
+            <a:avLst/>
+          </a:prstGeom>
+          <a:noFill/>
+        </p:spPr>
+        <p:txBody>
+          <a:bodyPr wrap="none">
+            <a:spAutoFit/>
+          </a:bodyPr>
+          <a:lstStyle/>
+          <a:p>
+            <a:pPr>
+              <a:defRPr sz="1600" b="0">
+                <a:solidFill>
+                  <a:srgbClr val="2E86AB"/>
+                </a:solidFill>
+                <a:latin typeface="Source Sans Pro"/>
+              </a:defRPr>
+            </a:pPr>
+            <a:r>
+              <a:t>Body Text</a:t>
+            </a:r>
+          </a:p>
+        </p:txBody>
+      </p:sp>
+      <p:sp>
+        <p:nvSpPr>
+          <p:cNvPr id="10" name="TextBox 9"/>
+          <p:cNvSpPr txBox="1"/>
+          <p:nvPr/>
+        </p:nvSpPr>
+        <p:spPr>
+          <a:xfrm>
+            <a:off x="5257800" y="3429000"/>
+            <a:ext cx="3429000" cy="742950"/>
+          </a:xfrm>
+          <a:prstGeom prst="rect">
+            <a:avLst/>
+          </a:prstGeom>
+          <a:noFill/>
+        </p:spPr>
+        <p:txBody>
+          <a:bodyPr wrap="none">
+            <a:spAutoFit/>
+          </a:bodyPr>
+          <a:lstStyle/>
+          <a:p>
+            <a:pPr>
+              <a:defRPr sz="1600" b="1">
+                <a:solidFill>
+                  <a:srgbClr val="2E86AB"/>
+                </a:solidFill>
+                <a:latin typeface="Source Sans Pro"/>
+              </a:defRPr>
+            </a:pPr>
+            <a:r>
+              <a:t>Body Bold</a:t>
+            </a:r>
+          </a:p>
+        </p:txBody>
+      </p:sp>
+      <p:sp>
+        <p:nvSpPr>
+          <p:cNvPr id="11" name="TextBox 10"/>
+          <p:cNvSpPr txBox="1"/>
+          <p:nvPr/>
+        </p:nvSpPr>
+        <p:spPr>
+          <a:xfrm>
+            <a:off x="5257800" y="4171950"/>
+            <a:ext cx="3429000" cy="742950"/>
+          </a:xfrm>
+          <a:prstGeom prst="rect">
+            <a:avLst/>
+          </a:prstGeom>
+          <a:noFill/>
+        </p:spPr>
+        <p:txBody>
+          <a:bodyPr wrap="none">
+            <a:spAutoFit/>
+          </a:bodyPr>
+          <a:lstStyle/>
+          <a:p>
+            <a:pPr>
+              <a:defRPr sz="1200" b="0">
+                <a:solidFill>
+                  <a:srgbClr val="2E86AB"/>
+                </a:solidFill>
+                <a:latin typeface="Source Sans Pro"/>
+              </a:defRPr>
+            </a:pPr>
+            <a:r>
+              <a:t>Caption Text</a:t>
+            </a:r>
+          </a:p>
+        </p:txBody>
+      </p:sp>
+      <p:sp>
+        <p:nvSpPr>
+          <p:cNvPr id="12" name="TextBox 11"/>
+          <p:cNvSpPr txBox="1"/>
+          <p:nvPr/>
+        </p:nvSpPr>
+        <p:spPr>
+          <a:xfrm>
+            <a:off x="457200" y="5657850"/>
+            <a:ext cx="4114800" cy="742950"/>
+          </a:xfrm>
+          <a:prstGeom prst="rect">
+            <a:avLst/>
+          </a:prstGeom>
+          <a:noFill/>
+        </p:spPr>
+        <p:txBody>
+          <a:bodyPr wrap="none">
+            <a:spAutoFit/>
+          </a:bodyPr>
+          <a:lstStyle/>
+          <a:p>
+            <a:pPr algn="l">
+              <a:defRPr sz="1000" b="0">
+                <a:solidFill>
+                  <a:srgbClr val="2E86AB"/>
+                </a:solidFill>
+                <a:latin typeface="Source Sans Pro"/>
+              </a:defRPr>
+            </a:pPr>
+            <a:r>
+              <a:t>TechForward Live</a:t>
+            </a:r>
+          </a:p>
+        </p:txBody>
+      </p:sp>
+      <p:sp>
+        <p:nvSpPr>
+          <p:cNvPr id="13" name="TextBox 12"/>
+          <p:cNvSpPr txBox="1"/>
+          <p:nvPr/>
+        </p:nvSpPr>
+        <p:spPr>
+          <a:xfrm>
+            <a:off x="4572000" y="5657850"/>
+            <a:ext cx="4114800" cy="742950"/>
+          </a:xfrm>
+          <a:prstGeom prst="rect">
+            <a:avLst/>
+          </a:prstGeom>
+          <a:noFill/>
+        </p:spPr>
+        <p:txBody>
+          <a:bodyPr wrap="none">
+            <a:spAutoFit/>
+          </a:bodyPr>
+          <a:lstStyle/>
+          <a:p>
             <a:pPr algn="r">
               <a:defRPr sz="1000" b="0">
                 <a:solidFill>
@@ -6804,7 +7234,7 @@
               </a:defRPr>
             </a:pPr>
             <a:r>
-              <a:t>8</a:t>
+              <a:t>9</a:t>
             </a:r>
           </a:p>
         </p:txBody>

</xml_diff>

<commit_message>
Fixing Brand Story Template
</commit_message>
<xml_diff>
--- a/output/techforward_live/techforward_live_enhanced_brand_book.pptx
+++ b/output/techforward_live/techforward_live_enhanced_brand_book.pptx
@@ -6020,66 +6020,105 @@
 <file path=ppt/slides/slide7.xml><?xml version="1.0" encoding="utf-8"?>
 <p:sld xmlns:a="http://schemas.openxmlformats.org/drawingml/2006/main" xmlns:p="http://schemas.openxmlformats.org/presentationml/2006/main" xmlns:r="http://schemas.openxmlformats.org/officeDocument/2006/relationships">
   <p:cSld>
+    <p:bg>
+      <p:bgPr>
+        <a:solidFill>
+          <a:srgbClr val="000000"/>
+        </a:solidFill>
+        <a:effectLst/>
+      </p:bgPr>
+    </p:bg>
     <p:spTree>
       <p:nvGrpSpPr>
         <p:cNvPr id="1" name=""/>
         <p:cNvGrpSpPr/>
         <p:nvPr/>
       </p:nvGrpSpPr>
-      <p:sp>
-        <p:nvSpPr>
-          <p:cNvPr id="2" name="Rectangle 1"/>
-          <p:cNvSpPr/>
-          <p:nvPr/>
-        </p:nvSpPr>
-        <p:spPr>
-          <a:xfrm>
-            <a:off x="0" y="0"/>
-            <a:ext cx="9144000" cy="6858000"/>
-          </a:xfrm>
-          <a:prstGeom prst="rect">
-            <a:avLst/>
-          </a:prstGeom>
-          <a:solidFill>
-            <a:srgbClr val="1A1A1A"/>
-          </a:solidFill>
-          <a:ln>
-            <a:noFill/>
+      <p:grpSpPr/>
+      <p:sp>
+        <p:nvSpPr>
+          <p:cNvPr id="2" name="TextBox 1"/>
+          <p:cNvSpPr txBox="1"/>
+          <p:nvPr/>
+        </p:nvSpPr>
+        <p:spPr>
+          <a:xfrm>
+            <a:off x="800100" y="1051560"/>
+            <a:ext cx="6858000" cy="2971800"/>
+          </a:xfrm>
+          <a:prstGeom prst="rect">
+            <a:avLst/>
+          </a:prstGeom>
+          <a:noFill/>
+        </p:spPr>
+        <p:txBody>
+          <a:bodyPr wrap="square" lIns="0" rIns="0" tIns="0" bIns="0">
+            <a:spAutoFit/>
+          </a:bodyPr>
+          <a:lstStyle/>
+          <a:p>
+            <a:pPr algn="l">
+              <a:spcAft>
+                <a:spcPts val="800"/>
+              </a:spcAft>
+              <a:defRPr sz="2000" b="0">
+                <a:solidFill>
+                  <a:srgbClr val="FFFFFF"/>
+                </a:solidFill>
+                <a:latin typeface="Source Sans Pro"/>
+              </a:defRPr>
+            </a:pPr>
+            <a:r>
+              <a:t>We revolutionize technology through innovative design and human-centered solutions that empower businesses to achieve their digital transformation goals.</a:t>
+            </a:r>
+          </a:p>
+        </p:txBody>
+      </p:sp>
+      <p:cxnSp>
+        <p:nvCxnSpPr>
+          <p:cNvPr id="3" name="Connector 2"/>
+          <p:cNvCxnSpPr/>
+          <p:nvPr/>
+        </p:nvCxnSpPr>
+        <p:spPr>
+          <a:xfrm>
+            <a:off x="457200" y="4914900.0"/>
+            <a:ext cx="8229600" cy="0.0"/>
+          </a:xfrm>
+          <a:prstGeom prst="line">
+            <a:avLst/>
+          </a:prstGeom>
+          <a:ln w="25400">
+            <a:solidFill>
+              <a:srgbClr val="2E86AB"/>
+            </a:solidFill>
           </a:ln>
         </p:spPr>
         <p:style>
-          <a:lnRef idx="1">
+          <a:lnRef idx="2">
             <a:schemeClr val="accent1"/>
           </a:lnRef>
-          <a:fillRef idx="3">
+          <a:fillRef idx="0">
             <a:schemeClr val="accent1"/>
           </a:fillRef>
-          <a:effectRef idx="2">
+          <a:effectRef idx="1">
             <a:schemeClr val="accent1"/>
           </a:effectRef>
           <a:fontRef idx="minor">
-            <a:schemeClr val="lt1"/>
+            <a:schemeClr val="tx1"/>
           </a:fontRef>
         </p:style>
-        <p:txBody>
-          <a:bodyPr rtlCol="0" anchor="ctr"/>
-          <a:lstStyle/>
-          <a:p>
-            <a:pPr algn="ctr"/>
-          </a:p>
-        </p:txBody>
-      </p:sp>
-      <p:grpSpPr/>
-      <p:sp>
-        <p:nvSpPr>
-          <p:cNvPr id="3" name="TextBox 2"/>
+      </p:cxnSp>
+      <p:sp>
+        <p:nvSpPr>
+          <p:cNvPr id="4" name="TextBox 3"/>
           <p:cNvSpPr txBox="1"/>
           <p:nvPr/>
         </p:nvSpPr>
         <p:spPr>
           <a:xfrm>
-            <a:off x="1143000" y="457200"/>
-            <a:ext cx="6858000" cy="742950"/>
+            <a:off x="800100" y="5189220"/>
+            <a:ext cx="5486400" cy="731520"/>
           </a:xfrm>
           <a:prstGeom prst="rect">
             <a:avLst/>
@@ -6092,8 +6131,8 @@
           </a:bodyPr>
           <a:lstStyle/>
           <a:p>
-            <a:pPr>
-              <a:defRPr sz="3200" b="1">
+            <a:pPr algn="l">
+              <a:defRPr sz="2800" b="1">
                 <a:solidFill>
                   <a:srgbClr val="2E86AB"/>
                 </a:solidFill>
@@ -6101,115 +6140,7 @@
               </a:defRPr>
             </a:pPr>
             <a:r>
-              <a:t>Brand Story</a:t>
-            </a:r>
-          </a:p>
-        </p:txBody>
-      </p:sp>
-      <p:sp>
-        <p:nvSpPr>
-          <p:cNvPr id="4" name="TextBox 3"/>
-          <p:cNvSpPr txBox="1"/>
-          <p:nvPr/>
-        </p:nvSpPr>
-        <p:spPr>
-          <a:xfrm>
-            <a:off x="1143000" y="1943100"/>
-            <a:ext cx="6858000" cy="2971800"/>
-          </a:xfrm>
-          <a:prstGeom prst="rect">
-            <a:avLst/>
-          </a:prstGeom>
-          <a:noFill/>
-        </p:spPr>
-        <p:txBody>
-          <a:bodyPr wrap="square">
-            <a:spAutoFit/>
-          </a:bodyPr>
-          <a:lstStyle/>
-          <a:p>
-            <a:pPr>
-              <a:defRPr sz="1600" b="0">
-                <a:solidFill>
-                  <a:srgbClr val="2E86AB"/>
-                </a:solidFill>
-                <a:latin typeface="Source Sans Pro"/>
-              </a:defRPr>
-            </a:pPr>
-            <a:r>
-              <a:t>We revolutionize technology through innovative design and human-centered solutions that empower businesses to achieve their digital transformation goals.</a:t>
-            </a:r>
-          </a:p>
-        </p:txBody>
-      </p:sp>
-      <p:sp>
-        <p:nvSpPr>
-          <p:cNvPr id="5" name="TextBox 4"/>
-          <p:cNvSpPr txBox="1"/>
-          <p:nvPr/>
-        </p:nvSpPr>
-        <p:spPr>
-          <a:xfrm>
-            <a:off x="457200" y="5657850"/>
-            <a:ext cx="4114800" cy="742950"/>
-          </a:xfrm>
-          <a:prstGeom prst="rect">
-            <a:avLst/>
-          </a:prstGeom>
-          <a:noFill/>
-        </p:spPr>
-        <p:txBody>
-          <a:bodyPr wrap="none">
-            <a:spAutoFit/>
-          </a:bodyPr>
-          <a:lstStyle/>
-          <a:p>
-            <a:pPr algn="l">
-              <a:defRPr sz="1000" b="0">
-                <a:solidFill>
-                  <a:srgbClr val="2E86AB"/>
-                </a:solidFill>
-                <a:latin typeface="Source Sans Pro"/>
-              </a:defRPr>
-            </a:pPr>
-            <a:r>
-              <a:t>TechForward Live</a:t>
-            </a:r>
-          </a:p>
-        </p:txBody>
-      </p:sp>
-      <p:sp>
-        <p:nvSpPr>
-          <p:cNvPr id="6" name="TextBox 5"/>
-          <p:cNvSpPr txBox="1"/>
-          <p:nvPr/>
-        </p:nvSpPr>
-        <p:spPr>
-          <a:xfrm>
-            <a:off x="4572000" y="5657850"/>
-            <a:ext cx="4114800" cy="742950"/>
-          </a:xfrm>
-          <a:prstGeom prst="rect">
-            <a:avLst/>
-          </a:prstGeom>
-          <a:noFill/>
-        </p:spPr>
-        <p:txBody>
-          <a:bodyPr wrap="none">
-            <a:spAutoFit/>
-          </a:bodyPr>
-          <a:lstStyle/>
-          <a:p>
-            <a:pPr algn="r">
-              <a:defRPr sz="1000" b="0">
-                <a:solidFill>
-                  <a:srgbClr val="2E86AB"/>
-                </a:solidFill>
-                <a:latin typeface="Source Sans Pro"/>
-              </a:defRPr>
-            </a:pPr>
-            <a:r>
-              <a:t>7</a:t>
+              <a:t>BRAND STORY</a:t>
             </a:r>
           </a:p>
         </p:txBody>

</xml_diff>

<commit_message>
Added New Template for slide 1
</commit_message>
<xml_diff>
--- a/output/techforward_live/techforward_live_enhanced_brand_book.pptx
+++ b/output/techforward_live/techforward_live_enhanced_brand_book.pptx
@@ -3105,45 +3105,9 @@
         <p:nvPr/>
       </p:nvGrpSpPr>
       <p:grpSpPr/>
-      <p:sp>
-        <p:nvSpPr>
-          <p:cNvPr id="2" name="TextBox 1"/>
-          <p:cNvSpPr txBox="1"/>
-          <p:nvPr/>
-        </p:nvSpPr>
-        <p:spPr>
-          <a:xfrm>
-            <a:off x="1143000" y="3800475"/>
-            <a:ext cx="2743200" cy="742950"/>
-          </a:xfrm>
-          <a:prstGeom prst="rect">
-            <a:avLst/>
-          </a:prstGeom>
-          <a:noFill/>
-        </p:spPr>
-        <p:txBody>
-          <a:bodyPr wrap="none" lIns="0" rIns="0" tIns="0" bIns="0">
-            <a:spAutoFit/>
-          </a:bodyPr>
-          <a:lstStyle/>
-          <a:p>
-            <a:pPr algn="l">
-              <a:defRPr sz="3600" b="1">
-                <a:solidFill>
-                  <a:srgbClr val="FFFFFF"/>
-                </a:solidFill>
-                <a:latin typeface="Inter"/>
-              </a:defRPr>
-            </a:pPr>
-            <a:r>
-              <a:t>TechForward Live</a:t>
-            </a:r>
-          </a:p>
-        </p:txBody>
-      </p:sp>
       <p:cxnSp>
         <p:nvCxnSpPr>
-          <p:cNvPr id="3" name="Connector 2"/>
+          <p:cNvPr id="2" name="Connector 1"/>
           <p:cNvCxnSpPr/>
           <p:nvPr/>
         </p:nvCxnSpPr>
@@ -3178,7 +3142,7 @@
       </p:cxnSp>
       <p:sp>
         <p:nvSpPr>
-          <p:cNvPr id="4" name="TextBox 3"/>
+          <p:cNvPr id="3" name="TextBox 2"/>
           <p:cNvSpPr txBox="1"/>
           <p:nvPr/>
         </p:nvSpPr>

</xml_diff>

<commit_message>
Added Logo Slide in live pptx dev
</commit_message>
<xml_diff>
--- a/output/techforward_live/techforward_live_enhanced_brand_book.pptx
+++ b/output/techforward_live/techforward_live_enhanced_brand_book.pptx
@@ -15,6 +15,7 @@
     <p:sldId id="263" r:id="rId14"/>
     <p:sldId id="264" r:id="rId15"/>
     <p:sldId id="265" r:id="rId16"/>
+    <p:sldId id="266" r:id="rId17"/>
   </p:sldIdLst>
   <p:sldSz cx="9144000" cy="6858000" type="screen4x3"/>
   <p:notesSz cx="6858000" cy="9144000"/>
@@ -3105,9 +3106,33 @@
         <p:nvPr/>
       </p:nvGrpSpPr>
       <p:grpSpPr/>
+      <p:pic>
+        <p:nvPicPr>
+          <p:cNvPr id="2" name="Picture 1" descr="zeta_logo_1_20250828_235333_3e1fde11.png"/>
+          <p:cNvPicPr>
+            <a:picLocks noChangeAspect="1"/>
+          </p:cNvPicPr>
+          <p:nvPr/>
+        </p:nvPicPr>
+        <p:blipFill>
+          <a:blip r:embed="rId2"/>
+          <a:stretch>
+            <a:fillRect/>
+          </a:stretch>
+        </p:blipFill>
+        <p:spPr>
+          <a:xfrm>
+            <a:off x="0" y="0"/>
+            <a:ext cx="9144000" cy="6858000"/>
+          </a:xfrm>
+          <a:prstGeom prst="rect">
+            <a:avLst/>
+          </a:prstGeom>
+        </p:spPr>
+      </p:pic>
       <p:cxnSp>
         <p:nvCxnSpPr>
-          <p:cNvPr id="2" name="Connector 1"/>
+          <p:cNvPr id="3" name="Connector 2"/>
           <p:cNvCxnSpPr/>
           <p:nvPr/>
         </p:nvCxnSpPr>
@@ -3142,7 +3167,7 @@
       </p:cxnSp>
       <p:sp>
         <p:nvSpPr>
-          <p:cNvPr id="3" name="TextBox 2"/>
+          <p:cNvPr id="4" name="TextBox 3"/>
           <p:cNvSpPr txBox="1"/>
           <p:nvPr/>
         </p:nvSpPr>
@@ -3268,6 +3293,463 @@
               </a:defRPr>
             </a:pPr>
             <a:r>
+              <a:t>Typography</a:t>
+            </a:r>
+          </a:p>
+        </p:txBody>
+      </p:sp>
+      <p:sp>
+        <p:nvSpPr>
+          <p:cNvPr id="4" name="TextBox 3"/>
+          <p:cNvSpPr txBox="1"/>
+          <p:nvPr/>
+        </p:nvSpPr>
+        <p:spPr>
+          <a:xfrm>
+            <a:off x="1143000" y="1943100"/>
+            <a:ext cx="3429000" cy="742950"/>
+          </a:xfrm>
+          <a:prstGeom prst="rect">
+            <a:avLst/>
+          </a:prstGeom>
+          <a:noFill/>
+        </p:spPr>
+        <p:txBody>
+          <a:bodyPr wrap="none">
+            <a:spAutoFit/>
+          </a:bodyPr>
+          <a:lstStyle/>
+          <a:p>
+            <a:pPr>
+              <a:defRPr sz="2000" b="0">
+                <a:solidFill>
+                  <a:srgbClr val="2E86AB"/>
+                </a:solidFill>
+                <a:latin typeface="Source Sans Pro"/>
+              </a:defRPr>
+            </a:pPr>
+            <a:r>
+              <a:t>Primary Font: Inter</a:t>
+            </a:r>
+          </a:p>
+        </p:txBody>
+      </p:sp>
+      <p:sp>
+        <p:nvSpPr>
+          <p:cNvPr id="5" name="TextBox 4"/>
+          <p:cNvSpPr txBox="1"/>
+          <p:nvPr/>
+        </p:nvSpPr>
+        <p:spPr>
+          <a:xfrm>
+            <a:off x="1143000" y="2686050"/>
+            <a:ext cx="3429000" cy="742950"/>
+          </a:xfrm>
+          <a:prstGeom prst="rect">
+            <a:avLst/>
+          </a:prstGeom>
+          <a:noFill/>
+        </p:spPr>
+        <p:txBody>
+          <a:bodyPr wrap="none">
+            <a:spAutoFit/>
+          </a:bodyPr>
+          <a:lstStyle/>
+          <a:p>
+            <a:pPr>
+              <a:defRPr sz="3200" b="1">
+                <a:solidFill>
+                  <a:srgbClr val="2E86AB"/>
+                </a:solidFill>
+                <a:latin typeface="Inter"/>
+              </a:defRPr>
+            </a:pPr>
+            <a:r>
+              <a:t>H1 Heading</a:t>
+            </a:r>
+          </a:p>
+        </p:txBody>
+      </p:sp>
+      <p:sp>
+        <p:nvSpPr>
+          <p:cNvPr id="6" name="TextBox 5"/>
+          <p:cNvSpPr txBox="1"/>
+          <p:nvPr/>
+        </p:nvSpPr>
+        <p:spPr>
+          <a:xfrm>
+            <a:off x="1143000" y="3429000"/>
+            <a:ext cx="3429000" cy="742950"/>
+          </a:xfrm>
+          <a:prstGeom prst="rect">
+            <a:avLst/>
+          </a:prstGeom>
+          <a:noFill/>
+        </p:spPr>
+        <p:txBody>
+          <a:bodyPr wrap="none">
+            <a:spAutoFit/>
+          </a:bodyPr>
+          <a:lstStyle/>
+          <a:p>
+            <a:pPr>
+              <a:defRPr sz="2400" b="1">
+                <a:solidFill>
+                  <a:srgbClr val="2E86AB"/>
+                </a:solidFill>
+                <a:latin typeface="Inter"/>
+              </a:defRPr>
+            </a:pPr>
+            <a:r>
+              <a:t>H2 Heading</a:t>
+            </a:r>
+          </a:p>
+        </p:txBody>
+      </p:sp>
+      <p:sp>
+        <p:nvSpPr>
+          <p:cNvPr id="7" name="TextBox 6"/>
+          <p:cNvSpPr txBox="1"/>
+          <p:nvPr/>
+        </p:nvSpPr>
+        <p:spPr>
+          <a:xfrm>
+            <a:off x="1143000" y="4171950"/>
+            <a:ext cx="3429000" cy="742950"/>
+          </a:xfrm>
+          <a:prstGeom prst="rect">
+            <a:avLst/>
+          </a:prstGeom>
+          <a:noFill/>
+        </p:spPr>
+        <p:txBody>
+          <a:bodyPr wrap="none">
+            <a:spAutoFit/>
+          </a:bodyPr>
+          <a:lstStyle/>
+          <a:p>
+            <a:pPr>
+              <a:defRPr sz="2000" b="0">
+                <a:solidFill>
+                  <a:srgbClr val="2E86AB"/>
+                </a:solidFill>
+                <a:latin typeface="Inter"/>
+              </a:defRPr>
+            </a:pPr>
+            <a:r>
+              <a:t>H3 Heading</a:t>
+            </a:r>
+          </a:p>
+        </p:txBody>
+      </p:sp>
+      <p:sp>
+        <p:nvSpPr>
+          <p:cNvPr id="8" name="TextBox 7"/>
+          <p:cNvSpPr txBox="1"/>
+          <p:nvPr/>
+        </p:nvSpPr>
+        <p:spPr>
+          <a:xfrm>
+            <a:off x="5257800" y="1943100"/>
+            <a:ext cx="3429000" cy="742950"/>
+          </a:xfrm>
+          <a:prstGeom prst="rect">
+            <a:avLst/>
+          </a:prstGeom>
+          <a:noFill/>
+        </p:spPr>
+        <p:txBody>
+          <a:bodyPr wrap="none">
+            <a:spAutoFit/>
+          </a:bodyPr>
+          <a:lstStyle/>
+          <a:p>
+            <a:pPr>
+              <a:defRPr sz="2000" b="0">
+                <a:solidFill>
+                  <a:srgbClr val="2E86AB"/>
+                </a:solidFill>
+                <a:latin typeface="Source Sans Pro"/>
+              </a:defRPr>
+            </a:pPr>
+            <a:r>
+              <a:t>Secondary Font: Source Sans Pro</a:t>
+            </a:r>
+          </a:p>
+        </p:txBody>
+      </p:sp>
+      <p:sp>
+        <p:nvSpPr>
+          <p:cNvPr id="9" name="TextBox 8"/>
+          <p:cNvSpPr txBox="1"/>
+          <p:nvPr/>
+        </p:nvSpPr>
+        <p:spPr>
+          <a:xfrm>
+            <a:off x="5257800" y="2686050"/>
+            <a:ext cx="3429000" cy="742950"/>
+          </a:xfrm>
+          <a:prstGeom prst="rect">
+            <a:avLst/>
+          </a:prstGeom>
+          <a:noFill/>
+        </p:spPr>
+        <p:txBody>
+          <a:bodyPr wrap="none">
+            <a:spAutoFit/>
+          </a:bodyPr>
+          <a:lstStyle/>
+          <a:p>
+            <a:pPr>
+              <a:defRPr sz="1600" b="0">
+                <a:solidFill>
+                  <a:srgbClr val="2E86AB"/>
+                </a:solidFill>
+                <a:latin typeface="Source Sans Pro"/>
+              </a:defRPr>
+            </a:pPr>
+            <a:r>
+              <a:t>Body Text</a:t>
+            </a:r>
+          </a:p>
+        </p:txBody>
+      </p:sp>
+      <p:sp>
+        <p:nvSpPr>
+          <p:cNvPr id="10" name="TextBox 9"/>
+          <p:cNvSpPr txBox="1"/>
+          <p:nvPr/>
+        </p:nvSpPr>
+        <p:spPr>
+          <a:xfrm>
+            <a:off x="5257800" y="3429000"/>
+            <a:ext cx="3429000" cy="742950"/>
+          </a:xfrm>
+          <a:prstGeom prst="rect">
+            <a:avLst/>
+          </a:prstGeom>
+          <a:noFill/>
+        </p:spPr>
+        <p:txBody>
+          <a:bodyPr wrap="none">
+            <a:spAutoFit/>
+          </a:bodyPr>
+          <a:lstStyle/>
+          <a:p>
+            <a:pPr>
+              <a:defRPr sz="1600" b="1">
+                <a:solidFill>
+                  <a:srgbClr val="2E86AB"/>
+                </a:solidFill>
+                <a:latin typeface="Source Sans Pro"/>
+              </a:defRPr>
+            </a:pPr>
+            <a:r>
+              <a:t>Body Bold</a:t>
+            </a:r>
+          </a:p>
+        </p:txBody>
+      </p:sp>
+      <p:sp>
+        <p:nvSpPr>
+          <p:cNvPr id="11" name="TextBox 10"/>
+          <p:cNvSpPr txBox="1"/>
+          <p:nvPr/>
+        </p:nvSpPr>
+        <p:spPr>
+          <a:xfrm>
+            <a:off x="5257800" y="4171950"/>
+            <a:ext cx="3429000" cy="742950"/>
+          </a:xfrm>
+          <a:prstGeom prst="rect">
+            <a:avLst/>
+          </a:prstGeom>
+          <a:noFill/>
+        </p:spPr>
+        <p:txBody>
+          <a:bodyPr wrap="none">
+            <a:spAutoFit/>
+          </a:bodyPr>
+          <a:lstStyle/>
+          <a:p>
+            <a:pPr>
+              <a:defRPr sz="1200" b="0">
+                <a:solidFill>
+                  <a:srgbClr val="2E86AB"/>
+                </a:solidFill>
+                <a:latin typeface="Source Sans Pro"/>
+              </a:defRPr>
+            </a:pPr>
+            <a:r>
+              <a:t>Caption Text</a:t>
+            </a:r>
+          </a:p>
+        </p:txBody>
+      </p:sp>
+      <p:sp>
+        <p:nvSpPr>
+          <p:cNvPr id="12" name="TextBox 11"/>
+          <p:cNvSpPr txBox="1"/>
+          <p:nvPr/>
+        </p:nvSpPr>
+        <p:spPr>
+          <a:xfrm>
+            <a:off x="457200" y="5657850"/>
+            <a:ext cx="4114800" cy="742950"/>
+          </a:xfrm>
+          <a:prstGeom prst="rect">
+            <a:avLst/>
+          </a:prstGeom>
+          <a:noFill/>
+        </p:spPr>
+        <p:txBody>
+          <a:bodyPr wrap="none">
+            <a:spAutoFit/>
+          </a:bodyPr>
+          <a:lstStyle/>
+          <a:p>
+            <a:pPr algn="l">
+              <a:defRPr sz="1000" b="0">
+                <a:solidFill>
+                  <a:srgbClr val="2E86AB"/>
+                </a:solidFill>
+                <a:latin typeface="Source Sans Pro"/>
+              </a:defRPr>
+            </a:pPr>
+            <a:r>
+              <a:t>TechForward Live</a:t>
+            </a:r>
+          </a:p>
+        </p:txBody>
+      </p:sp>
+      <p:sp>
+        <p:nvSpPr>
+          <p:cNvPr id="13" name="TextBox 12"/>
+          <p:cNvSpPr txBox="1"/>
+          <p:nvPr/>
+        </p:nvSpPr>
+        <p:spPr>
+          <a:xfrm>
+            <a:off x="4572000" y="5657850"/>
+            <a:ext cx="4114800" cy="742950"/>
+          </a:xfrm>
+          <a:prstGeom prst="rect">
+            <a:avLst/>
+          </a:prstGeom>
+          <a:noFill/>
+        </p:spPr>
+        <p:txBody>
+          <a:bodyPr wrap="none">
+            <a:spAutoFit/>
+          </a:bodyPr>
+          <a:lstStyle/>
+          <a:p>
+            <a:pPr algn="r">
+              <a:defRPr sz="1000" b="0">
+                <a:solidFill>
+                  <a:srgbClr val="2E86AB"/>
+                </a:solidFill>
+                <a:latin typeface="Source Sans Pro"/>
+              </a:defRPr>
+            </a:pPr>
+            <a:r>
+              <a:t>10</a:t>
+            </a:r>
+          </a:p>
+        </p:txBody>
+      </p:sp>
+    </p:spTree>
+  </p:cSld>
+  <p:clrMapOvr>
+    <a:masterClrMapping/>
+  </p:clrMapOvr>
+</p:sld>
+</file>
+
+<file path=ppt/slides/slide11.xml><?xml version="1.0" encoding="utf-8"?>
+<p:sld xmlns:a="http://schemas.openxmlformats.org/drawingml/2006/main" xmlns:p="http://schemas.openxmlformats.org/presentationml/2006/main" xmlns:r="http://schemas.openxmlformats.org/officeDocument/2006/relationships">
+  <p:cSld>
+    <p:spTree>
+      <p:nvGrpSpPr>
+        <p:cNvPr id="1" name=""/>
+        <p:cNvGrpSpPr/>
+        <p:nvPr/>
+      </p:nvGrpSpPr>
+      <p:sp>
+        <p:nvSpPr>
+          <p:cNvPr id="2" name="Rectangle 1"/>
+          <p:cNvSpPr/>
+          <p:nvPr/>
+        </p:nvSpPr>
+        <p:spPr>
+          <a:xfrm>
+            <a:off x="0" y="0"/>
+            <a:ext cx="9144000" cy="6858000"/>
+          </a:xfrm>
+          <a:prstGeom prst="rect">
+            <a:avLst/>
+          </a:prstGeom>
+          <a:solidFill>
+            <a:srgbClr val="1A1A1A"/>
+          </a:solidFill>
+          <a:ln>
+            <a:noFill/>
+          </a:ln>
+        </p:spPr>
+        <p:style>
+          <a:lnRef idx="1">
+            <a:schemeClr val="accent1"/>
+          </a:lnRef>
+          <a:fillRef idx="3">
+            <a:schemeClr val="accent1"/>
+          </a:fillRef>
+          <a:effectRef idx="2">
+            <a:schemeClr val="accent1"/>
+          </a:effectRef>
+          <a:fontRef idx="minor">
+            <a:schemeClr val="lt1"/>
+          </a:fontRef>
+        </p:style>
+        <p:txBody>
+          <a:bodyPr rtlCol="0" anchor="ctr"/>
+          <a:lstStyle/>
+          <a:p>
+            <a:pPr algn="ctr"/>
+          </a:p>
+        </p:txBody>
+      </p:sp>
+      <p:grpSpPr/>
+      <p:sp>
+        <p:nvSpPr>
+          <p:cNvPr id="3" name="TextBox 2"/>
+          <p:cNvSpPr txBox="1"/>
+          <p:nvPr/>
+        </p:nvSpPr>
+        <p:spPr>
+          <a:xfrm>
+            <a:off x="1143000" y="457200"/>
+            <a:ext cx="6858000" cy="742950"/>
+          </a:xfrm>
+          <a:prstGeom prst="rect">
+            <a:avLst/>
+          </a:prstGeom>
+          <a:noFill/>
+        </p:spPr>
+        <p:txBody>
+          <a:bodyPr wrap="none">
+            <a:spAutoFit/>
+          </a:bodyPr>
+          <a:lstStyle/>
+          <a:p>
+            <a:pPr>
+              <a:defRPr sz="3200" b="1">
+                <a:solidFill>
+                  <a:srgbClr val="2E86AB"/>
+                </a:solidFill>
+                <a:latin typeface="Inter"/>
+              </a:defRPr>
+            </a:pPr>
+            <a:r>
               <a:t>Visual &amp; Photography Guidelines</a:t>
             </a:r>
           </a:p>
@@ -3759,7 +4241,7 @@
               </a:defRPr>
             </a:pPr>
             <a:r>
-              <a:t>10</a:t>
+              <a:t>11</a:t>
             </a:r>
           </a:p>
         </p:txBody>
@@ -5788,117 +6270,8 @@
               </a:defRPr>
             </a:pPr>
             <a:r>
-              <a:t>Core Values:</a:t>
-            </a:r>
-          </a:p>
-          <a:p>
-            <a:pPr algn="l">
-              <a:spcAft>
-                <a:spcPts val="800"/>
-              </a:spcAft>
-              <a:defRPr sz="2000" b="0">
-                <a:solidFill>
-                  <a:srgbClr val="FFFFFF"/>
-                </a:solidFill>
-                <a:latin typeface="Source Sans Pro"/>
-              </a:defRPr>
-            </a:pPr>
-            <a:r>
-              <a:t>• Innovation: Driving progress through creative thinking and breakthrough solutions</a:t>
-            </a:r>
-          </a:p>
-          <a:p>
-            <a:pPr algn="l">
-              <a:spcAft>
-                <a:spcPts val="800"/>
-              </a:spcAft>
-              <a:defRPr sz="2000" b="0">
-                <a:solidFill>
-                  <a:srgbClr val="FFFFFF"/>
-                </a:solidFill>
-                <a:latin typeface="Source Sans Pro"/>
-              </a:defRPr>
-            </a:pPr>
-            <a:r>
-              <a:t>• Simplicity: Embodying simplicity in all aspects of our business operations</a:t>
-            </a:r>
-          </a:p>
-          <a:p>
-            <a:pPr algn="l">
-              <a:spcAft>
-                <a:spcPts val="800"/>
-              </a:spcAft>
-              <a:defRPr sz="2000" b="0">
-                <a:solidFill>
-                  <a:srgbClr val="FFFFFF"/>
-                </a:solidFill>
-                <a:latin typeface="Source Sans Pro"/>
-              </a:defRPr>
-            </a:pPr>
-            <a:r>
-              <a:t>• Human-Centered: Embodying human-centered in all aspects of our business operations</a:t>
-            </a:r>
-          </a:p>
-          <a:p>
-            <a:pPr algn="l">
-              <a:spcAft>
-                <a:spcPts val="800"/>
-              </a:spcAft>
-              <a:defRPr sz="2000" b="0">
-                <a:solidFill>
-                  <a:srgbClr val="FFFFFF"/>
-                </a:solidFill>
-                <a:latin typeface="Source Sans Pro"/>
-              </a:defRPr>
-            </a:pPr>
-            <a:r>
-              <a:t>• Excellence: Pursuing the highest standards in everything we deliver</a:t>
-            </a:r>
-          </a:p>
-          <a:p>
-            <a:pPr algn="l">
-              <a:spcAft>
-                <a:spcPts val="800"/>
-              </a:spcAft>
-              <a:defRPr sz="2000" b="0">
-                <a:solidFill>
-                  <a:srgbClr val="FFFFFF"/>
-                </a:solidFill>
-                <a:latin typeface="Source Sans Pro"/>
-              </a:defRPr>
-            </a:pPr>
-            <a:r>
-              <a:t>• Trust: Building lasting relationships through transparency and consistent delivery</a:t>
-            </a:r>
-          </a:p>
-          <a:p>
-            <a:pPr algn="l">
-              <a:spcAft>
-                <a:spcPts val="800"/>
-              </a:spcAft>
-              <a:defRPr sz="2000" b="0">
-                <a:solidFill>
-                  <a:srgbClr val="FFFFFF"/>
-                </a:solidFill>
-                <a:latin typeface="Source Sans Pro"/>
-              </a:defRPr>
-            </a:pPr>
-            <a:r>
-              <a:t>• Reliability: Ensuring dependable performance and unwavering support in all our services</a:t>
-            </a:r>
-          </a:p>
-          <a:p>
-            <a:pPr algn="l">
-              <a:spcAft>
-                <a:spcPts val="800"/>
-              </a:spcAft>
-              <a:defRPr sz="2000" b="0">
-                <a:solidFill>
-                  <a:srgbClr val="FFFFFF"/>
-                </a:solidFill>
-                <a:latin typeface="Source Sans Pro"/>
-              </a:defRPr>
-            </a:pPr>
+              <a:t>Core Values: Our foundation rests on innovation, simplicity, human-centered, excellence, trust, and reliability, which together guide our commitment to excellence and drive our mission to create meaningful impact for our clients.</a:t>
+            </a:r>
           </a:p>
         </p:txBody>
       </p:sp>
@@ -6201,7 +6574,7 @@
               </a:defRPr>
             </a:pPr>
             <a:r>
-              <a:t>Color Palette</a:t>
+              <a:t>Logo Variations (3 designs)</a:t>
             </a:r>
           </a:p>
         </p:txBody>
@@ -6214,19 +6587,17 @@
         </p:nvSpPr>
         <p:spPr>
           <a:xfrm>
-            <a:off x="1143000" y="1943100"/>
-            <a:ext cx="2057400" cy="1485900"/>
+            <a:off x="1051560" y="1851660"/>
+            <a:ext cx="1554480" cy="1668780"/>
           </a:xfrm>
           <a:prstGeom prst="rect">
             <a:avLst/>
           </a:prstGeom>
           <a:solidFill>
-            <a:srgbClr val="2E86AB"/>
+            <a:srgbClr val="FFFFFF"/>
           </a:solidFill>
-          <a:ln w="12700">
-            <a:solidFill>
-              <a:srgbClr val="FFFFFF"/>
-            </a:solidFill>
+          <a:ln>
+            <a:noFill/>
           </a:ln>
         </p:spPr>
         <p:style>
@@ -6251,16 +6622,40 @@
           </a:p>
         </p:txBody>
       </p:sp>
-      <p:sp>
-        <p:nvSpPr>
-          <p:cNvPr id="5" name="TextBox 4"/>
+      <p:pic>
+        <p:nvPicPr>
+          <p:cNvPr id="5" name="Picture 4" descr="zeta_logo_1_20250828_235333_3e1fde11.png"/>
+          <p:cNvPicPr>
+            <a:picLocks noChangeAspect="1"/>
+          </p:cNvPicPr>
+          <p:nvPr/>
+        </p:nvPicPr>
+        <p:blipFill>
+          <a:blip r:embed="rId2"/>
+          <a:stretch>
+            <a:fillRect/>
+          </a:stretch>
+        </p:blipFill>
+        <p:spPr>
+          <a:xfrm>
+            <a:off x="1143000" y="1943100"/>
+            <a:ext cx="1371600" cy="1485900"/>
+          </a:xfrm>
+          <a:prstGeom prst="rect">
+            <a:avLst/>
+          </a:prstGeom>
+        </p:spPr>
+      </p:pic>
+      <p:sp>
+        <p:nvSpPr>
+          <p:cNvPr id="6" name="TextBox 5"/>
           <p:cNvSpPr txBox="1"/>
           <p:nvPr/>
         </p:nvSpPr>
         <p:spPr>
           <a:xfrm>
             <a:off x="1143000" y="3429000"/>
-            <a:ext cx="2057400" cy="1485900"/>
+            <a:ext cx="1371600" cy="742950"/>
           </a:xfrm>
           <a:prstGeom prst="rect">
             <a:avLst/>
@@ -6268,13 +6663,13 @@
           <a:noFill/>
         </p:spPr>
         <p:txBody>
-          <a:bodyPr wrap="square">
+          <a:bodyPr wrap="none">
             <a:spAutoFit/>
           </a:bodyPr>
           <a:lstStyle/>
           <a:p>
-            <a:pPr>
-              <a:defRPr sz="1000" b="0">
+            <a:pPr algn="ctr">
+              <a:defRPr sz="1200" b="0">
                 <a:solidFill>
                   <a:srgbClr val="2E86AB"/>
                 </a:solidFill>
@@ -6282,84 +6677,30 @@
               </a:defRPr>
             </a:pPr>
             <a:r>
-              <a:t>Primary</a:t>
-            </a:r>
-          </a:p>
-          <a:p>
-            <a:pPr>
-              <a:defRPr sz="1000" b="0">
-                <a:solidFill>
-                  <a:srgbClr val="2E86AB"/>
-                </a:solidFill>
-                <a:latin typeface="Source Sans Pro"/>
-              </a:defRPr>
-            </a:pPr>
-            <a:r>
-              <a:t>#2E86AB</a:t>
-            </a:r>
-          </a:p>
-          <a:p>
-            <a:pPr>
-              <a:defRPr sz="1000" b="0">
-                <a:solidFill>
-                  <a:srgbClr val="2E86AB"/>
-                </a:solidFill>
-                <a:latin typeface="Source Sans Pro"/>
-              </a:defRPr>
-            </a:pPr>
-            <a:r>
-              <a:t>RGB(46, 134, 171)</a:t>
-            </a:r>
-          </a:p>
-          <a:p>
-            <a:pPr>
-              <a:defRPr sz="1000" b="0">
-                <a:solidFill>
-                  <a:srgbClr val="2E86AB"/>
-                </a:solidFill>
-                <a:latin typeface="Source Sans Pro"/>
-              </a:defRPr>
-            </a:pPr>
-            <a:r>
-              <a:t>CMYK(73, 21, 0, 32)</a:t>
-            </a:r>
-          </a:p>
-          <a:p>
-            <a:pPr>
-              <a:defRPr sz="1000" b="0">
-                <a:solidFill>
-                  <a:srgbClr val="2E86AB"/>
-                </a:solidFill>
-                <a:latin typeface="Source Sans Pro"/>
-              </a:defRPr>
-            </a:pPr>
-            <a:r>
-              <a:t>Use Light Text</a:t>
-            </a:r>
-          </a:p>
-        </p:txBody>
-      </p:sp>
-      <p:sp>
-        <p:nvSpPr>
-          <p:cNvPr id="6" name="Rectangle 5"/>
+              <a:t>Version 1</a:t>
+            </a:r>
+          </a:p>
+        </p:txBody>
+      </p:sp>
+      <p:sp>
+        <p:nvSpPr>
+          <p:cNvPr id="7" name="Rectangle 6"/>
           <p:cNvSpPr/>
           <p:nvPr/>
         </p:nvSpPr>
         <p:spPr>
           <a:xfrm>
-            <a:off x="3886200" y="1943100"/>
-            <a:ext cx="2057400" cy="1485900"/>
+            <a:off x="3108960" y="1851660"/>
+            <a:ext cx="1554480" cy="1668780"/>
           </a:xfrm>
           <a:prstGeom prst="rect">
             <a:avLst/>
           </a:prstGeom>
           <a:solidFill>
-            <a:srgbClr val="A23B72"/>
+            <a:srgbClr val="FFFFFF"/>
           </a:solidFill>
-          <a:ln w="12700">
-            <a:solidFill>
-              <a:srgbClr val="FFFFFF"/>
-            </a:solidFill>
+          <a:ln>
+            <a:noFill/>
           </a:ln>
         </p:spPr>
         <p:style>
@@ -6384,16 +6725,40 @@
           </a:p>
         </p:txBody>
       </p:sp>
-      <p:sp>
-        <p:nvSpPr>
-          <p:cNvPr id="7" name="TextBox 6"/>
+      <p:pic>
+        <p:nvPicPr>
+          <p:cNvPr id="8" name="Picture 7" descr="zeta_logo_2_20250828_235352_a3259202.png"/>
+          <p:cNvPicPr>
+            <a:picLocks noChangeAspect="1"/>
+          </p:cNvPicPr>
+          <p:nvPr/>
+        </p:nvPicPr>
+        <p:blipFill>
+          <a:blip r:embed="rId3"/>
+          <a:stretch>
+            <a:fillRect/>
+          </a:stretch>
+        </p:blipFill>
+        <p:spPr>
+          <a:xfrm>
+            <a:off x="3200400" y="1943100"/>
+            <a:ext cx="1371600" cy="1485900"/>
+          </a:xfrm>
+          <a:prstGeom prst="rect">
+            <a:avLst/>
+          </a:prstGeom>
+        </p:spPr>
+      </p:pic>
+      <p:sp>
+        <p:nvSpPr>
+          <p:cNvPr id="9" name="TextBox 8"/>
           <p:cNvSpPr txBox="1"/>
           <p:nvPr/>
         </p:nvSpPr>
         <p:spPr>
           <a:xfrm>
-            <a:off x="3886200" y="3429000"/>
-            <a:ext cx="2057400" cy="1485900"/>
+            <a:off x="3200400" y="3429000"/>
+            <a:ext cx="1371600" cy="742950"/>
           </a:xfrm>
           <a:prstGeom prst="rect">
             <a:avLst/>
@@ -6401,13 +6766,13 @@
           <a:noFill/>
         </p:spPr>
         <p:txBody>
-          <a:bodyPr wrap="square">
+          <a:bodyPr wrap="none">
             <a:spAutoFit/>
           </a:bodyPr>
           <a:lstStyle/>
           <a:p>
-            <a:pPr>
-              <a:defRPr sz="1000" b="0">
+            <a:pPr algn="ctr">
+              <a:defRPr sz="1200" b="0">
                 <a:solidFill>
                   <a:srgbClr val="2E86AB"/>
                 </a:solidFill>
@@ -6415,84 +6780,30 @@
               </a:defRPr>
             </a:pPr>
             <a:r>
-              <a:t>Secondary</a:t>
-            </a:r>
-          </a:p>
-          <a:p>
-            <a:pPr>
-              <a:defRPr sz="1000" b="0">
-                <a:solidFill>
-                  <a:srgbClr val="2E86AB"/>
-                </a:solidFill>
-                <a:latin typeface="Source Sans Pro"/>
-              </a:defRPr>
-            </a:pPr>
-            <a:r>
-              <a:t>#A23B72</a:t>
-            </a:r>
-          </a:p>
-          <a:p>
-            <a:pPr>
-              <a:defRPr sz="1000" b="0">
-                <a:solidFill>
-                  <a:srgbClr val="2E86AB"/>
-                </a:solidFill>
-                <a:latin typeface="Source Sans Pro"/>
-              </a:defRPr>
-            </a:pPr>
-            <a:r>
-              <a:t>RGB(162, 59, 114)</a:t>
-            </a:r>
-          </a:p>
-          <a:p>
-            <a:pPr>
-              <a:defRPr sz="1000" b="0">
-                <a:solidFill>
-                  <a:srgbClr val="2E86AB"/>
-                </a:solidFill>
-                <a:latin typeface="Source Sans Pro"/>
-              </a:defRPr>
-            </a:pPr>
-            <a:r>
-              <a:t>CMYK(0, 63, 29, 36)</a:t>
-            </a:r>
-          </a:p>
-          <a:p>
-            <a:pPr>
-              <a:defRPr sz="1000" b="0">
-                <a:solidFill>
-                  <a:srgbClr val="2E86AB"/>
-                </a:solidFill>
-                <a:latin typeface="Source Sans Pro"/>
-              </a:defRPr>
-            </a:pPr>
-            <a:r>
-              <a:t>Use Light Text</a:t>
-            </a:r>
-          </a:p>
-        </p:txBody>
-      </p:sp>
-      <p:sp>
-        <p:nvSpPr>
-          <p:cNvPr id="8" name="Rectangle 7"/>
+              <a:t>Version 2</a:t>
+            </a:r>
+          </a:p>
+        </p:txBody>
+      </p:sp>
+      <p:sp>
+        <p:nvSpPr>
+          <p:cNvPr id="10" name="Rectangle 9"/>
           <p:cNvSpPr/>
           <p:nvPr/>
         </p:nvSpPr>
         <p:spPr>
           <a:xfrm>
-            <a:off x="6629400" y="1943100"/>
-            <a:ext cx="2057400" cy="1485900"/>
+            <a:off x="5166360" y="1851660"/>
+            <a:ext cx="1554480" cy="1668780"/>
           </a:xfrm>
           <a:prstGeom prst="rect">
             <a:avLst/>
           </a:prstGeom>
           <a:solidFill>
-            <a:srgbClr val="F18F01"/>
+            <a:srgbClr val="FFFFFF"/>
           </a:solidFill>
-          <a:ln w="12700">
-            <a:solidFill>
-              <a:srgbClr val="FFFFFF"/>
-            </a:solidFill>
+          <a:ln>
+            <a:noFill/>
           </a:ln>
         </p:spPr>
         <p:style>
@@ -6517,104 +6828,40 @@
           </a:p>
         </p:txBody>
       </p:sp>
-      <p:sp>
-        <p:nvSpPr>
-          <p:cNvPr id="9" name="TextBox 8"/>
+      <p:pic>
+        <p:nvPicPr>
+          <p:cNvPr id="11" name="Picture 10" descr="zeta_logo_3_20250828_235415_054bae29.png"/>
+          <p:cNvPicPr>
+            <a:picLocks noChangeAspect="1"/>
+          </p:cNvPicPr>
+          <p:nvPr/>
+        </p:nvPicPr>
+        <p:blipFill>
+          <a:blip r:embed="rId4"/>
+          <a:stretch>
+            <a:fillRect/>
+          </a:stretch>
+        </p:blipFill>
+        <p:spPr>
+          <a:xfrm>
+            <a:off x="5257800" y="1943100"/>
+            <a:ext cx="1371600" cy="1485900"/>
+          </a:xfrm>
+          <a:prstGeom prst="rect">
+            <a:avLst/>
+          </a:prstGeom>
+        </p:spPr>
+      </p:pic>
+      <p:sp>
+        <p:nvSpPr>
+          <p:cNvPr id="12" name="TextBox 11"/>
           <p:cNvSpPr txBox="1"/>
           <p:nvPr/>
         </p:nvSpPr>
         <p:spPr>
           <a:xfrm>
-            <a:off x="6629400" y="3429000"/>
-            <a:ext cx="2057400" cy="1485900"/>
-          </a:xfrm>
-          <a:prstGeom prst="rect">
-            <a:avLst/>
-          </a:prstGeom>
-          <a:noFill/>
-        </p:spPr>
-        <p:txBody>
-          <a:bodyPr wrap="square">
-            <a:spAutoFit/>
-          </a:bodyPr>
-          <a:lstStyle/>
-          <a:p>
-            <a:pPr>
-              <a:defRPr sz="1000" b="0">
-                <a:solidFill>
-                  <a:srgbClr val="2E86AB"/>
-                </a:solidFill>
-                <a:latin typeface="Source Sans Pro"/>
-              </a:defRPr>
-            </a:pPr>
-            <a:r>
-              <a:t>Accent</a:t>
-            </a:r>
-          </a:p>
-          <a:p>
-            <a:pPr>
-              <a:defRPr sz="1000" b="0">
-                <a:solidFill>
-                  <a:srgbClr val="2E86AB"/>
-                </a:solidFill>
-                <a:latin typeface="Source Sans Pro"/>
-              </a:defRPr>
-            </a:pPr>
-            <a:r>
-              <a:t>#F18F01</a:t>
-            </a:r>
-          </a:p>
-          <a:p>
-            <a:pPr>
-              <a:defRPr sz="1000" b="0">
-                <a:solidFill>
-                  <a:srgbClr val="2E86AB"/>
-                </a:solidFill>
-                <a:latin typeface="Source Sans Pro"/>
-              </a:defRPr>
-            </a:pPr>
-            <a:r>
-              <a:t>RGB(241, 143, 1)</a:t>
-            </a:r>
-          </a:p>
-          <a:p>
-            <a:pPr>
-              <a:defRPr sz="1000" b="0">
-                <a:solidFill>
-                  <a:srgbClr val="2E86AB"/>
-                </a:solidFill>
-                <a:latin typeface="Source Sans Pro"/>
-              </a:defRPr>
-            </a:pPr>
-            <a:r>
-              <a:t>CMYK(0, 40, 99, 5)</a:t>
-            </a:r>
-          </a:p>
-          <a:p>
-            <a:pPr>
-              <a:defRPr sz="1000" b="0">
-                <a:solidFill>
-                  <a:srgbClr val="2E86AB"/>
-                </a:solidFill>
-                <a:latin typeface="Source Sans Pro"/>
-              </a:defRPr>
-            </a:pPr>
-            <a:r>
-              <a:t>Use Dark Text</a:t>
-            </a:r>
-          </a:p>
-        </p:txBody>
-      </p:sp>
-      <p:sp>
-        <p:nvSpPr>
-          <p:cNvPr id="10" name="TextBox 9"/>
-          <p:cNvSpPr txBox="1"/>
-          <p:nvPr/>
-        </p:nvSpPr>
-        <p:spPr>
-          <a:xfrm>
-            <a:off x="457200" y="5657850"/>
-            <a:ext cx="4114800" cy="742950"/>
+            <a:off x="5257800" y="3429000"/>
+            <a:ext cx="1371600" cy="742950"/>
           </a:xfrm>
           <a:prstGeom prst="rect">
             <a:avLst/>
@@ -6627,6 +6874,78 @@
           </a:bodyPr>
           <a:lstStyle/>
           <a:p>
+            <a:pPr algn="ctr">
+              <a:defRPr sz="1200" b="0">
+                <a:solidFill>
+                  <a:srgbClr val="2E86AB"/>
+                </a:solidFill>
+                <a:latin typeface="Source Sans Pro"/>
+              </a:defRPr>
+            </a:pPr>
+            <a:r>
+              <a:t>Version 3</a:t>
+            </a:r>
+          </a:p>
+        </p:txBody>
+      </p:sp>
+      <p:sp>
+        <p:nvSpPr>
+          <p:cNvPr id="13" name="TextBox 12"/>
+          <p:cNvSpPr txBox="1"/>
+          <p:nvPr/>
+        </p:nvSpPr>
+        <p:spPr>
+          <a:xfrm>
+            <a:off x="1143000" y="4914900"/>
+            <a:ext cx="7543800" cy="742950"/>
+          </a:xfrm>
+          <a:prstGeom prst="rect">
+            <a:avLst/>
+          </a:prstGeom>
+          <a:noFill/>
+        </p:spPr>
+        <p:txBody>
+          <a:bodyPr wrap="none">
+            <a:spAutoFit/>
+          </a:bodyPr>
+          <a:lstStyle/>
+          <a:p>
+            <a:pPr algn="ctr">
+              <a:defRPr sz="1200" b="0">
+                <a:solidFill>
+                  <a:srgbClr val="2E86AB"/>
+                </a:solidFill>
+                <a:latin typeface="Source Sans Pro"/>
+              </a:defRPr>
+            </a:pPr>
+            <a:r>
+              <a:t>Minimum size: 0.5 inches • Clearspace: 0.25 inches on all sides</a:t>
+            </a:r>
+          </a:p>
+        </p:txBody>
+      </p:sp>
+      <p:sp>
+        <p:nvSpPr>
+          <p:cNvPr id="14" name="TextBox 13"/>
+          <p:cNvSpPr txBox="1"/>
+          <p:nvPr/>
+        </p:nvSpPr>
+        <p:spPr>
+          <a:xfrm>
+            <a:off x="457200" y="5657850"/>
+            <a:ext cx="4114800" cy="742950"/>
+          </a:xfrm>
+          <a:prstGeom prst="rect">
+            <a:avLst/>
+          </a:prstGeom>
+          <a:noFill/>
+        </p:spPr>
+        <p:txBody>
+          <a:bodyPr wrap="none">
+            <a:spAutoFit/>
+          </a:bodyPr>
+          <a:lstStyle/>
+          <a:p>
             <a:pPr algn="l">
               <a:defRPr sz="1000" b="0">
                 <a:solidFill>
@@ -6643,7 +6962,7 @@
       </p:sp>
       <p:sp>
         <p:nvSpPr>
-          <p:cNvPr id="11" name="TextBox 10"/>
+          <p:cNvPr id="15" name="TextBox 14"/>
           <p:cNvSpPr txBox="1"/>
           <p:nvPr/>
         </p:nvSpPr>
@@ -6769,21 +7088,420 @@
               </a:defRPr>
             </a:pPr>
             <a:r>
-              <a:t>Typography</a:t>
-            </a:r>
-          </a:p>
-        </p:txBody>
-      </p:sp>
-      <p:sp>
-        <p:nvSpPr>
-          <p:cNvPr id="4" name="TextBox 3"/>
+              <a:t>Color Palette</a:t>
+            </a:r>
+          </a:p>
+        </p:txBody>
+      </p:sp>
+      <p:sp>
+        <p:nvSpPr>
+          <p:cNvPr id="4" name="Rectangle 3"/>
+          <p:cNvSpPr/>
+          <p:nvPr/>
+        </p:nvSpPr>
+        <p:spPr>
+          <a:xfrm>
+            <a:off x="1143000" y="1943100"/>
+            <a:ext cx="2057400" cy="1485900"/>
+          </a:xfrm>
+          <a:prstGeom prst="rect">
+            <a:avLst/>
+          </a:prstGeom>
+          <a:solidFill>
+            <a:srgbClr val="2E86AB"/>
+          </a:solidFill>
+          <a:ln w="12700">
+            <a:solidFill>
+              <a:srgbClr val="FFFFFF"/>
+            </a:solidFill>
+          </a:ln>
+        </p:spPr>
+        <p:style>
+          <a:lnRef idx="1">
+            <a:schemeClr val="accent1"/>
+          </a:lnRef>
+          <a:fillRef idx="3">
+            <a:schemeClr val="accent1"/>
+          </a:fillRef>
+          <a:effectRef idx="2">
+            <a:schemeClr val="accent1"/>
+          </a:effectRef>
+          <a:fontRef idx="minor">
+            <a:schemeClr val="lt1"/>
+          </a:fontRef>
+        </p:style>
+        <p:txBody>
+          <a:bodyPr rtlCol="0" anchor="ctr"/>
+          <a:lstStyle/>
+          <a:p>
+            <a:pPr algn="ctr"/>
+          </a:p>
+        </p:txBody>
+      </p:sp>
+      <p:sp>
+        <p:nvSpPr>
+          <p:cNvPr id="5" name="TextBox 4"/>
           <p:cNvSpPr txBox="1"/>
           <p:nvPr/>
         </p:nvSpPr>
         <p:spPr>
           <a:xfrm>
-            <a:off x="1143000" y="1943100"/>
-            <a:ext cx="3429000" cy="742950"/>
+            <a:off x="1143000" y="3429000"/>
+            <a:ext cx="2057400" cy="1485900"/>
+          </a:xfrm>
+          <a:prstGeom prst="rect">
+            <a:avLst/>
+          </a:prstGeom>
+          <a:noFill/>
+        </p:spPr>
+        <p:txBody>
+          <a:bodyPr wrap="square">
+            <a:spAutoFit/>
+          </a:bodyPr>
+          <a:lstStyle/>
+          <a:p>
+            <a:pPr>
+              <a:defRPr sz="1000" b="0">
+                <a:solidFill>
+                  <a:srgbClr val="2E86AB"/>
+                </a:solidFill>
+                <a:latin typeface="Source Sans Pro"/>
+              </a:defRPr>
+            </a:pPr>
+            <a:r>
+              <a:t>Primary</a:t>
+            </a:r>
+          </a:p>
+          <a:p>
+            <a:pPr>
+              <a:defRPr sz="1000" b="0">
+                <a:solidFill>
+                  <a:srgbClr val="2E86AB"/>
+                </a:solidFill>
+                <a:latin typeface="Source Sans Pro"/>
+              </a:defRPr>
+            </a:pPr>
+            <a:r>
+              <a:t>#2E86AB</a:t>
+            </a:r>
+          </a:p>
+          <a:p>
+            <a:pPr>
+              <a:defRPr sz="1000" b="0">
+                <a:solidFill>
+                  <a:srgbClr val="2E86AB"/>
+                </a:solidFill>
+                <a:latin typeface="Source Sans Pro"/>
+              </a:defRPr>
+            </a:pPr>
+            <a:r>
+              <a:t>RGB(46, 134, 171)</a:t>
+            </a:r>
+          </a:p>
+          <a:p>
+            <a:pPr>
+              <a:defRPr sz="1000" b="0">
+                <a:solidFill>
+                  <a:srgbClr val="2E86AB"/>
+                </a:solidFill>
+                <a:latin typeface="Source Sans Pro"/>
+              </a:defRPr>
+            </a:pPr>
+            <a:r>
+              <a:t>CMYK(73, 21, 0, 32)</a:t>
+            </a:r>
+          </a:p>
+          <a:p>
+            <a:pPr>
+              <a:defRPr sz="1000" b="0">
+                <a:solidFill>
+                  <a:srgbClr val="2E86AB"/>
+                </a:solidFill>
+                <a:latin typeface="Source Sans Pro"/>
+              </a:defRPr>
+            </a:pPr>
+            <a:r>
+              <a:t>Use Light Text</a:t>
+            </a:r>
+          </a:p>
+        </p:txBody>
+      </p:sp>
+      <p:sp>
+        <p:nvSpPr>
+          <p:cNvPr id="6" name="Rectangle 5"/>
+          <p:cNvSpPr/>
+          <p:nvPr/>
+        </p:nvSpPr>
+        <p:spPr>
+          <a:xfrm>
+            <a:off x="3886200" y="1943100"/>
+            <a:ext cx="2057400" cy="1485900"/>
+          </a:xfrm>
+          <a:prstGeom prst="rect">
+            <a:avLst/>
+          </a:prstGeom>
+          <a:solidFill>
+            <a:srgbClr val="A23B72"/>
+          </a:solidFill>
+          <a:ln w="12700">
+            <a:solidFill>
+              <a:srgbClr val="FFFFFF"/>
+            </a:solidFill>
+          </a:ln>
+        </p:spPr>
+        <p:style>
+          <a:lnRef idx="1">
+            <a:schemeClr val="accent1"/>
+          </a:lnRef>
+          <a:fillRef idx="3">
+            <a:schemeClr val="accent1"/>
+          </a:fillRef>
+          <a:effectRef idx="2">
+            <a:schemeClr val="accent1"/>
+          </a:effectRef>
+          <a:fontRef idx="minor">
+            <a:schemeClr val="lt1"/>
+          </a:fontRef>
+        </p:style>
+        <p:txBody>
+          <a:bodyPr rtlCol="0" anchor="ctr"/>
+          <a:lstStyle/>
+          <a:p>
+            <a:pPr algn="ctr"/>
+          </a:p>
+        </p:txBody>
+      </p:sp>
+      <p:sp>
+        <p:nvSpPr>
+          <p:cNvPr id="7" name="TextBox 6"/>
+          <p:cNvSpPr txBox="1"/>
+          <p:nvPr/>
+        </p:nvSpPr>
+        <p:spPr>
+          <a:xfrm>
+            <a:off x="3886200" y="3429000"/>
+            <a:ext cx="2057400" cy="1485900"/>
+          </a:xfrm>
+          <a:prstGeom prst="rect">
+            <a:avLst/>
+          </a:prstGeom>
+          <a:noFill/>
+        </p:spPr>
+        <p:txBody>
+          <a:bodyPr wrap="square">
+            <a:spAutoFit/>
+          </a:bodyPr>
+          <a:lstStyle/>
+          <a:p>
+            <a:pPr>
+              <a:defRPr sz="1000" b="0">
+                <a:solidFill>
+                  <a:srgbClr val="2E86AB"/>
+                </a:solidFill>
+                <a:latin typeface="Source Sans Pro"/>
+              </a:defRPr>
+            </a:pPr>
+            <a:r>
+              <a:t>Secondary</a:t>
+            </a:r>
+          </a:p>
+          <a:p>
+            <a:pPr>
+              <a:defRPr sz="1000" b="0">
+                <a:solidFill>
+                  <a:srgbClr val="2E86AB"/>
+                </a:solidFill>
+                <a:latin typeface="Source Sans Pro"/>
+              </a:defRPr>
+            </a:pPr>
+            <a:r>
+              <a:t>#A23B72</a:t>
+            </a:r>
+          </a:p>
+          <a:p>
+            <a:pPr>
+              <a:defRPr sz="1000" b="0">
+                <a:solidFill>
+                  <a:srgbClr val="2E86AB"/>
+                </a:solidFill>
+                <a:latin typeface="Source Sans Pro"/>
+              </a:defRPr>
+            </a:pPr>
+            <a:r>
+              <a:t>RGB(162, 59, 114)</a:t>
+            </a:r>
+          </a:p>
+          <a:p>
+            <a:pPr>
+              <a:defRPr sz="1000" b="0">
+                <a:solidFill>
+                  <a:srgbClr val="2E86AB"/>
+                </a:solidFill>
+                <a:latin typeface="Source Sans Pro"/>
+              </a:defRPr>
+            </a:pPr>
+            <a:r>
+              <a:t>CMYK(0, 63, 29, 36)</a:t>
+            </a:r>
+          </a:p>
+          <a:p>
+            <a:pPr>
+              <a:defRPr sz="1000" b="0">
+                <a:solidFill>
+                  <a:srgbClr val="2E86AB"/>
+                </a:solidFill>
+                <a:latin typeface="Source Sans Pro"/>
+              </a:defRPr>
+            </a:pPr>
+            <a:r>
+              <a:t>Use Light Text</a:t>
+            </a:r>
+          </a:p>
+        </p:txBody>
+      </p:sp>
+      <p:sp>
+        <p:nvSpPr>
+          <p:cNvPr id="8" name="Rectangle 7"/>
+          <p:cNvSpPr/>
+          <p:nvPr/>
+        </p:nvSpPr>
+        <p:spPr>
+          <a:xfrm>
+            <a:off x="6629400" y="1943100"/>
+            <a:ext cx="2057400" cy="1485900"/>
+          </a:xfrm>
+          <a:prstGeom prst="rect">
+            <a:avLst/>
+          </a:prstGeom>
+          <a:solidFill>
+            <a:srgbClr val="F18F01"/>
+          </a:solidFill>
+          <a:ln w="12700">
+            <a:solidFill>
+              <a:srgbClr val="FFFFFF"/>
+            </a:solidFill>
+          </a:ln>
+        </p:spPr>
+        <p:style>
+          <a:lnRef idx="1">
+            <a:schemeClr val="accent1"/>
+          </a:lnRef>
+          <a:fillRef idx="3">
+            <a:schemeClr val="accent1"/>
+          </a:fillRef>
+          <a:effectRef idx="2">
+            <a:schemeClr val="accent1"/>
+          </a:effectRef>
+          <a:fontRef idx="minor">
+            <a:schemeClr val="lt1"/>
+          </a:fontRef>
+        </p:style>
+        <p:txBody>
+          <a:bodyPr rtlCol="0" anchor="ctr"/>
+          <a:lstStyle/>
+          <a:p>
+            <a:pPr algn="ctr"/>
+          </a:p>
+        </p:txBody>
+      </p:sp>
+      <p:sp>
+        <p:nvSpPr>
+          <p:cNvPr id="9" name="TextBox 8"/>
+          <p:cNvSpPr txBox="1"/>
+          <p:nvPr/>
+        </p:nvSpPr>
+        <p:spPr>
+          <a:xfrm>
+            <a:off x="6629400" y="3429000"/>
+            <a:ext cx="2057400" cy="1485900"/>
+          </a:xfrm>
+          <a:prstGeom prst="rect">
+            <a:avLst/>
+          </a:prstGeom>
+          <a:noFill/>
+        </p:spPr>
+        <p:txBody>
+          <a:bodyPr wrap="square">
+            <a:spAutoFit/>
+          </a:bodyPr>
+          <a:lstStyle/>
+          <a:p>
+            <a:pPr>
+              <a:defRPr sz="1000" b="0">
+                <a:solidFill>
+                  <a:srgbClr val="2E86AB"/>
+                </a:solidFill>
+                <a:latin typeface="Source Sans Pro"/>
+              </a:defRPr>
+            </a:pPr>
+            <a:r>
+              <a:t>Accent</a:t>
+            </a:r>
+          </a:p>
+          <a:p>
+            <a:pPr>
+              <a:defRPr sz="1000" b="0">
+                <a:solidFill>
+                  <a:srgbClr val="2E86AB"/>
+                </a:solidFill>
+                <a:latin typeface="Source Sans Pro"/>
+              </a:defRPr>
+            </a:pPr>
+            <a:r>
+              <a:t>#F18F01</a:t>
+            </a:r>
+          </a:p>
+          <a:p>
+            <a:pPr>
+              <a:defRPr sz="1000" b="0">
+                <a:solidFill>
+                  <a:srgbClr val="2E86AB"/>
+                </a:solidFill>
+                <a:latin typeface="Source Sans Pro"/>
+              </a:defRPr>
+            </a:pPr>
+            <a:r>
+              <a:t>RGB(241, 143, 1)</a:t>
+            </a:r>
+          </a:p>
+          <a:p>
+            <a:pPr>
+              <a:defRPr sz="1000" b="0">
+                <a:solidFill>
+                  <a:srgbClr val="2E86AB"/>
+                </a:solidFill>
+                <a:latin typeface="Source Sans Pro"/>
+              </a:defRPr>
+            </a:pPr>
+            <a:r>
+              <a:t>CMYK(0, 40, 99, 5)</a:t>
+            </a:r>
+          </a:p>
+          <a:p>
+            <a:pPr>
+              <a:defRPr sz="1000" b="0">
+                <a:solidFill>
+                  <a:srgbClr val="2E86AB"/>
+                </a:solidFill>
+                <a:latin typeface="Source Sans Pro"/>
+              </a:defRPr>
+            </a:pPr>
+            <a:r>
+              <a:t>Use Dark Text</a:t>
+            </a:r>
+          </a:p>
+        </p:txBody>
+      </p:sp>
+      <p:sp>
+        <p:nvSpPr>
+          <p:cNvPr id="10" name="TextBox 9"/>
+          <p:cNvSpPr txBox="1"/>
+          <p:nvPr/>
+        </p:nvSpPr>
+        <p:spPr>
+          <a:xfrm>
+            <a:off x="457200" y="5657850"/>
+            <a:ext cx="4114800" cy="742950"/>
           </a:xfrm>
           <a:prstGeom prst="rect">
             <a:avLst/>
@@ -6796,294 +7514,6 @@
           </a:bodyPr>
           <a:lstStyle/>
           <a:p>
-            <a:pPr>
-              <a:defRPr sz="2000" b="0">
-                <a:solidFill>
-                  <a:srgbClr val="2E86AB"/>
-                </a:solidFill>
-                <a:latin typeface="Source Sans Pro"/>
-              </a:defRPr>
-            </a:pPr>
-            <a:r>
-              <a:t>Primary Font: Inter</a:t>
-            </a:r>
-          </a:p>
-        </p:txBody>
-      </p:sp>
-      <p:sp>
-        <p:nvSpPr>
-          <p:cNvPr id="5" name="TextBox 4"/>
-          <p:cNvSpPr txBox="1"/>
-          <p:nvPr/>
-        </p:nvSpPr>
-        <p:spPr>
-          <a:xfrm>
-            <a:off x="1143000" y="2686050"/>
-            <a:ext cx="3429000" cy="742950"/>
-          </a:xfrm>
-          <a:prstGeom prst="rect">
-            <a:avLst/>
-          </a:prstGeom>
-          <a:noFill/>
-        </p:spPr>
-        <p:txBody>
-          <a:bodyPr wrap="none">
-            <a:spAutoFit/>
-          </a:bodyPr>
-          <a:lstStyle/>
-          <a:p>
-            <a:pPr>
-              <a:defRPr sz="3200" b="1">
-                <a:solidFill>
-                  <a:srgbClr val="2E86AB"/>
-                </a:solidFill>
-                <a:latin typeface="Inter"/>
-              </a:defRPr>
-            </a:pPr>
-            <a:r>
-              <a:t>H1 Heading</a:t>
-            </a:r>
-          </a:p>
-        </p:txBody>
-      </p:sp>
-      <p:sp>
-        <p:nvSpPr>
-          <p:cNvPr id="6" name="TextBox 5"/>
-          <p:cNvSpPr txBox="1"/>
-          <p:nvPr/>
-        </p:nvSpPr>
-        <p:spPr>
-          <a:xfrm>
-            <a:off x="1143000" y="3429000"/>
-            <a:ext cx="3429000" cy="742950"/>
-          </a:xfrm>
-          <a:prstGeom prst="rect">
-            <a:avLst/>
-          </a:prstGeom>
-          <a:noFill/>
-        </p:spPr>
-        <p:txBody>
-          <a:bodyPr wrap="none">
-            <a:spAutoFit/>
-          </a:bodyPr>
-          <a:lstStyle/>
-          <a:p>
-            <a:pPr>
-              <a:defRPr sz="2400" b="1">
-                <a:solidFill>
-                  <a:srgbClr val="2E86AB"/>
-                </a:solidFill>
-                <a:latin typeface="Inter"/>
-              </a:defRPr>
-            </a:pPr>
-            <a:r>
-              <a:t>H2 Heading</a:t>
-            </a:r>
-          </a:p>
-        </p:txBody>
-      </p:sp>
-      <p:sp>
-        <p:nvSpPr>
-          <p:cNvPr id="7" name="TextBox 6"/>
-          <p:cNvSpPr txBox="1"/>
-          <p:nvPr/>
-        </p:nvSpPr>
-        <p:spPr>
-          <a:xfrm>
-            <a:off x="1143000" y="4171950"/>
-            <a:ext cx="3429000" cy="742950"/>
-          </a:xfrm>
-          <a:prstGeom prst="rect">
-            <a:avLst/>
-          </a:prstGeom>
-          <a:noFill/>
-        </p:spPr>
-        <p:txBody>
-          <a:bodyPr wrap="none">
-            <a:spAutoFit/>
-          </a:bodyPr>
-          <a:lstStyle/>
-          <a:p>
-            <a:pPr>
-              <a:defRPr sz="2000" b="0">
-                <a:solidFill>
-                  <a:srgbClr val="2E86AB"/>
-                </a:solidFill>
-                <a:latin typeface="Inter"/>
-              </a:defRPr>
-            </a:pPr>
-            <a:r>
-              <a:t>H3 Heading</a:t>
-            </a:r>
-          </a:p>
-        </p:txBody>
-      </p:sp>
-      <p:sp>
-        <p:nvSpPr>
-          <p:cNvPr id="8" name="TextBox 7"/>
-          <p:cNvSpPr txBox="1"/>
-          <p:nvPr/>
-        </p:nvSpPr>
-        <p:spPr>
-          <a:xfrm>
-            <a:off x="5257800" y="1943100"/>
-            <a:ext cx="3429000" cy="742950"/>
-          </a:xfrm>
-          <a:prstGeom prst="rect">
-            <a:avLst/>
-          </a:prstGeom>
-          <a:noFill/>
-        </p:spPr>
-        <p:txBody>
-          <a:bodyPr wrap="none">
-            <a:spAutoFit/>
-          </a:bodyPr>
-          <a:lstStyle/>
-          <a:p>
-            <a:pPr>
-              <a:defRPr sz="2000" b="0">
-                <a:solidFill>
-                  <a:srgbClr val="2E86AB"/>
-                </a:solidFill>
-                <a:latin typeface="Source Sans Pro"/>
-              </a:defRPr>
-            </a:pPr>
-            <a:r>
-              <a:t>Secondary Font: Source Sans Pro</a:t>
-            </a:r>
-          </a:p>
-        </p:txBody>
-      </p:sp>
-      <p:sp>
-        <p:nvSpPr>
-          <p:cNvPr id="9" name="TextBox 8"/>
-          <p:cNvSpPr txBox="1"/>
-          <p:nvPr/>
-        </p:nvSpPr>
-        <p:spPr>
-          <a:xfrm>
-            <a:off x="5257800" y="2686050"/>
-            <a:ext cx="3429000" cy="742950"/>
-          </a:xfrm>
-          <a:prstGeom prst="rect">
-            <a:avLst/>
-          </a:prstGeom>
-          <a:noFill/>
-        </p:spPr>
-        <p:txBody>
-          <a:bodyPr wrap="none">
-            <a:spAutoFit/>
-          </a:bodyPr>
-          <a:lstStyle/>
-          <a:p>
-            <a:pPr>
-              <a:defRPr sz="1600" b="0">
-                <a:solidFill>
-                  <a:srgbClr val="2E86AB"/>
-                </a:solidFill>
-                <a:latin typeface="Source Sans Pro"/>
-              </a:defRPr>
-            </a:pPr>
-            <a:r>
-              <a:t>Body Text</a:t>
-            </a:r>
-          </a:p>
-        </p:txBody>
-      </p:sp>
-      <p:sp>
-        <p:nvSpPr>
-          <p:cNvPr id="10" name="TextBox 9"/>
-          <p:cNvSpPr txBox="1"/>
-          <p:nvPr/>
-        </p:nvSpPr>
-        <p:spPr>
-          <a:xfrm>
-            <a:off x="5257800" y="3429000"/>
-            <a:ext cx="3429000" cy="742950"/>
-          </a:xfrm>
-          <a:prstGeom prst="rect">
-            <a:avLst/>
-          </a:prstGeom>
-          <a:noFill/>
-        </p:spPr>
-        <p:txBody>
-          <a:bodyPr wrap="none">
-            <a:spAutoFit/>
-          </a:bodyPr>
-          <a:lstStyle/>
-          <a:p>
-            <a:pPr>
-              <a:defRPr sz="1600" b="1">
-                <a:solidFill>
-                  <a:srgbClr val="2E86AB"/>
-                </a:solidFill>
-                <a:latin typeface="Source Sans Pro"/>
-              </a:defRPr>
-            </a:pPr>
-            <a:r>
-              <a:t>Body Bold</a:t>
-            </a:r>
-          </a:p>
-        </p:txBody>
-      </p:sp>
-      <p:sp>
-        <p:nvSpPr>
-          <p:cNvPr id="11" name="TextBox 10"/>
-          <p:cNvSpPr txBox="1"/>
-          <p:nvPr/>
-        </p:nvSpPr>
-        <p:spPr>
-          <a:xfrm>
-            <a:off x="5257800" y="4171950"/>
-            <a:ext cx="3429000" cy="742950"/>
-          </a:xfrm>
-          <a:prstGeom prst="rect">
-            <a:avLst/>
-          </a:prstGeom>
-          <a:noFill/>
-        </p:spPr>
-        <p:txBody>
-          <a:bodyPr wrap="none">
-            <a:spAutoFit/>
-          </a:bodyPr>
-          <a:lstStyle/>
-          <a:p>
-            <a:pPr>
-              <a:defRPr sz="1200" b="0">
-                <a:solidFill>
-                  <a:srgbClr val="2E86AB"/>
-                </a:solidFill>
-                <a:latin typeface="Source Sans Pro"/>
-              </a:defRPr>
-            </a:pPr>
-            <a:r>
-              <a:t>Caption Text</a:t>
-            </a:r>
-          </a:p>
-        </p:txBody>
-      </p:sp>
-      <p:sp>
-        <p:nvSpPr>
-          <p:cNvPr id="12" name="TextBox 11"/>
-          <p:cNvSpPr txBox="1"/>
-          <p:nvPr/>
-        </p:nvSpPr>
-        <p:spPr>
-          <a:xfrm>
-            <a:off x="457200" y="5657850"/>
-            <a:ext cx="4114800" cy="742950"/>
-          </a:xfrm>
-          <a:prstGeom prst="rect">
-            <a:avLst/>
-          </a:prstGeom>
-          <a:noFill/>
-        </p:spPr>
-        <p:txBody>
-          <a:bodyPr wrap="none">
-            <a:spAutoFit/>
-          </a:bodyPr>
-          <a:lstStyle/>
-          <a:p>
             <a:pPr algn="l">
               <a:defRPr sz="1000" b="0">
                 <a:solidFill>
@@ -7100,7 +7530,7 @@
       </p:sp>
       <p:sp>
         <p:nvSpPr>
-          <p:cNvPr id="13" name="TextBox 12"/>
+          <p:cNvPr id="11" name="TextBox 10"/>
           <p:cNvSpPr txBox="1"/>
           <p:nvPr/>
         </p:nvSpPr>

</xml_diff>

<commit_message>
remove footer from 2 slides
</commit_message>
<xml_diff>
--- a/output/techforward_live/techforward_live_enhanced_brand_book.pptx
+++ b/output/techforward_live/techforward_live_enhanced_brand_book.pptx
@@ -3407,7 +3407,7 @@
             <a:avLst/>
           </a:prstGeom>
           <a:solidFill>
-            <a:srgbClr val="2E86AB"/>
+            <a:srgbClr val="FF4D4D"/>
           </a:solidFill>
           <a:ln w="25400">
             <a:solidFill>
@@ -3461,73 +3461,73 @@
           <a:p>
             <a:pPr algn="l">
               <a:spcAft>
-                <a:spcPts val="400"/>
+                <a:spcPts val="300"/>
               </a:spcAft>
-              <a:defRPr sz="1200" b="0">
-                <a:solidFill>
-                  <a:srgbClr val="FFFFFF"/>
-                </a:solidFill>
-                <a:latin typeface="Source Sans Pro"/>
-              </a:defRPr>
-            </a:pPr>
-            <a:r>
-              <a:t>Primary Blue</a:t>
+              <a:defRPr sz="1000" b="0">
+                <a:solidFill>
+                  <a:srgbClr val="FFFFFF"/>
+                </a:solidFill>
+                <a:latin typeface="Source Sans Pro"/>
+              </a:defRPr>
+            </a:pPr>
+            <a:r>
+              <a:t>Innovation Red</a:t>
             </a:r>
           </a:p>
           <a:p>
             <a:pPr algn="l">
               <a:spcAft>
-                <a:spcPts val="400"/>
+                <a:spcPts val="300"/>
               </a:spcAft>
-              <a:defRPr sz="1200" b="0">
-                <a:solidFill>
-                  <a:srgbClr val="FFFFFF"/>
-                </a:solidFill>
-                <a:latin typeface="Source Sans Pro"/>
-              </a:defRPr>
-            </a:pPr>
-            <a:r>
-              <a:t>#2E86AB</a:t>
+              <a:defRPr sz="1000" b="0">
+                <a:solidFill>
+                  <a:srgbClr val="FFFFFF"/>
+                </a:solidFill>
+                <a:latin typeface="Source Sans Pro"/>
+              </a:defRPr>
+            </a:pPr>
+            <a:r>
+              <a:t>#FF4D4D</a:t>
             </a:r>
           </a:p>
           <a:p>
             <a:pPr algn="l">
               <a:spcAft>
-                <a:spcPts val="400"/>
+                <a:spcPts val="300"/>
               </a:spcAft>
-              <a:defRPr sz="1200" b="0">
-                <a:solidFill>
-                  <a:srgbClr val="FFFFFF"/>
-                </a:solidFill>
-                <a:latin typeface="Source Sans Pro"/>
-              </a:defRPr>
-            </a:pPr>
-            <a:r>
-              <a:t>RGB(46, 134, 171)</a:t>
+              <a:defRPr sz="1000" b="0">
+                <a:solidFill>
+                  <a:srgbClr val="FFFFFF"/>
+                </a:solidFill>
+                <a:latin typeface="Source Sans Pro"/>
+              </a:defRPr>
+            </a:pPr>
+            <a:r>
+              <a:t>RGB(255, 77, 77)</a:t>
             </a:r>
           </a:p>
           <a:p>
             <a:pPr algn="l">
               <a:spcAft>
-                <a:spcPts val="400"/>
+                <a:spcPts val="300"/>
               </a:spcAft>
-              <a:defRPr sz="1200" b="0">
-                <a:solidFill>
-                  <a:srgbClr val="FFFFFF"/>
-                </a:solidFill>
-                <a:latin typeface="Source Sans Pro"/>
-              </a:defRPr>
-            </a:pPr>
-            <a:r>
-              <a:t>CMYK(73, 21, 0, 32)</a:t>
+              <a:defRPr sz="1000" b="0">
+                <a:solidFill>
+                  <a:srgbClr val="FFFFFF"/>
+                </a:solidFill>
+                <a:latin typeface="Source Sans Pro"/>
+              </a:defRPr>
+            </a:pPr>
+            <a:r>
+              <a:t>CMYK(0, 69, 69, 0)</a:t>
             </a:r>
           </a:p>
           <a:p>
             <a:pPr algn="l">
               <a:spcAft>
-                <a:spcPts val="400"/>
+                <a:spcPts val="300"/>
               </a:spcAft>
-              <a:defRPr sz="1200" b="0">
+              <a:defRPr sz="1000" b="0">
                 <a:solidFill>
                   <a:srgbClr val="FFFFFF"/>
                 </a:solidFill>
@@ -3555,7 +3555,7 @@
             <a:avLst/>
           </a:prstGeom>
           <a:solidFill>
-            <a:srgbClr val="24A19C"/>
+            <a:srgbClr val="3F88C5"/>
           </a:solidFill>
           <a:ln w="25400">
             <a:solidFill>
@@ -3609,73 +3609,73 @@
           <a:p>
             <a:pPr algn="l">
               <a:spcAft>
-                <a:spcPts val="400"/>
+                <a:spcPts val="300"/>
               </a:spcAft>
-              <a:defRPr sz="1200" b="0">
-                <a:solidFill>
-                  <a:srgbClr val="FFFFFF"/>
-                </a:solidFill>
-                <a:latin typeface="Source Sans Pro"/>
-              </a:defRPr>
-            </a:pPr>
-            <a:r>
-              <a:t>Accent Teal</a:t>
+              <a:defRPr sz="1000" b="0">
+                <a:solidFill>
+                  <a:srgbClr val="FFFFFF"/>
+                </a:solidFill>
+                <a:latin typeface="Source Sans Pro"/>
+              </a:defRPr>
+            </a:pPr>
+            <a:r>
+              <a:t>Tech Blue</a:t>
             </a:r>
           </a:p>
           <a:p>
             <a:pPr algn="l">
               <a:spcAft>
-                <a:spcPts val="400"/>
+                <a:spcPts val="300"/>
               </a:spcAft>
-              <a:defRPr sz="1200" b="0">
-                <a:solidFill>
-                  <a:srgbClr val="FFFFFF"/>
-                </a:solidFill>
-                <a:latin typeface="Source Sans Pro"/>
-              </a:defRPr>
-            </a:pPr>
-            <a:r>
-              <a:t>#24A19C</a:t>
+              <a:defRPr sz="1000" b="0">
+                <a:solidFill>
+                  <a:srgbClr val="FFFFFF"/>
+                </a:solidFill>
+                <a:latin typeface="Source Sans Pro"/>
+              </a:defRPr>
+            </a:pPr>
+            <a:r>
+              <a:t>#3F88C5</a:t>
             </a:r>
           </a:p>
           <a:p>
             <a:pPr algn="l">
               <a:spcAft>
-                <a:spcPts val="400"/>
+                <a:spcPts val="300"/>
               </a:spcAft>
-              <a:defRPr sz="1200" b="0">
-                <a:solidFill>
-                  <a:srgbClr val="FFFFFF"/>
-                </a:solidFill>
-                <a:latin typeface="Source Sans Pro"/>
-              </a:defRPr>
-            </a:pPr>
-            <a:r>
-              <a:t>RGB(36, 161, 156)</a:t>
+              <a:defRPr sz="1000" b="0">
+                <a:solidFill>
+                  <a:srgbClr val="FFFFFF"/>
+                </a:solidFill>
+                <a:latin typeface="Source Sans Pro"/>
+              </a:defRPr>
+            </a:pPr>
+            <a:r>
+              <a:t>RGB(63, 136, 197)</a:t>
             </a:r>
           </a:p>
           <a:p>
             <a:pPr algn="l">
               <a:spcAft>
-                <a:spcPts val="400"/>
+                <a:spcPts val="300"/>
               </a:spcAft>
-              <a:defRPr sz="1200" b="0">
-                <a:solidFill>
-                  <a:srgbClr val="FFFFFF"/>
-                </a:solidFill>
-                <a:latin typeface="Source Sans Pro"/>
-              </a:defRPr>
-            </a:pPr>
-            <a:r>
-              <a:t>CMYK(77, 0, 3, 36)</a:t>
+              <a:defRPr sz="1000" b="0">
+                <a:solidFill>
+                  <a:srgbClr val="FFFFFF"/>
+                </a:solidFill>
+                <a:latin typeface="Source Sans Pro"/>
+              </a:defRPr>
+            </a:pPr>
+            <a:r>
+              <a:t>CMYK(68, 30, 0, 22)</a:t>
             </a:r>
           </a:p>
           <a:p>
             <a:pPr algn="l">
               <a:spcAft>
-                <a:spcPts val="400"/>
+                <a:spcPts val="300"/>
               </a:spcAft>
-              <a:defRPr sz="1200" b="0">
+              <a:defRPr sz="1000" b="0">
                 <a:solidFill>
                   <a:srgbClr val="FFFFFF"/>
                 </a:solidFill>
@@ -3703,7 +3703,7 @@
             <a:avLst/>
           </a:prstGeom>
           <a:solidFill>
-            <a:srgbClr val="1B365D"/>
+            <a:srgbClr val="00B159"/>
           </a:solidFill>
           <a:ln w="25400">
             <a:solidFill>
@@ -3757,81 +3757,81 @@
           <a:p>
             <a:pPr algn="l">
               <a:spcAft>
-                <a:spcPts val="400"/>
+                <a:spcPts val="300"/>
               </a:spcAft>
-              <a:defRPr sz="1200" b="0">
-                <a:solidFill>
-                  <a:srgbClr val="FFFFFF"/>
-                </a:solidFill>
-                <a:latin typeface="Source Sans Pro"/>
-              </a:defRPr>
-            </a:pPr>
-            <a:r>
-              <a:t>Deep Navy</a:t>
+              <a:defRPr sz="1000" b="0">
+                <a:solidFill>
+                  <a:srgbClr val="FFFFFF"/>
+                </a:solidFill>
+                <a:latin typeface="Source Sans Pro"/>
+              </a:defRPr>
+            </a:pPr>
+            <a:r>
+              <a:t>Digital Green</a:t>
             </a:r>
           </a:p>
           <a:p>
             <a:pPr algn="l">
               <a:spcAft>
-                <a:spcPts val="400"/>
+                <a:spcPts val="300"/>
               </a:spcAft>
-              <a:defRPr sz="1200" b="0">
-                <a:solidFill>
-                  <a:srgbClr val="FFFFFF"/>
-                </a:solidFill>
-                <a:latin typeface="Source Sans Pro"/>
-              </a:defRPr>
-            </a:pPr>
-            <a:r>
-              <a:t>#1B365D</a:t>
+              <a:defRPr sz="1000" b="0">
+                <a:solidFill>
+                  <a:srgbClr val="FFFFFF"/>
+                </a:solidFill>
+                <a:latin typeface="Source Sans Pro"/>
+              </a:defRPr>
+            </a:pPr>
+            <a:r>
+              <a:t>#00B159</a:t>
             </a:r>
           </a:p>
           <a:p>
             <a:pPr algn="l">
               <a:spcAft>
-                <a:spcPts val="400"/>
+                <a:spcPts val="300"/>
               </a:spcAft>
-              <a:defRPr sz="1200" b="0">
-                <a:solidFill>
-                  <a:srgbClr val="FFFFFF"/>
-                </a:solidFill>
-                <a:latin typeface="Source Sans Pro"/>
-              </a:defRPr>
-            </a:pPr>
-            <a:r>
-              <a:t>RGB(27, 54, 93)</a:t>
+              <a:defRPr sz="1000" b="0">
+                <a:solidFill>
+                  <a:srgbClr val="FFFFFF"/>
+                </a:solidFill>
+                <a:latin typeface="Source Sans Pro"/>
+              </a:defRPr>
+            </a:pPr>
+            <a:r>
+              <a:t>RGB(0, 177, 89)</a:t>
             </a:r>
           </a:p>
           <a:p>
             <a:pPr algn="l">
               <a:spcAft>
-                <a:spcPts val="400"/>
+                <a:spcPts val="300"/>
               </a:spcAft>
-              <a:defRPr sz="1200" b="0">
-                <a:solidFill>
-                  <a:srgbClr val="FFFFFF"/>
-                </a:solidFill>
-                <a:latin typeface="Source Sans Pro"/>
-              </a:defRPr>
-            </a:pPr>
-            <a:r>
-              <a:t>CMYK(70, 41, 0, 63)</a:t>
+              <a:defRPr sz="1000" b="0">
+                <a:solidFill>
+                  <a:srgbClr val="FFFFFF"/>
+                </a:solidFill>
+                <a:latin typeface="Source Sans Pro"/>
+              </a:defRPr>
+            </a:pPr>
+            <a:r>
+              <a:t>CMYK(100, 0, 49, 30)</a:t>
             </a:r>
           </a:p>
           <a:p>
             <a:pPr algn="l">
               <a:spcAft>
-                <a:spcPts val="400"/>
+                <a:spcPts val="300"/>
               </a:spcAft>
-              <a:defRPr sz="1200" b="0">
-                <a:solidFill>
-                  <a:srgbClr val="FFFFFF"/>
-                </a:solidFill>
-                <a:latin typeface="Source Sans Pro"/>
-              </a:defRPr>
-            </a:pPr>
-            <a:r>
-              <a:t>Use Light Text</a:t>
+              <a:defRPr sz="1000" b="0">
+                <a:solidFill>
+                  <a:srgbClr val="FFFFFF"/>
+                </a:solidFill>
+                <a:latin typeface="Source Sans Pro"/>
+              </a:defRPr>
+            </a:pPr>
+            <a:r>
+              <a:t>Use Dark Text</a:t>
             </a:r>
           </a:p>
         </p:txBody>
@@ -4064,7 +4064,7 @@
             <a:avLst/>
           </a:prstGeom>
           <a:solidFill>
-            <a:srgbClr val="9AD1D4"/>
+            <a:srgbClr val="6FFFB0"/>
           </a:solidFill>
           <a:ln w="25400">
             <a:solidFill>
@@ -4128,7 +4128,7 @@
               </a:defRPr>
             </a:pPr>
             <a:r>
-              <a:t>Pale Aqua</a:t>
+              <a:t>Mint Green</a:t>
             </a:r>
           </a:p>
           <a:p>
@@ -4144,7 +4144,7 @@
               </a:defRPr>
             </a:pPr>
             <a:r>
-              <a:t>#9AD1D4</a:t>
+              <a:t>#6FFFB0</a:t>
             </a:r>
           </a:p>
           <a:p>
@@ -4180,7 +4180,7 @@
             <a:avLst/>
           </a:prstGeom>
           <a:solidFill>
-            <a:srgbClr val="145C61"/>
+            <a:srgbClr val="6E88A3"/>
           </a:solidFill>
           <a:ln w="25400">
             <a:solidFill>
@@ -4244,7 +4244,7 @@
               </a:defRPr>
             </a:pPr>
             <a:r>
-              <a:t>Deep Teal</a:t>
+              <a:t>Dusty Blue</a:t>
             </a:r>
           </a:p>
           <a:p>
@@ -4260,7 +4260,7 @@
               </a:defRPr>
             </a:pPr>
             <a:r>
-              <a:t>#145C61</a:t>
+              <a:t>#6E88A3</a:t>
             </a:r>
           </a:p>
           <a:p>
@@ -4276,7 +4276,7 @@
               </a:defRPr>
             </a:pPr>
             <a:r>
-              <a:t>Use Light Text</a:t>
+              <a:t>Use Dark Text</a:t>
             </a:r>
           </a:p>
         </p:txBody>
@@ -4296,7 +4296,7 @@
             <a:avLst/>
           </a:prstGeom>
           <a:solidFill>
-            <a:srgbClr val="5CA4B7"/>
+            <a:srgbClr val="B98DE0"/>
           </a:solidFill>
           <a:ln w="25400">
             <a:solidFill>
@@ -4360,7 +4360,7 @@
               </a:defRPr>
             </a:pPr>
             <a:r>
-              <a:t>Soft Blue</a:t>
+              <a:t>Lavender</a:t>
             </a:r>
           </a:p>
           <a:p>
@@ -4376,7 +4376,7 @@
               </a:defRPr>
             </a:pPr>
             <a:r>
-              <a:t>#5CA4B7</a:t>
+              <a:t>#B98DE0</a:t>
             </a:r>
           </a:p>
           <a:p>
@@ -4412,7 +4412,7 @@
             <a:avLst/>
           </a:prstGeom>
           <a:solidFill>
-            <a:srgbClr val="708090"/>
+            <a:srgbClr val="333333"/>
           </a:solidFill>
           <a:ln w="25400">
             <a:solidFill>
@@ -4476,7 +4476,7 @@
               </a:defRPr>
             </a:pPr>
             <a:r>
-              <a:t>Slate Gray</a:t>
+              <a:t>Charcoal</a:t>
             </a:r>
           </a:p>
           <a:p>
@@ -4492,7 +4492,7 @@
               </a:defRPr>
             </a:pPr>
             <a:r>
-              <a:t>#708090</a:t>
+              <a:t>#333333</a:t>
             </a:r>
           </a:p>
           <a:p>
@@ -4508,7 +4508,7 @@
               </a:defRPr>
             </a:pPr>
             <a:r>
-              <a:t>Use Dark Text</a:t>
+              <a:t>Use Light Text</a:t>
             </a:r>
           </a:p>
         </p:txBody>
@@ -4634,25 +4634,25 @@
           <a:p>
             <a:pPr algn="l">
               <a:spcAft>
-                <a:spcPts val="800"/>
+                <a:spcPts val="600"/>
               </a:spcAft>
-              <a:defRPr sz="1600" b="0">
-                <a:solidFill>
-                  <a:srgbClr val="FFFFFF"/>
-                </a:solidFill>
-                <a:latin typeface="Source Sans Pro"/>
-              </a:defRPr>
-            </a:pPr>
-            <a:r>
-              <a:t>Primary Color Usage Guidelines</a:t>
+              <a:defRPr sz="1400" b="0">
+                <a:solidFill>
+                  <a:srgbClr val="FFFFFF"/>
+                </a:solidFill>
+                <a:latin typeface="Source Sans Pro"/>
+              </a:defRPr>
+            </a:pPr>
+            <a:r>
+              <a:t>Primary Color Usage</a:t>
             </a:r>
           </a:p>
           <a:p>
             <a:pPr algn="l">
               <a:spcAft>
-                <a:spcPts val="800"/>
+                <a:spcPts val="600"/>
               </a:spcAft>
-              <a:defRPr sz="1600" b="0">
+              <a:defRPr sz="1400" b="0">
                 <a:solidFill>
                   <a:srgbClr val="FFFFFF"/>
                 </a:solidFill>
@@ -4663,118 +4663,118 @@
           <a:p>
             <a:pPr algn="l">
               <a:spcAft>
-                <a:spcPts val="800"/>
+                <a:spcPts val="600"/>
               </a:spcAft>
-              <a:defRPr sz="1600" b="0">
-                <a:solidFill>
-                  <a:srgbClr val="FFFFFF"/>
-                </a:solidFill>
-                <a:latin typeface="Source Sans Pro"/>
-              </a:defRPr>
-            </a:pPr>
-            <a:r>
-              <a:t>Your primary colors are the foundation of your brand identity. Use them prominently in:</a:t>
+              <a:defRPr sz="1400" b="0">
+                <a:solidFill>
+                  <a:srgbClr val="FFFFFF"/>
+                </a:solidFill>
+                <a:latin typeface="Source Sans Pro"/>
+              </a:defRPr>
+            </a:pPr>
+            <a:r>
+              <a:t>Use for brand-critical elements:</a:t>
             </a:r>
           </a:p>
           <a:p>
             <a:pPr algn="l">
               <a:spcAft>
-                <a:spcPts val="800"/>
+                <a:spcPts val="600"/>
               </a:spcAft>
-              <a:defRPr sz="1600" b="0">
-                <a:solidFill>
-                  <a:srgbClr val="FFFFFF"/>
-                </a:solidFill>
-                <a:latin typeface="Source Sans Pro"/>
-              </a:defRPr>
-            </a:pPr>
+              <a:defRPr sz="1400" b="0">
+                <a:solidFill>
+                  <a:srgbClr val="FFFFFF"/>
+                </a:solidFill>
+                <a:latin typeface="Source Sans Pro"/>
+              </a:defRPr>
+            </a:pPr>
+            <a:r>
+              <a:t>• Logos and main brand marks</a:t>
+            </a:r>
           </a:p>
           <a:p>
             <a:pPr algn="l">
               <a:spcAft>
-                <a:spcPts val="800"/>
+                <a:spcPts val="600"/>
               </a:spcAft>
-              <a:defRPr sz="1600" b="0">
-                <a:solidFill>
-                  <a:srgbClr val="FFFFFF"/>
-                </a:solidFill>
-                <a:latin typeface="Source Sans Pro"/>
-              </a:defRPr>
-            </a:pPr>
-            <a:r>
-              <a:t>• Brand logos and primary brand marks</a:t>
+              <a:defRPr sz="1400" b="0">
+                <a:solidFill>
+                  <a:srgbClr val="FFFFFF"/>
+                </a:solidFill>
+                <a:latin typeface="Source Sans Pro"/>
+              </a:defRPr>
+            </a:pPr>
+            <a:r>
+              <a:t>• Headlines and key text</a:t>
             </a:r>
           </a:p>
           <a:p>
             <a:pPr algn="l">
               <a:spcAft>
-                <a:spcPts val="800"/>
+                <a:spcPts val="600"/>
               </a:spcAft>
-              <a:defRPr sz="1600" b="0">
-                <a:solidFill>
-                  <a:srgbClr val="FFFFFF"/>
-                </a:solidFill>
-                <a:latin typeface="Source Sans Pro"/>
-              </a:defRPr>
-            </a:pPr>
-            <a:r>
-              <a:t>• Headlines and primary text elements</a:t>
+              <a:defRPr sz="1400" b="0">
+                <a:solidFill>
+                  <a:srgbClr val="FFFFFF"/>
+                </a:solidFill>
+                <a:latin typeface="Source Sans Pro"/>
+              </a:defRPr>
+            </a:pPr>
+            <a:r>
+              <a:t>• CTA buttons and navigation</a:t>
             </a:r>
           </a:p>
           <a:p>
             <a:pPr algn="l">
               <a:spcAft>
-                <a:spcPts val="800"/>
+                <a:spcPts val="600"/>
               </a:spcAft>
-              <a:defRPr sz="1600" b="0">
-                <a:solidFill>
-                  <a:srgbClr val="FFFFFF"/>
-                </a:solidFill>
-                <a:latin typeface="Source Sans Pro"/>
-              </a:defRPr>
-            </a:pPr>
-            <a:r>
-              <a:t>• Call-to-action buttons and key interactive elements</a:t>
+              <a:defRPr sz="1400" b="0">
+                <a:solidFill>
+                  <a:srgbClr val="FFFFFF"/>
+                </a:solidFill>
+                <a:latin typeface="Source Sans Pro"/>
+              </a:defRPr>
+            </a:pPr>
+            <a:r>
+              <a:t>• Hero sections</a:t>
             </a:r>
           </a:p>
           <a:p>
             <a:pPr algn="l">
               <a:spcAft>
-                <a:spcPts val="800"/>
+                <a:spcPts val="600"/>
               </a:spcAft>
-              <a:defRPr sz="1600" b="0">
-                <a:solidFill>
-                  <a:srgbClr val="FFFFFF"/>
-                </a:solidFill>
-                <a:latin typeface="Source Sans Pro"/>
-              </a:defRPr>
-            </a:pPr>
-            <a:r>
-              <a:t>• Primary navigation and menu items</a:t>
-            </a:r>
+              <a:defRPr sz="1400" b="0">
+                <a:solidFill>
+                  <a:srgbClr val="FFFFFF"/>
+                </a:solidFill>
+                <a:latin typeface="Source Sans Pro"/>
+              </a:defRPr>
+            </a:pPr>
           </a:p>
           <a:p>
             <a:pPr algn="l">
               <a:spcAft>
-                <a:spcPts val="800"/>
+                <a:spcPts val="600"/>
               </a:spcAft>
-              <a:defRPr sz="1600" b="0">
-                <a:solidFill>
-                  <a:srgbClr val="FFFFFF"/>
-                </a:solidFill>
-                <a:latin typeface="Source Sans Pro"/>
-              </a:defRPr>
-            </a:pPr>
-            <a:r>
-              <a:t>• Hero sections and main content areas</a:t>
+              <a:defRPr sz="1400" b="0">
+                <a:solidFill>
+                  <a:srgbClr val="FFFFFF"/>
+                </a:solidFill>
+                <a:latin typeface="Source Sans Pro"/>
+              </a:defRPr>
+            </a:pPr>
+            <a:r>
+              <a:t>Colors: Innovation Red, Tech Blue, Digital Green</a:t>
             </a:r>
           </a:p>
           <a:p>
             <a:pPr algn="l">
               <a:spcAft>
-                <a:spcPts val="800"/>
+                <a:spcPts val="600"/>
               </a:spcAft>
-              <a:defRPr sz="1600" b="0">
+              <a:defRPr sz="1400" b="0">
                 <a:solidFill>
                   <a:srgbClr val="FFFFFF"/>
                 </a:solidFill>
@@ -4785,126 +4785,81 @@
           <a:p>
             <a:pPr algn="l">
               <a:spcAft>
-                <a:spcPts val="800"/>
+                <a:spcPts val="600"/>
               </a:spcAft>
-              <a:defRPr sz="1600" b="0">
-                <a:solidFill>
-                  <a:srgbClr val="FFFFFF"/>
-                </a:solidFill>
-                <a:latin typeface="Source Sans Pro"/>
-              </a:defRPr>
-            </a:pPr>
-            <a:r>
-              <a:t>Primary Colors: Primary Blue, Accent Teal, Deep Navy</a:t>
+              <a:defRPr sz="1400" b="0">
+                <a:solidFill>
+                  <a:srgbClr val="FFFFFF"/>
+                </a:solidFill>
+                <a:latin typeface="Source Sans Pro"/>
+              </a:defRPr>
+            </a:pPr>
+            <a:r>
+              <a:t>Best Practices:</a:t>
             </a:r>
           </a:p>
           <a:p>
             <a:pPr algn="l">
               <a:spcAft>
-                <a:spcPts val="800"/>
+                <a:spcPts val="600"/>
               </a:spcAft>
-              <a:defRPr sz="1600" b="0">
-                <a:solidFill>
-                  <a:srgbClr val="FFFFFF"/>
-                </a:solidFill>
-                <a:latin typeface="Source Sans Pro"/>
-              </a:defRPr>
-            </a:pPr>
+              <a:defRPr sz="1400" b="0">
+                <a:solidFill>
+                  <a:srgbClr val="FFFFFF"/>
+                </a:solidFill>
+                <a:latin typeface="Source Sans Pro"/>
+              </a:defRPr>
+            </a:pPr>
+            <a:r>
+              <a:t>- Maximum brand recognition</a:t>
+            </a:r>
           </a:p>
           <a:p>
             <a:pPr algn="l">
               <a:spcAft>
-                <a:spcPts val="800"/>
+                <a:spcPts val="600"/>
               </a:spcAft>
-              <a:defRPr sz="1600" b="0">
-                <a:solidFill>
-                  <a:srgbClr val="FFFFFF"/>
-                </a:solidFill>
-                <a:latin typeface="Source Sans Pro"/>
-              </a:defRPr>
-            </a:pPr>
-            <a:r>
-              <a:t>Best Practices:</a:t>
+              <a:defRPr sz="1400" b="0">
+                <a:solidFill>
+                  <a:srgbClr val="FFFFFF"/>
+                </a:solidFill>
+                <a:latin typeface="Source Sans Pro"/>
+              </a:defRPr>
+            </a:pPr>
+            <a:r>
+              <a:t>- Consistent application</a:t>
             </a:r>
           </a:p>
           <a:p>
             <a:pPr algn="l">
               <a:spcAft>
-                <a:spcPts val="800"/>
+                <a:spcPts val="600"/>
               </a:spcAft>
-              <a:defRPr sz="1600" b="0">
-                <a:solidFill>
-                  <a:srgbClr val="FFFFFF"/>
-                </a:solidFill>
-                <a:latin typeface="Source Sans Pro"/>
-              </a:defRPr>
-            </a:pPr>
-            <a:r>
-              <a:t>- Use primary colors for maximum brand recognition</a:t>
+              <a:defRPr sz="1400" b="0">
+                <a:solidFill>
+                  <a:srgbClr val="FFFFFF"/>
+                </a:solidFill>
+                <a:latin typeface="Source Sans Pro"/>
+              </a:defRPr>
+            </a:pPr>
+            <a:r>
+              <a:t>- Sufficient contrast</a:t>
             </a:r>
           </a:p>
           <a:p>
             <a:pPr algn="l">
               <a:spcAft>
-                <a:spcPts val="800"/>
+                <a:spcPts val="600"/>
               </a:spcAft>
-              <a:defRPr sz="1600" b="0">
-                <a:solidFill>
-                  <a:srgbClr val="FFFFFF"/>
-                </a:solidFill>
-                <a:latin typeface="Source Sans Pro"/>
-              </a:defRPr>
-            </a:pPr>
-            <a:r>
-              <a:t>- Maintain sufficient contrast with background elements</a:t>
-            </a:r>
-          </a:p>
-          <a:p>
-            <a:pPr algn="l">
-              <a:spcAft>
-                <a:spcPts val="800"/>
-              </a:spcAft>
-              <a:defRPr sz="1600" b="0">
-                <a:solidFill>
-                  <a:srgbClr val="FFFFFF"/>
-                </a:solidFill>
-                <a:latin typeface="Source Sans Pro"/>
-              </a:defRPr>
-            </a:pPr>
-            <a:r>
-              <a:t>- Apply consistently across all brand touchpoints</a:t>
-            </a:r>
-          </a:p>
-          <a:p>
-            <a:pPr algn="l">
-              <a:spcAft>
-                <a:spcPts val="800"/>
-              </a:spcAft>
-              <a:defRPr sz="1600" b="0">
-                <a:solidFill>
-                  <a:srgbClr val="FFFFFF"/>
-                </a:solidFill>
-                <a:latin typeface="Source Sans Pro"/>
-              </a:defRPr>
-            </a:pPr>
-            <a:r>
-              <a:t>- Reserve for the most important visual elements</a:t>
-            </a:r>
-          </a:p>
-          <a:p>
-            <a:pPr algn="l">
-              <a:spcAft>
-                <a:spcPts val="800"/>
-              </a:spcAft>
-              <a:defRPr sz="1600" b="0">
-                <a:solidFill>
-                  <a:srgbClr val="FFFFFF"/>
-                </a:solidFill>
-                <a:latin typeface="Source Sans Pro"/>
-              </a:defRPr>
-            </a:pPr>
-            <a:r>
-              <a:t>- Ensure accessibility compliance in all applications</a:t>
+              <a:defRPr sz="1400" b="0">
+                <a:solidFill>
+                  <a:srgbClr val="FFFFFF"/>
+                </a:solidFill>
+                <a:latin typeface="Source Sans Pro"/>
+              </a:defRPr>
+            </a:pPr>
+            <a:r>
+              <a:t>- Accessibility compliance</a:t>
             </a:r>
           </a:p>
         </p:txBody>
@@ -4925,7 +4880,7 @@
           </a:prstGeom>
           <a:ln w="25400">
             <a:solidFill>
-              <a:srgbClr val="2E86AB"/>
+              <a:srgbClr val="FF4D4D"/>
             </a:solidFill>
           </a:ln>
         </p:spPr>
@@ -4969,85 +4924,13 @@
             <a:pPr algn="l">
               <a:defRPr sz="2800" b="1">
                 <a:solidFill>
-                  <a:srgbClr val="2E86AB"/>
+                  <a:srgbClr val="FF4D4D"/>
                 </a:solidFill>
                 <a:latin typeface="Inter"/>
               </a:defRPr>
             </a:pPr>
             <a:r>
               <a:t>Color Usage 1/2</a:t>
-            </a:r>
-          </a:p>
-        </p:txBody>
-      </p:sp>
-      <p:sp>
-        <p:nvSpPr>
-          <p:cNvPr id="5" name="TextBox 4"/>
-          <p:cNvSpPr txBox="1"/>
-          <p:nvPr/>
-        </p:nvSpPr>
-        <p:spPr>
-          <a:xfrm>
-            <a:off x="457200" y="5657850"/>
-            <a:ext cx="4114800" cy="742950"/>
-          </a:xfrm>
-          <a:prstGeom prst="rect">
-            <a:avLst/>
-          </a:prstGeom>
-          <a:noFill/>
-        </p:spPr>
-        <p:txBody>
-          <a:bodyPr wrap="none">
-            <a:spAutoFit/>
-          </a:bodyPr>
-          <a:lstStyle/>
-          <a:p>
-            <a:pPr algn="l">
-              <a:defRPr sz="1000" b="0">
-                <a:solidFill>
-                  <a:srgbClr val="FFFFFF"/>
-                </a:solidFill>
-                <a:latin typeface="Source Sans Pro"/>
-              </a:defRPr>
-            </a:pPr>
-            <a:r>
-              <a:t>TechForward Live</a:t>
-            </a:r>
-          </a:p>
-        </p:txBody>
-      </p:sp>
-      <p:sp>
-        <p:nvSpPr>
-          <p:cNvPr id="6" name="TextBox 5"/>
-          <p:cNvSpPr txBox="1"/>
-          <p:nvPr/>
-        </p:nvSpPr>
-        <p:spPr>
-          <a:xfrm>
-            <a:off x="4572000" y="5657850"/>
-            <a:ext cx="4114800" cy="742950"/>
-          </a:xfrm>
-          <a:prstGeom prst="rect">
-            <a:avLst/>
-          </a:prstGeom>
-          <a:noFill/>
-        </p:spPr>
-        <p:txBody>
-          <a:bodyPr wrap="none">
-            <a:spAutoFit/>
-          </a:bodyPr>
-          <a:lstStyle/>
-          <a:p>
-            <a:pPr algn="r">
-              <a:defRPr sz="1000" b="0">
-                <a:solidFill>
-                  <a:srgbClr val="FFFFFF"/>
-                </a:solidFill>
-                <a:latin typeface="Source Sans Pro"/>
-              </a:defRPr>
-            </a:pPr>
-            <a:r>
-              <a:t>13</a:t>
             </a:r>
           </a:p>
         </p:txBody>
@@ -5102,25 +4985,25 @@
           <a:p>
             <a:pPr algn="l">
               <a:spcAft>
-                <a:spcPts val="800"/>
+                <a:spcPts val="600"/>
               </a:spcAft>
-              <a:defRPr sz="1600" b="0">
-                <a:solidFill>
-                  <a:srgbClr val="FFFFFF"/>
-                </a:solidFill>
-                <a:latin typeface="Source Sans Pro"/>
-              </a:defRPr>
-            </a:pPr>
-            <a:r>
-              <a:t>Secondary Color Usage Guidelines</a:t>
+              <a:defRPr sz="1400" b="0">
+                <a:solidFill>
+                  <a:srgbClr val="FFFFFF"/>
+                </a:solidFill>
+                <a:latin typeface="Source Sans Pro"/>
+              </a:defRPr>
+            </a:pPr>
+            <a:r>
+              <a:t>Secondary Color Usage</a:t>
             </a:r>
           </a:p>
           <a:p>
             <a:pPr algn="l">
               <a:spcAft>
-                <a:spcPts val="800"/>
+                <a:spcPts val="600"/>
               </a:spcAft>
-              <a:defRPr sz="1600" b="0">
+              <a:defRPr sz="1400" b="0">
                 <a:solidFill>
                   <a:srgbClr val="FFFFFF"/>
                 </a:solidFill>
@@ -5131,118 +5014,118 @@
           <a:p>
             <a:pPr algn="l">
               <a:spcAft>
-                <a:spcPts val="800"/>
+                <a:spcPts val="600"/>
               </a:spcAft>
-              <a:defRPr sz="1600" b="0">
-                <a:solidFill>
-                  <a:srgbClr val="FFFFFF"/>
-                </a:solidFill>
-                <a:latin typeface="Source Sans Pro"/>
-              </a:defRPr>
-            </a:pPr>
-            <a:r>
-              <a:t>Secondary colors support and enhance your primary palette. Use them for:</a:t>
+              <a:defRPr sz="1400" b="0">
+                <a:solidFill>
+                  <a:srgbClr val="FFFFFF"/>
+                </a:solidFill>
+                <a:latin typeface="Source Sans Pro"/>
+              </a:defRPr>
+            </a:pPr>
+            <a:r>
+              <a:t>Use for supporting elements:</a:t>
             </a:r>
           </a:p>
           <a:p>
             <a:pPr algn="l">
               <a:spcAft>
-                <a:spcPts val="800"/>
+                <a:spcPts val="600"/>
               </a:spcAft>
-              <a:defRPr sz="1600" b="0">
-                <a:solidFill>
-                  <a:srgbClr val="FFFFFF"/>
-                </a:solidFill>
-                <a:latin typeface="Source Sans Pro"/>
-              </a:defRPr>
-            </a:pPr>
+              <a:defRPr sz="1400" b="0">
+                <a:solidFill>
+                  <a:srgbClr val="FFFFFF"/>
+                </a:solidFill>
+                <a:latin typeface="Source Sans Pro"/>
+              </a:defRPr>
+            </a:pPr>
+            <a:r>
+              <a:t>• Backgrounds and subtle accents</a:t>
+            </a:r>
           </a:p>
           <a:p>
             <a:pPr algn="l">
               <a:spcAft>
-                <a:spcPts val="800"/>
+                <a:spcPts val="600"/>
               </a:spcAft>
-              <a:defRPr sz="1600" b="0">
-                <a:solidFill>
-                  <a:srgbClr val="FFFFFF"/>
-                </a:solidFill>
-                <a:latin typeface="Source Sans Pro"/>
-              </a:defRPr>
-            </a:pPr>
-            <a:r>
-              <a:t>• Background elements and subtle accents</a:t>
+              <a:defRPr sz="1400" b="0">
+                <a:solidFill>
+                  <a:srgbClr val="FFFFFF"/>
+                </a:solidFill>
+                <a:latin typeface="Source Sans Pro"/>
+              </a:defRPr>
+            </a:pPr>
+            <a:r>
+              <a:t>• Secondary text</a:t>
             </a:r>
           </a:p>
           <a:p>
             <a:pPr algn="l">
               <a:spcAft>
-                <a:spcPts val="800"/>
+                <a:spcPts val="600"/>
               </a:spcAft>
-              <a:defRPr sz="1600" b="0">
-                <a:solidFill>
-                  <a:srgbClr val="FFFFFF"/>
-                </a:solidFill>
-                <a:latin typeface="Source Sans Pro"/>
-              </a:defRPr>
-            </a:pPr>
-            <a:r>
-              <a:t>• Secondary text and supporting information</a:t>
+              <a:defRPr sz="1400" b="0">
+                <a:solidFill>
+                  <a:srgbClr val="FFFFFF"/>
+                </a:solidFill>
+                <a:latin typeface="Source Sans Pro"/>
+              </a:defRPr>
+            </a:pPr>
+            <a:r>
+              <a:t>• Borders and dividers</a:t>
             </a:r>
           </a:p>
           <a:p>
             <a:pPr algn="l">
               <a:spcAft>
-                <a:spcPts val="800"/>
+                <a:spcPts val="600"/>
               </a:spcAft>
-              <a:defRPr sz="1600" b="0">
-                <a:solidFill>
-                  <a:srgbClr val="FFFFFF"/>
-                </a:solidFill>
-                <a:latin typeface="Source Sans Pro"/>
-              </a:defRPr>
-            </a:pPr>
-            <a:r>
-              <a:t>• Borders, dividers, and structural elements</a:t>
+              <a:defRPr sz="1400" b="0">
+                <a:solidFill>
+                  <a:srgbClr val="FFFFFF"/>
+                </a:solidFill>
+                <a:latin typeface="Source Sans Pro"/>
+              </a:defRPr>
+            </a:pPr>
+            <a:r>
+              <a:t>• Hover states and icons</a:t>
             </a:r>
           </a:p>
           <a:p>
             <a:pPr algn="l">
               <a:spcAft>
-                <a:spcPts val="800"/>
+                <a:spcPts val="600"/>
               </a:spcAft>
-              <a:defRPr sz="1600" b="0">
-                <a:solidFill>
-                  <a:srgbClr val="FFFFFF"/>
-                </a:solidFill>
-                <a:latin typeface="Source Sans Pro"/>
-              </a:defRPr>
-            </a:pPr>
-            <a:r>
-              <a:t>• Hover states and interactive feedback</a:t>
-            </a:r>
+              <a:defRPr sz="1400" b="0">
+                <a:solidFill>
+                  <a:srgbClr val="FFFFFF"/>
+                </a:solidFill>
+                <a:latin typeface="Source Sans Pro"/>
+              </a:defRPr>
+            </a:pPr>
           </a:p>
           <a:p>
             <a:pPr algn="l">
               <a:spcAft>
-                <a:spcPts val="800"/>
+                <a:spcPts val="600"/>
               </a:spcAft>
-              <a:defRPr sz="1600" b="0">
-                <a:solidFill>
-                  <a:srgbClr val="FFFFFF"/>
-                </a:solidFill>
-                <a:latin typeface="Source Sans Pro"/>
-              </a:defRPr>
-            </a:pPr>
-            <a:r>
-              <a:t>• Icons and decorative elements</a:t>
+              <a:defRPr sz="1400" b="0">
+                <a:solidFill>
+                  <a:srgbClr val="FFFFFF"/>
+                </a:solidFill>
+                <a:latin typeface="Source Sans Pro"/>
+              </a:defRPr>
+            </a:pPr>
+            <a:r>
+              <a:t>Colors: Light Gray, Mint Green, Dusty Blue, Lavender, Charcoal</a:t>
             </a:r>
           </a:p>
           <a:p>
             <a:pPr algn="l">
               <a:spcAft>
-                <a:spcPts val="800"/>
+                <a:spcPts val="600"/>
               </a:spcAft>
-              <a:defRPr sz="1600" b="0">
+              <a:defRPr sz="1400" b="0">
                 <a:solidFill>
                   <a:srgbClr val="FFFFFF"/>
                 </a:solidFill>
@@ -5253,126 +5136,81 @@
           <a:p>
             <a:pPr algn="l">
               <a:spcAft>
-                <a:spcPts val="800"/>
+                <a:spcPts val="600"/>
               </a:spcAft>
-              <a:defRPr sz="1600" b="0">
-                <a:solidFill>
-                  <a:srgbClr val="FFFFFF"/>
-                </a:solidFill>
-                <a:latin typeface="Source Sans Pro"/>
-              </a:defRPr>
-            </a:pPr>
-            <a:r>
-              <a:t>Secondary Colors: Light Gray, Pale Aqua, Deep Teal, Soft Blue, Slate Gray</a:t>
+              <a:defRPr sz="1400" b="0">
+                <a:solidFill>
+                  <a:srgbClr val="FFFFFF"/>
+                </a:solidFill>
+                <a:latin typeface="Source Sans Pro"/>
+              </a:defRPr>
+            </a:pPr>
+            <a:r>
+              <a:t>Best Practices:</a:t>
             </a:r>
           </a:p>
           <a:p>
             <a:pPr algn="l">
               <a:spcAft>
-                <a:spcPts val="800"/>
+                <a:spcPts val="600"/>
               </a:spcAft>
-              <a:defRPr sz="1600" b="0">
-                <a:solidFill>
-                  <a:srgbClr val="FFFFFF"/>
-                </a:solidFill>
-                <a:latin typeface="Source Sans Pro"/>
-              </a:defRPr>
-            </a:pPr>
+              <a:defRPr sz="1400" b="0">
+                <a:solidFill>
+                  <a:srgbClr val="FFFFFF"/>
+                </a:solidFill>
+                <a:latin typeface="Source Sans Pro"/>
+              </a:defRPr>
+            </a:pPr>
+            <a:r>
+              <a:t>- Create visual hierarchy</a:t>
+            </a:r>
           </a:p>
           <a:p>
             <a:pPr algn="l">
               <a:spcAft>
-                <a:spcPts val="800"/>
+                <a:spcPts val="600"/>
               </a:spcAft>
-              <a:defRPr sz="1600" b="0">
-                <a:solidFill>
-                  <a:srgbClr val="FFFFFF"/>
-                </a:solidFill>
-                <a:latin typeface="Source Sans Pro"/>
-              </a:defRPr>
-            </a:pPr>
-            <a:r>
-              <a:t>Best Practices:</a:t>
+              <a:defRPr sz="1400" b="0">
+                <a:solidFill>
+                  <a:srgbClr val="FFFFFF"/>
+                </a:solidFill>
+                <a:latin typeface="Source Sans Pro"/>
+              </a:defRPr>
+            </a:pPr>
+            <a:r>
+              <a:t>- Support, don't compete</a:t>
             </a:r>
           </a:p>
           <a:p>
             <a:pPr algn="l">
               <a:spcAft>
-                <a:spcPts val="800"/>
+                <a:spcPts val="600"/>
               </a:spcAft>
-              <a:defRPr sz="1600" b="0">
-                <a:solidFill>
-                  <a:srgbClr val="FFFFFF"/>
-                </a:solidFill>
-                <a:latin typeface="Source Sans Pro"/>
-              </a:defRPr>
-            </a:pPr>
-            <a:r>
-              <a:t>- Use to create visual hierarchy and balance</a:t>
+              <a:defRPr sz="1400" b="0">
+                <a:solidFill>
+                  <a:srgbClr val="FFFFFF"/>
+                </a:solidFill>
+                <a:latin typeface="Source Sans Pro"/>
+              </a:defRPr>
+            </a:pPr>
+            <a:r>
+              <a:t>- Maintain readability</a:t>
             </a:r>
           </a:p>
           <a:p>
             <a:pPr algn="l">
               <a:spcAft>
-                <a:spcPts val="800"/>
+                <a:spcPts val="600"/>
               </a:spcAft>
-              <a:defRPr sz="1600" b="0">
-                <a:solidFill>
-                  <a:srgbClr val="FFFFFF"/>
-                </a:solidFill>
-                <a:latin typeface="Source Sans Pro"/>
-              </a:defRPr>
-            </a:pPr>
-            <a:r>
-              <a:t>- Apply for backgrounds and supporting elements</a:t>
-            </a:r>
-          </a:p>
-          <a:p>
-            <a:pPr algn="l">
-              <a:spcAft>
-                <a:spcPts val="800"/>
-              </a:spcAft>
-              <a:defRPr sz="1600" b="0">
-                <a:solidFill>
-                  <a:srgbClr val="FFFFFF"/>
-                </a:solidFill>
-                <a:latin typeface="Source Sans Pro"/>
-              </a:defRPr>
-            </a:pPr>
-            <a:r>
-              <a:t>- Maintain readability with appropriate contrast</a:t>
-            </a:r>
-          </a:p>
-          <a:p>
-            <a:pPr algn="l">
-              <a:spcAft>
-                <a:spcPts val="800"/>
-              </a:spcAft>
-              <a:defRPr sz="1600" b="0">
-                <a:solidFill>
-                  <a:srgbClr val="FFFFFF"/>
-                </a:solidFill>
-                <a:latin typeface="Source Sans Pro"/>
-              </a:defRPr>
-            </a:pPr>
-            <a:r>
-              <a:t>- Use sparingly to avoid overwhelming the design</a:t>
-            </a:r>
-          </a:p>
-          <a:p>
-            <a:pPr algn="l">
-              <a:spcAft>
-                <a:spcPts val="800"/>
-              </a:spcAft>
-              <a:defRPr sz="1600" b="0">
-                <a:solidFill>
-                  <a:srgbClr val="FFFFFF"/>
-                </a:solidFill>
-                <a:latin typeface="Source Sans Pro"/>
-              </a:defRPr>
-            </a:pPr>
-            <a:r>
-              <a:t>- Complement, don't compete with primary colors</a:t>
+              <a:defRPr sz="1400" b="0">
+                <a:solidFill>
+                  <a:srgbClr val="FFFFFF"/>
+                </a:solidFill>
+                <a:latin typeface="Source Sans Pro"/>
+              </a:defRPr>
+            </a:pPr>
+            <a:r>
+              <a:t>- Use sparingly</a:t>
             </a:r>
           </a:p>
         </p:txBody>
@@ -5393,7 +5231,7 @@
           </a:prstGeom>
           <a:ln w="25400">
             <a:solidFill>
-              <a:srgbClr val="2E86AB"/>
+              <a:srgbClr val="FF4D4D"/>
             </a:solidFill>
           </a:ln>
         </p:spPr>
@@ -5437,85 +5275,13 @@
             <a:pPr algn="l">
               <a:defRPr sz="2800" b="1">
                 <a:solidFill>
-                  <a:srgbClr val="2E86AB"/>
+                  <a:srgbClr val="FF4D4D"/>
                 </a:solidFill>
                 <a:latin typeface="Inter"/>
               </a:defRPr>
             </a:pPr>
             <a:r>
               <a:t>Color Usage 2/2</a:t>
-            </a:r>
-          </a:p>
-        </p:txBody>
-      </p:sp>
-      <p:sp>
-        <p:nvSpPr>
-          <p:cNvPr id="5" name="TextBox 4"/>
-          <p:cNvSpPr txBox="1"/>
-          <p:nvPr/>
-        </p:nvSpPr>
-        <p:spPr>
-          <a:xfrm>
-            <a:off x="457200" y="5657850"/>
-            <a:ext cx="4114800" cy="742950"/>
-          </a:xfrm>
-          <a:prstGeom prst="rect">
-            <a:avLst/>
-          </a:prstGeom>
-          <a:noFill/>
-        </p:spPr>
-        <p:txBody>
-          <a:bodyPr wrap="none">
-            <a:spAutoFit/>
-          </a:bodyPr>
-          <a:lstStyle/>
-          <a:p>
-            <a:pPr algn="l">
-              <a:defRPr sz="1000" b="0">
-                <a:solidFill>
-                  <a:srgbClr val="FFFFFF"/>
-                </a:solidFill>
-                <a:latin typeface="Source Sans Pro"/>
-              </a:defRPr>
-            </a:pPr>
-            <a:r>
-              <a:t>TechForward Live</a:t>
-            </a:r>
-          </a:p>
-        </p:txBody>
-      </p:sp>
-      <p:sp>
-        <p:nvSpPr>
-          <p:cNvPr id="6" name="TextBox 5"/>
-          <p:cNvSpPr txBox="1"/>
-          <p:nvPr/>
-        </p:nvSpPr>
-        <p:spPr>
-          <a:xfrm>
-            <a:off x="4572000" y="5657850"/>
-            <a:ext cx="4114800" cy="742950"/>
-          </a:xfrm>
-          <a:prstGeom prst="rect">
-            <a:avLst/>
-          </a:prstGeom>
-          <a:noFill/>
-        </p:spPr>
-        <p:txBody>
-          <a:bodyPr wrap="none">
-            <a:spAutoFit/>
-          </a:bodyPr>
-          <a:lstStyle/>
-          <a:p>
-            <a:pPr algn="r">
-              <a:defRPr sz="1000" b="0">
-                <a:solidFill>
-                  <a:srgbClr val="FFFFFF"/>
-                </a:solidFill>
-                <a:latin typeface="Source Sans Pro"/>
-              </a:defRPr>
-            </a:pPr>
-            <a:r>
-              <a:t>14</a:t>
             </a:r>
           </a:p>
         </p:txBody>
@@ -8153,7 +7919,7 @@
               </a:defRPr>
             </a:pPr>
             <a:r>
-              <a:t>Welcome to TechForward Live's brand identity system presentation, where we unveil a transformative approach to showcasing our commitment to innovation and human-centered design. This system ensures an internationally engaging, consistent, and proprietary brand presentation, reflecting our core values of simplicity, excellence, and trust in the dynamic landscape of technology and digital solutions.</a:t>
+              <a:t>Welcome to TechForward Live's brand identity system presentation. Here, we unveil a cohesive framework that guarantees an international, engaging, and recognizable brand presence. Rooted in our core values of innovation, simplicity, and human-centered design, this system embodies our commitment to bridging the gap between complex technology and intuitive user experiences.</a:t>
             </a:r>
           </a:p>
         </p:txBody>
@@ -8289,7 +8055,7 @@
               </a:defRPr>
             </a:pPr>
             <a:r>
-              <a:t>Our vision at TechForward Live is to empower a future where technology seamlessly enhances human potential, driving unparalleled innovation and digital transformation for progressive businesses. We aspire to be the catalyst for unlocking new possibilities and shaping a world where simplicity and excellence define the digital landscape.</a:t>
+              <a:t>At TechForward Live, our vision is to empower Progressive businesses with transformative digital solutions that propel them towards a future of limitless innovation and sustainable growth. We aspire to be the catalyst for change, driving digital transformation and unlocking the full potential of businesses through technology.</a:t>
             </a:r>
           </a:p>
         </p:txBody>
@@ -8425,7 +8191,7 @@
               </a:defRPr>
             </a:pPr>
             <a:r>
-              <a:t>At TechForward Live, we are dedicated to bridging the gap between complex technology and intuitive user experiences. Our mission is to provide cutting-edge technology solutions that drive digital transformation and innovation for businesses, ensuring that our human-centered approach leads the way in creating impactful, user-friendly digital solutions.</a:t>
+              <a:t>Our mission at TechForward Live is to deliver intuitive and human-centered technology solutions that simplify complexity, enhance productivity, and drive innovation in the Technology &amp; Digital Solutions industry. We are committed to bridging the gap between cutting-edge technology and user-friendly experiences, ensuring seamless integration and impactful outcomes for our clients.</a:t>
             </a:r>
           </a:p>
         </p:txBody>
@@ -8561,7 +8327,7 @@
               </a:defRPr>
             </a:pPr>
             <a:r>
-              <a:t>At the core of TechForward Live, our values of innovation, simplicity, human-centered design, excellence, trust, and reliability guide every aspect of our work. We believe in pushing boundaries through innovation, simplifying complexities to create seamless experiences, and always putting humans at the center of our solutions. Our commitment to excellence, trustworthiness, and reliability ensures that we deliver technology solutions that truly transform businesses and drive progress in the digital world.</a:t>
+              <a:t>At the core of TechForward Live's ethos are our unwavering values of Innovation, Simplicity, Human-Centered design, Excellence, Trust, and Reliability. We believe in pushing boundaries through continuous innovation, crafting solutions that prioritize simplicity without compromising on excellence. Our human-centered approach ensures that trust and reliability are woven into every aspect of our technology, empowering Progressive businesses to thrive in an ever-evolving digital landscape.</a:t>
             </a:r>
           </a:p>
         </p:txBody>

</xml_diff>